<commit_message>
v2 pitch: replace after-go-live results with go-live readiness, since ERM is not live yet
Co-Authored-By: Claude Opus 5.5 <noreply@anthropic.com>
Claude-Session: https://claude.ai/code/session_01HdxEbeqqWM97gKbcNqpjAq
</commit_message>
<xml_diff>
--- a/erm-migration/docs/ERM-Migration-Jury-Pitch-v2.pptx
+++ b/erm-migration/docs/ERM-Migration-Jury-Pitch-v2.pptx
@@ -113,28 +113,28 @@
   <p:extLst>
     <p:ext uri="{521415D9-36F7-43E2-AB2F-B90AF26B5E84}">
       <p14:sectionLst xmlns:p14="http://schemas.microsoft.com/office/powerpoint/2010/main">
-        <p14:section name="Answer" id="{2b2d7114-d823-b424-9d64-c0d3e9213a57}">
+        <p14:section name="Answer" id="{976a79f0-e7d2-08d1-f704-09e3144c994b}">
           <p14:sldIdLst>
             <p14:sldId id="256"/>
           </p14:sldIdLst>
         </p14:section>
-        <p14:section name="Situation" id="{28bc32a9-d50c-0057-d80a-627b7e73cebf}">
+        <p14:section name="Situation" id="{7fc3d639-b828-db46-3ccf-ec1bd167fca2}">
           <p14:sldIdLst>
             <p14:sldId id="257"/>
           </p14:sldIdLst>
         </p14:section>
-        <p14:section name="Complication" id="{94e86031-1ccd-9354-9f15-feaa44d6bae9}">
+        <p14:section name="Complication" id="{798dc338-5c53-f1b0-a923-870122805125}">
           <p14:sldIdLst>
             <p14:sldId id="258"/>
           </p14:sldIdLst>
         </p14:section>
-        <p14:section name="Answer and proof" id="{306d7dee-85cc-f0da-2c90-830d004c7327}">
+        <p14:section name="Answer and proof" id="{fb83d86c-4fe4-31b6-37f6-1b3484a375b0}">
           <p14:sldIdLst>
             <p14:sldId id="259"/>
             <p14:sldId id="260"/>
           </p14:sldIdLst>
         </p14:section>
-        <p14:section name="Fit and scale" id="{03418415-bf70-30a9-d0b5-9b9fcd4d0bc2}">
+        <p14:section name="Fit and scale" id="{64316c4d-9dbe-8461-a5ff-106430e23b67}">
           <p14:sldIdLst>
             <p14:sldId id="261"/>
             <p14:sldId id="262"/>
@@ -959,7 +959,7 @@
           <a:p>
             <a:r>
               <a:rPr lang="en-US" dirty="0"/>
-              <a:t>Give the answer first, in one breath: two developers moved ERM, a business-critical Slate application with no documentation, to Airbus DevX with React and OSDK in a single PI, using an AI-assisted method we designed and that any team can reuse. Then: let me show you why that was hard, what we did differently, and the proof.</a:t>
+              <a:t>Give the answer first, in one breath: two developers rebuilt ERM, a business-critical Slate application with no documentation, for Airbus DevX with React and OSDK in a single PI, ready for go-live, using an AI-assisted method we designed and that any team can reuse. Then: let me show you why that was hard, what we did differently, and the proof.</a:t>
             </a:r>
             <a:endParaRPr lang="en-US" dirty="0"/>
           </a:p>
@@ -1311,7 +1311,7 @@
           <a:p>
             <a:r>
               <a:rPr lang="en-US" dirty="0"/>
-              <a:t>The proof, hard facts first. One PI. Two developers. All 105 features carried over and checked. The AI review found and prioritised 31 gaps, including 7 security and data-integrity issues such as unsanitised rich text and permission checks, all caught in review; the dashboard sharing-access fix is deployed. Documentation went from nothing to 10 documents. Against a generic estimate of about 340 person-days, roughly 17 sprints for two developers, we used 4 sprints: about 76% less effort. Say clearly that this is a generic estimate. Then the after-go-live row: fill in real numbers for users retained, page-switch time and incidents before presenting, or remove the row.</a:t>
+              <a:t>The proof, hard facts first. One PI. Two developers. All 105 features carried over and checked. The AI review found and prioritised 31 gaps, including 7 security and data-integrity issues such as unsanitised rich text and permission checks, all caught in review; the dashboard sharing-access fix is deployed. Documentation went from nothing to 10 documents. Against a generic estimate of about 340 person-days, roughly 17 sprints for two developers, we used 4 sprints: about 76% less effort. Say clearly that this is a generic estimate. Then the readiness row: be clear the app is not live yet. Everything is checked and the backend sharing fix is deployed; go-live is planned for [date], after which the Slate app is retired. Tell the jury what you will measure after go-live: users retained, page-switch time against Slate, and incidents after release.</a:t>
             </a:r>
             <a:endParaRPr lang="en-US" dirty="0"/>
           </a:p>
@@ -1399,7 +1399,7 @@
           <a:p>
             <a:r>
               <a:rPr lang="en-US" dirty="0"/>
-              <a:t>This slide shows strategic fit and teamwork; the flow builds one branch at a time. One: Leverage AI to solve business problems. The AI read all 8 Slate exports and the packed React code, recovered 105 features from an undocumented app and found 31 gaps. Two: Deliver on time, on cost, on quality. Two developers delivered it in one PI, about 76% less effort than a generic manual estimate. Three: Ensure our operational performance. ERM is a business system; every one of its 105 features was tracked for parity, and it now runs on standard, maintainable React and OSDK code instead of legacy Slate configuration. Four: Grow digital acumen and competencies. pack-project.ts and the playbook mean other teams can repeat this, which builds AI-assisted engineering skills across the organisation. Finally the team strip: business users confirmed the feature catalogue, data and security owners kept the restricted-view access model intact, and backend and frontend fixes shipped together. Name the people and teams here.</a:t>
+              <a:t>This slide shows strategic fit and teamwork; the flow builds one branch at a time. One: Leverage AI to solve business problems. The AI read all 8 Slate exports and the packed React code, recovered 105 features from an undocumented app and found 31 gaps. Two: Deliver on time, on cost, on quality. Two developers delivered it in one PI, about 76% less effort than a generic manual estimate. Three: Ensure our operational performance. ERM is a business system; every one of its 105 features was tracked for parity, and it is rebuilt on standard, maintainable React and OSDK code, ready to replace the legacy Slate configuration. Four: Grow digital acumen and competencies. pack-project.ts and the playbook mean other teams can repeat this, which builds AI-assisted engineering skills across the organisation. Finally the team strip: business users confirmed the feature catalogue, data and security owners kept the restricted-view access model intact, and backend and frontend fixes shipped together. Name the people and teams here.</a:t>
             </a:r>
             <a:endParaRPr lang="en-US" dirty="0"/>
           </a:p>
@@ -2293,7 +2293,7 @@
                   <a:schemeClr val="bg1"/>
                 </a:solidFill>
               </a:rPr>
-              <a:t>2 developers moved a business-critical, undocumented app to Airbus DevX in one PI, with an AI method any team can reuse</a:t>
+              <a:t>2 developers rebuilt a business-critical, undocumented app for Airbus DevX in one PI, with an AI method any team can reuse</a:t>
             </a:r>
             <a:endParaRPr lang="en-US" sz="2000" dirty="0"/>
           </a:p>
@@ -7543,7 +7543,7 @@
         <p:spPr>
           <a:xfrm>
             <a:off x="822960" y="4937760"/>
-            <a:ext cx="3657600" cy="274320"/>
+            <a:ext cx="7315200" cy="274320"/>
           </a:xfrm>
           <a:prstGeom prst="rect">
             <a:avLst/>
@@ -7564,7 +7564,7 @@
                   <a:schemeClr val="accent3"/>
                 </a:solidFill>
               </a:rPr>
-              <a:t>AFTER GO-LIVE</a:t>
+              <a:t>READY FOR GO-LIVE · [planned date]</a:t>
             </a:r>
             <a:endParaRPr lang="en-US" sz="1100" dirty="0"/>
           </a:p>
@@ -7595,14 +7595,14 @@
               <a:buNone/>
             </a:pPr>
             <a:r>
-              <a:rPr lang="en-US" sz="2400" b="1" dirty="0">
+              <a:rPr lang="en-US" sz="1600" b="1" dirty="0">
                 <a:solidFill>
                   <a:schemeClr val="tx1"/>
                 </a:solidFill>
               </a:rPr>
-              <a:t>[__] users</a:t>
-            </a:r>
-            <a:endParaRPr lang="en-US" sz="2400" dirty="0"/>
+              <a:t>Ready now</a:t>
+            </a:r>
+            <a:endParaRPr lang="en-US" sz="1600" dirty="0"/>
           </a:p>
           <a:p>
             <a:pPr indent="0" marL="0">
@@ -7614,9 +7614,9 @@
                   <a:schemeClr val="tx2"/>
                 </a:solidFill>
               </a:rPr>
-              <a:t>kept using ERM after the switch</a:t>
-            </a:r>
-            <a:endParaRPr lang="en-US" sz="2400" dirty="0"/>
+              <a:t>All 105 features checked against the code; backend sharing fix deployed</a:t>
+            </a:r>
+            <a:endParaRPr lang="en-US" sz="1600" dirty="0"/>
           </a:p>
         </p:txBody>
       </p:sp>
@@ -7645,14 +7645,14 @@
               <a:buNone/>
             </a:pPr>
             <a:r>
-              <a:rPr lang="en-US" sz="2400" b="1" dirty="0">
+              <a:rPr lang="en-US" sz="1600" b="1" dirty="0">
                 <a:solidFill>
                   <a:schemeClr val="tx1"/>
                 </a:solidFill>
               </a:rPr>
-              <a:t>[__] s</a:t>
-            </a:r>
-            <a:endParaRPr lang="en-US" sz="2400" dirty="0"/>
+              <a:t>Next</a:t>
+            </a:r>
+            <a:endParaRPr lang="en-US" sz="1600" dirty="0"/>
           </a:p>
           <a:p>
             <a:pPr indent="0" marL="0">
@@ -7664,9 +7664,9 @@
                   <a:schemeClr val="tx2"/>
                 </a:solidFill>
               </a:rPr>
-              <a:t>page switch, down from [__] s in Slate</a:t>
-            </a:r>
-            <a:endParaRPr lang="en-US" sz="2400" dirty="0"/>
+              <a:t>Go-live to 892 users across 6 countries, then retire the Slate app</a:t>
+            </a:r>
+            <a:endParaRPr lang="en-US" sz="1600" dirty="0"/>
           </a:p>
         </p:txBody>
       </p:sp>
@@ -7695,14 +7695,14 @@
               <a:buNone/>
             </a:pPr>
             <a:r>
-              <a:rPr lang="en-US" sz="2400" b="1" dirty="0">
+              <a:rPr lang="en-US" sz="1600" b="1" dirty="0">
                 <a:solidFill>
                   <a:schemeClr val="tx1"/>
                 </a:solidFill>
               </a:rPr>
-              <a:t>[__]</a:t>
-            </a:r>
-            <a:endParaRPr lang="en-US" sz="2400" dirty="0"/>
+              <a:t>We will measure</a:t>
+            </a:r>
+            <a:endParaRPr lang="en-US" sz="1600" dirty="0"/>
           </a:p>
           <a:p>
             <a:pPr indent="0" marL="0">
@@ -7714,9 +7714,9 @@
                   <a:schemeClr val="tx2"/>
                 </a:solidFill>
               </a:rPr>
-              <a:t>incidents after release</a:t>
-            </a:r>
-            <a:endParaRPr lang="en-US" sz="2400" dirty="0"/>
+              <a:t>Users retained, page-switch time against Slate, incidents after release</a:t>
+            </a:r>
+            <a:endParaRPr lang="en-US" sz="1600" dirty="0"/>
           </a:p>
         </p:txBody>
       </p:sp>
@@ -9492,7 +9492,7 @@
                   <a:schemeClr val="tx1"/>
                 </a:solidFill>
               </a:rPr>
-              <a:t>All 105 features tracked for parity; ERM moved off legacy Slate onto a standard, maintainable stack</a:t>
+              <a:t>All 105 features tracked for parity; ERM rebuilt on a standard, maintainable stack, ready to leave Slate</a:t>
             </a:r>
             <a:endParaRPr lang="en-US" sz="1300" dirty="0"/>
           </a:p>
@@ -11741,7 +11741,7 @@
                   <a:schemeClr val="bg1"/>
                 </a:solidFill>
               </a:rPr>
-              <a:t>Same users, same features, one PI, two developers. Ready for the next app.</a:t>
+              <a:t>105 features, one PI, two developers. Ready for go-live, and for the next app.</a:t>
             </a:r>
             <a:endParaRPr lang="en-US" sz="2200" dirty="0"/>
           </a:p>

</xml_diff>

<commit_message>
Add business testimonials slide to both jury pitch decks (attributed by role)
Co-Authored-By: Claude Opus 5.5 <noreply@anthropic.com>
Claude-Session: https://claude.ai/code/session_01HdxEbeqqWM97gKbcNqpjAq
</commit_message>
<xml_diff>
--- a/erm-migration/docs/ERM-Migration-Jury-Pitch-v2.pptx
+++ b/erm-migration/docs/ERM-Migration-Jury-Pitch-v2.pptx
@@ -12,9 +12,10 @@
     <p:sldId id="260" r:id="rId6"/>
     <p:sldId id="261" r:id="rId7"/>
     <p:sldId id="262" r:id="rId8"/>
+    <p:sldId id="263" r:id="rId9"/>
   </p:sldIdLst>
   <p:notesMasterIdLst>
-    <p:notesMasterId r:id="rId9"/>
+    <p:notesMasterId r:id="rId10"/>
   </p:notesMasterIdLst>
   <p:sldSz cx="12192000" cy="6858000"/>
   <p:notesSz cx="6858000" cy="12192000"/>
@@ -113,31 +114,32 @@
   <p:extLst>
     <p:ext uri="{521415D9-36F7-43E2-AB2F-B90AF26B5E84}">
       <p14:sectionLst xmlns:p14="http://schemas.microsoft.com/office/powerpoint/2010/main">
-        <p14:section name="Answer" id="{976a79f0-e7d2-08d1-f704-09e3144c994b}">
+        <p14:section name="Answer" id="{7c3e8660-2e10-84df-dc5f-6ee849dc40a0}">
           <p14:sldIdLst>
             <p14:sldId id="256"/>
           </p14:sldIdLst>
         </p14:section>
-        <p14:section name="Situation" id="{7fc3d639-b828-db46-3ccf-ec1bd167fca2}">
+        <p14:section name="Situation" id="{ab86797d-9a67-508d-9e39-f72f3a6a14eb}">
           <p14:sldIdLst>
             <p14:sldId id="257"/>
           </p14:sldIdLst>
         </p14:section>
-        <p14:section name="Complication" id="{798dc338-5c53-f1b0-a923-870122805125}">
+        <p14:section name="Complication" id="{ebdeb920-a5eb-f74c-fa2a-6bfd144b7ae5}">
           <p14:sldIdLst>
             <p14:sldId id="258"/>
           </p14:sldIdLst>
         </p14:section>
-        <p14:section name="Answer and proof" id="{fb83d86c-4fe4-31b6-37f6-1b3484a375b0}">
+        <p14:section name="Answer and proof" id="{7d7c7f72-3db3-c2d7-12b9-83e400fcb167}">
           <p14:sldIdLst>
             <p14:sldId id="259"/>
             <p14:sldId id="260"/>
+            <p14:sldId id="261"/>
           </p14:sldIdLst>
         </p14:section>
-        <p14:section name="Fit and scale" id="{64316c4d-9dbe-8461-a5ff-106430e23b67}">
+        <p14:section name="Fit and scale" id="{22ef6901-0bbe-2a6c-9434-10753d2a1036}">
           <p14:sldIdLst>
-            <p14:sldId id="261"/>
             <p14:sldId id="262"/>
+            <p14:sldId id="263"/>
           </p14:sldIdLst>
         </p14:section>
       </p14:sectionLst>
@@ -1399,7 +1401,7 @@
           <a:p>
             <a:r>
               <a:rPr lang="en-US" dirty="0"/>
-              <a:t>This slide shows strategic fit and teamwork; the flow builds one branch at a time. One: Leverage AI to solve business problems. The AI read all 8 Slate exports and the packed React code, recovered 105 features from an undocumented app and found 31 gaps. Two: Deliver on time, on cost, on quality. Two developers delivered it in one PI, about 76% less effort than a generic manual estimate. Three: Ensure our operational performance. ERM is a business system; every one of its 105 features was tracked for parity, and it is rebuilt on standard, maintainable React and OSDK code, ready to replace the legacy Slate configuration. Four: Grow digital acumen and competencies. pack-project.ts and the playbook mean other teams can repeat this, which builds AI-assisted engineering skills across the organisation. Finally the team strip: business users confirmed the feature catalogue, data and security owners kept the restricted-view access model intact, and backend and frontend fixes shipped together. Name the people and teams here.</a:t>
+              <a:t>Let the business speak. These are testimonials sent by ERM stakeholders in September 2026 about the team and the ERM tool. A member of the ERM centre of competence: teamwork with the business and strong IT skills turned an idea into a proof of concept, and the user interface and performance have significantly improved since. An ERM stakeholder: the ERM dashboard is a tremendous addition to the ERM toolset, and more and more users prepare and run their risk and opportunity reviews with it. A Risk and Opportunity Manager in Hamburg: new features made navigation easier and gave a much clearer view of R&amp;O data, and issues were fixed quickly. Make clear these speak about the team and the tool overall.</a:t>
             </a:r>
             <a:endParaRPr lang="en-US" dirty="0"/>
           </a:p>
@@ -1487,7 +1489,7 @@
           <a:p>
             <a:r>
               <a:rPr lang="en-US" dirty="0"/>
-              <a:t>Close on scale and make an ask. The method is five steps: pack, extract, compare, fix, document. The pieces are ready to reuse: pack-project.ts, the comparison template and the diagram formats. It fits other Slate apps and any low-code tool with little documentation. Then the ask: fill in what you want from the jury or leadership, for example sponsorship to run the playbook on a number of other Slate apps next PI, or a team to pilot it. End on the line on screen and invite questions.</a:t>
+              <a:t>This slide shows strategic fit and teamwork; the flow builds one branch at a time. One: Leverage AI to solve business problems. The AI read all 8 Slate exports and the packed React code, recovered 105 features from an undocumented app and found 31 gaps. Two: Deliver on time, on cost, on quality. Two developers delivered it in one PI, about 76% less effort than a generic manual estimate. Three: Ensure our operational performance. ERM is a business system; every one of its 105 features was tracked for parity, and it is rebuilt on standard, maintainable React and OSDK code, ready to replace the legacy Slate configuration. Four: Grow digital acumen and competencies. pack-project.ts and the playbook mean other teams can repeat this, which builds AI-assisted engineering skills across the organisation. Finally the team strip: business users confirmed the feature catalogue, data and security owners kept the restricted-view access model intact, and backend and frontend fixes shipped together. Name the people and teams here.</a:t>
             </a:r>
             <a:endParaRPr lang="en-US" dirty="0"/>
           </a:p>
@@ -1511,6 +1513,94 @@
             <a:fld id="{F7021451-1387-4CA6-816F-3879F97B5CBC}" type="slidenum">
               <a:rPr lang="en-US"/>
               <a:t>7</a:t>
+            </a:fld>
+            <a:endParaRPr lang="en-US"/>
+          </a:p>
+        </p:txBody>
+      </p:sp>
+    </p:spTree>
+    <p:extLst>
+      <p:ext uri="{BB962C8B-B14F-4D97-AF65-F5344CB8AC3E}">
+        <p14:creationId xmlns:p14="http://schemas.microsoft.com/office/powerpoint/2010/main" val="1024086991"/>
+      </p:ext>
+    </p:extLst>
+  </p:cSld>
+  <p:clrMapOvr>
+    <a:masterClrMapping/>
+  </p:clrMapOvr>
+</p:notes>
+</file>
+
+<file path=ppt/notesSlides/notesSlide8.xml><?xml version="1.0" encoding="utf-8"?>
+<p:notes xmlns:a="http://schemas.openxmlformats.org/drawingml/2006/main" xmlns:r="http://schemas.openxmlformats.org/officeDocument/2006/relationships" xmlns:p="http://schemas.openxmlformats.org/presentationml/2006/main">
+  <p:cSld>
+    <p:spTree>
+      <p:nvGrpSpPr>
+        <p:cNvPr id="1" name=""/>
+        <p:cNvGrpSpPr/>
+        <p:nvPr/>
+      </p:nvGrpSpPr>
+      <p:grpSpPr>
+        <a:xfrm>
+          <a:off x="0" y="0"/>
+          <a:ext cx="0" cy="0"/>
+          <a:chOff x="0" y="0"/>
+          <a:chExt cx="0" cy="0"/>
+        </a:xfrm>
+      </p:grpSpPr>
+      <p:sp>
+        <p:nvSpPr>
+          <p:cNvPr id="2" name="Slide Image Placeholder 1"/>
+          <p:cNvSpPr>
+            <a:spLocks noGrp="1" noRot="1" noChangeAspect="1"/>
+          </p:cNvSpPr>
+          <p:nvPr>
+            <p:ph type="sldImg"/>
+          </p:nvPr>
+        </p:nvSpPr>
+        <p:spPr/>
+      </p:sp>
+      <p:sp>
+        <p:nvSpPr>
+          <p:cNvPr id="3" name="Notes Placeholder 2"/>
+          <p:cNvSpPr>
+            <a:spLocks noGrp="1"/>
+          </p:cNvSpPr>
+          <p:nvPr>
+            <p:ph type="body" idx="1"/>
+          </p:nvPr>
+        </p:nvSpPr>
+        <p:spPr/>
+        <p:txBody>
+          <a:bodyPr/>
+          <a:lstStyle/>
+          <a:p>
+            <a:r>
+              <a:rPr lang="en-US" dirty="0"/>
+              <a:t>Close on scale and make an ask. The method is five steps: pack, extract, compare, fix, document. The pieces are ready to reuse: pack-project.ts, the comparison template and the diagram formats. It fits other Slate apps and any low-code tool with little documentation. Then the ask: fill in what you want from the jury or leadership, for example sponsorship to run the playbook on a number of other Slate apps next PI, or a team to pilot it. End on the line on screen and invite questions.</a:t>
+            </a:r>
+            <a:endParaRPr lang="en-US" dirty="0"/>
+          </a:p>
+        </p:txBody>
+      </p:sp>
+      <p:sp>
+        <p:nvSpPr>
+          <p:cNvPr id="4" name="Slide Number Placeholder 3"/>
+          <p:cNvSpPr>
+            <a:spLocks noGrp="1"/>
+          </p:cNvSpPr>
+          <p:nvPr>
+            <p:ph type="sldNum" sz="quarter" idx="10"/>
+          </p:nvPr>
+        </p:nvSpPr>
+        <p:spPr/>
+        <p:txBody>
+          <a:bodyPr/>
+          <a:lstStyle/>
+          <a:p>
+            <a:fld id="{F7021451-1387-4CA6-816F-3879F97B5CBC}" type="slidenum">
+              <a:rPr lang="en-US"/>
+              <a:t>8</a:t>
             </a:fld>
             <a:endParaRPr lang="en-US"/>
           </a:p>
@@ -8794,6 +8884,1124 @@
                   <a:schemeClr val="accent3"/>
                 </a:solidFill>
               </a:rPr>
+              <a:t>VOICE OF THE BUSINESS · IMPACT</a:t>
+            </a:r>
+            <a:endParaRPr lang="en-US" sz="1100" dirty="0"/>
+          </a:p>
+        </p:txBody>
+      </p:sp>
+      <p:sp>
+        <p:nvSpPr>
+          <p:cNvPr id="3" name="Text 1"/>
+          <p:cNvSpPr/>
+          <p:nvPr>
+            <p:ph idx="101" type="title" hasCustomPrompt="1"/>
+          </p:nvPr>
+        </p:nvSpPr>
+        <p:spPr>
+          <a:xfrm>
+            <a:off x="548640" y="502920"/>
+            <a:ext cx="11094415" cy="822960"/>
+          </a:xfrm>
+          <a:prstGeom prst="rect">
+            <a:avLst/>
+          </a:prstGeom>
+          <a:noFill/>
+          <a:ln/>
+        </p:spPr>
+        <p:txBody>
+          <a:bodyPr wrap="square" lIns="0" tIns="0" rIns="0" bIns="0" rtlCol="0" anchor="t"/>
+          <a:lstStyle/>
+          <a:p>
+            <a:pPr algn="l" indent="0" marL="0">
+              <a:buNone/>
+            </a:pPr>
+            <a:r>
+              <a:rPr lang="en-US" sz="3600" b="1" dirty="0">
+                <a:solidFill>
+                  <a:schemeClr val="tx1"/>
+                </a:solidFill>
+              </a:rPr>
+              <a:t>What the business says</a:t>
+            </a:r>
+            <a:endParaRPr lang="en-US" sz="3600" dirty="0"/>
+          </a:p>
+        </p:txBody>
+      </p:sp>
+      <p:sp>
+        <p:nvSpPr>
+          <p:cNvPr id="4" name="quote-sub"/>
+          <p:cNvSpPr txBox="1"/>
+          <p:nvPr/>
+        </p:nvSpPr>
+        <p:spPr>
+          <a:xfrm>
+            <a:off x="548640" y="1115568"/>
+            <a:ext cx="11094415" cy="320040"/>
+          </a:xfrm>
+          <a:prstGeom prst="rect">
+            <a:avLst/>
+          </a:prstGeom>
+          <a:noFill/>
+          <a:ln/>
+        </p:spPr>
+        <p:txBody>
+          <a:bodyPr wrap="square" lIns="0" tIns="0" rIns="0" bIns="0" rtlCol="0" anchor="t"/>
+          <a:lstStyle/>
+          <a:p>
+            <a:pPr indent="0" marL="0">
+              <a:buNone/>
+            </a:pPr>
+            <a:r>
+              <a:rPr lang="en-US" sz="1400" dirty="0">
+                <a:solidFill>
+                  <a:schemeClr val="tx2"/>
+                </a:solidFill>
+              </a:rPr>
+              <a:t>Feedback from ERM business stakeholders, September 2026</a:t>
+            </a:r>
+            <a:endParaRPr lang="en-US" sz="1400" dirty="0"/>
+          </a:p>
+        </p:txBody>
+      </p:sp>
+      <p:sp>
+        <p:nvSpPr>
+          <p:cNvPr id="5" name="quote-0-card"/>
+          <p:cNvSpPr/>
+          <p:nvPr/>
+        </p:nvSpPr>
+        <p:spPr>
+          <a:xfrm>
+            <a:off x="548640" y="1645920"/>
+            <a:ext cx="3515258" cy="4480560"/>
+          </a:xfrm>
+          <a:prstGeom prst="roundRect">
+            <a:avLst>
+              <a:gd name="adj" fmla="val 3121"/>
+            </a:avLst>
+          </a:prstGeom>
+          <a:solidFill>
+            <a:schemeClr val="tx1"/>
+          </a:solidFill>
+          <a:ln/>
+        </p:spPr>
+      </p:sp>
+      <p:sp>
+        <p:nvSpPr>
+          <p:cNvPr id="6" name="quote-0-mark"/>
+          <p:cNvSpPr txBox="1"/>
+          <p:nvPr/>
+        </p:nvSpPr>
+        <p:spPr>
+          <a:xfrm>
+            <a:off x="822960" y="1783080"/>
+            <a:ext cx="914400" cy="731520"/>
+          </a:xfrm>
+          <a:prstGeom prst="rect">
+            <a:avLst/>
+          </a:prstGeom>
+          <a:noFill/>
+          <a:ln/>
+        </p:spPr>
+        <p:txBody>
+          <a:bodyPr wrap="square" lIns="0" tIns="0" rIns="0" bIns="0" rtlCol="0" anchor="t"/>
+          <a:lstStyle/>
+          <a:p>
+            <a:pPr indent="0" marL="0">
+              <a:buNone/>
+            </a:pPr>
+            <a:r>
+              <a:rPr lang="en-US" sz="6000" b="1" dirty="0">
+                <a:solidFill>
+                  <a:schemeClr val="accent5"/>
+                </a:solidFill>
+              </a:rPr>
+              <a:t>“</a:t>
+            </a:r>
+            <a:endParaRPr lang="en-US" sz="6000" dirty="0"/>
+          </a:p>
+        </p:txBody>
+      </p:sp>
+      <p:sp>
+        <p:nvSpPr>
+          <p:cNvPr id="7" name="quote-0-text"/>
+          <p:cNvSpPr txBox="1"/>
+          <p:nvPr/>
+        </p:nvSpPr>
+        <p:spPr>
+          <a:xfrm>
+            <a:off x="822960" y="2514600"/>
+            <a:ext cx="2966618" cy="2606040"/>
+          </a:xfrm>
+          <a:prstGeom prst="rect">
+            <a:avLst/>
+          </a:prstGeom>
+          <a:noFill/>
+          <a:ln/>
+        </p:spPr>
+        <p:txBody>
+          <a:bodyPr wrap="square" lIns="0" tIns="0" rIns="0" bIns="0" rtlCol="0" anchor="t"/>
+          <a:lstStyle/>
+          <a:p>
+            <a:pPr indent="0" marL="0">
+              <a:buNone/>
+            </a:pPr>
+            <a:r>
+              <a:rPr lang="en-US" sz="1800" i="1" dirty="0">
+                <a:solidFill>
+                  <a:schemeClr val="bg1"/>
+                </a:solidFill>
+              </a:rPr>
+              <a:t>Thanks to a mix of regular teamwork with the business and strong IT skills, they have turned an idea into a proof of concept… User interface and performance have significantly improved since the first proof of concept.</a:t>
+            </a:r>
+            <a:endParaRPr lang="en-US" sz="1800" dirty="0"/>
+          </a:p>
+        </p:txBody>
+      </p:sp>
+      <p:sp>
+        <p:nvSpPr>
+          <p:cNvPr id="8" name="quote-0-who"/>
+          <p:cNvSpPr txBox="1"/>
+          <p:nvPr/>
+        </p:nvSpPr>
+        <p:spPr>
+          <a:xfrm>
+            <a:off x="822960" y="5166360"/>
+            <a:ext cx="2966618" cy="731520"/>
+          </a:xfrm>
+          <a:prstGeom prst="rect">
+            <a:avLst/>
+          </a:prstGeom>
+          <a:noFill/>
+          <a:ln/>
+        </p:spPr>
+        <p:txBody>
+          <a:bodyPr wrap="square" lIns="0" tIns="0" rIns="0" bIns="0" rtlCol="0" anchor="b"/>
+          <a:lstStyle/>
+          <a:p>
+            <a:pPr indent="0" marL="0">
+              <a:buNone/>
+            </a:pPr>
+            <a:r>
+              <a:rPr lang="en-US" sz="1400" b="1" dirty="0">
+                <a:solidFill>
+                  <a:schemeClr val="bg1"/>
+                </a:solidFill>
+              </a:rPr>
+              <a:t>ERM Centre of Competence</a:t>
+            </a:r>
+            <a:endParaRPr lang="en-US" sz="1400" dirty="0"/>
+          </a:p>
+          <a:p>
+            <a:pPr indent="0" marL="0">
+              <a:buNone/>
+            </a:pPr>
+            <a:r>
+              <a:rPr lang="en-US" sz="1200" dirty="0">
+                <a:solidFill>
+                  <a:schemeClr val="accent5"/>
+                </a:solidFill>
+              </a:rPr>
+              <a:t>Enterprise Risk Management</a:t>
+            </a:r>
+            <a:endParaRPr lang="en-US" sz="1400" dirty="0"/>
+          </a:p>
+        </p:txBody>
+      </p:sp>
+      <p:sp>
+        <p:nvSpPr>
+          <p:cNvPr id="9" name="quote-1-card"/>
+          <p:cNvSpPr/>
+          <p:nvPr/>
+        </p:nvSpPr>
+        <p:spPr>
+          <a:xfrm>
+            <a:off x="4338218" y="1645920"/>
+            <a:ext cx="3515258" cy="4480560"/>
+          </a:xfrm>
+          <a:prstGeom prst="roundRect">
+            <a:avLst>
+              <a:gd name="adj" fmla="val 3121"/>
+            </a:avLst>
+          </a:prstGeom>
+          <a:solidFill>
+            <a:schemeClr val="bg1"/>
+          </a:solidFill>
+          <a:ln/>
+        </p:spPr>
+      </p:sp>
+      <p:sp>
+        <p:nvSpPr>
+          <p:cNvPr id="10" name="quote-1-mark"/>
+          <p:cNvSpPr txBox="1"/>
+          <p:nvPr/>
+        </p:nvSpPr>
+        <p:spPr>
+          <a:xfrm>
+            <a:off x="4612538" y="1783080"/>
+            <a:ext cx="914400" cy="731520"/>
+          </a:xfrm>
+          <a:prstGeom prst="rect">
+            <a:avLst/>
+          </a:prstGeom>
+          <a:noFill/>
+          <a:ln/>
+        </p:spPr>
+        <p:txBody>
+          <a:bodyPr wrap="square" lIns="0" tIns="0" rIns="0" bIns="0" rtlCol="0" anchor="t"/>
+          <a:lstStyle/>
+          <a:p>
+            <a:pPr indent="0" marL="0">
+              <a:buNone/>
+            </a:pPr>
+            <a:r>
+              <a:rPr lang="en-US" sz="6000" b="1" dirty="0">
+                <a:solidFill>
+                  <a:schemeClr val="accent3"/>
+                </a:solidFill>
+              </a:rPr>
+              <a:t>“</a:t>
+            </a:r>
+            <a:endParaRPr lang="en-US" sz="6000" dirty="0"/>
+          </a:p>
+        </p:txBody>
+      </p:sp>
+      <p:sp>
+        <p:nvSpPr>
+          <p:cNvPr id="11" name="quote-1-text"/>
+          <p:cNvSpPr txBox="1"/>
+          <p:nvPr/>
+        </p:nvSpPr>
+        <p:spPr>
+          <a:xfrm>
+            <a:off x="4612538" y="2514600"/>
+            <a:ext cx="2966618" cy="2606040"/>
+          </a:xfrm>
+          <a:prstGeom prst="rect">
+            <a:avLst/>
+          </a:prstGeom>
+          <a:noFill/>
+          <a:ln/>
+        </p:spPr>
+        <p:txBody>
+          <a:bodyPr wrap="square" lIns="0" tIns="0" rIns="0" bIns="0" rtlCol="0" anchor="t"/>
+          <a:lstStyle/>
+          <a:p>
+            <a:pPr indent="0" marL="0">
+              <a:buNone/>
+            </a:pPr>
+            <a:r>
+              <a:rPr lang="en-US" sz="1800" i="1" dirty="0">
+                <a:solidFill>
+                  <a:schemeClr val="tx1"/>
+                </a:solidFill>
+              </a:rPr>
+              <a:t>The Skywise ERM dashboard application is a tremendous addition to our ERM toolset… More and more users regularly prepare and facilitate risks &amp; opportunities reviews with the application.</a:t>
+            </a:r>
+            <a:endParaRPr lang="en-US" sz="1800" dirty="0"/>
+          </a:p>
+        </p:txBody>
+      </p:sp>
+      <p:sp>
+        <p:nvSpPr>
+          <p:cNvPr id="12" name="quote-1-who"/>
+          <p:cNvSpPr txBox="1"/>
+          <p:nvPr/>
+        </p:nvSpPr>
+        <p:spPr>
+          <a:xfrm>
+            <a:off x="4612538" y="5166360"/>
+            <a:ext cx="2966618" cy="731520"/>
+          </a:xfrm>
+          <a:prstGeom prst="rect">
+            <a:avLst/>
+          </a:prstGeom>
+          <a:noFill/>
+          <a:ln/>
+        </p:spPr>
+        <p:txBody>
+          <a:bodyPr wrap="square" lIns="0" tIns="0" rIns="0" bIns="0" rtlCol="0" anchor="b"/>
+          <a:lstStyle/>
+          <a:p>
+            <a:pPr indent="0" marL="0">
+              <a:buNone/>
+            </a:pPr>
+            <a:r>
+              <a:rPr lang="en-US" sz="1400" b="1" dirty="0">
+                <a:solidFill>
+                  <a:schemeClr val="tx1"/>
+                </a:solidFill>
+              </a:rPr>
+              <a:t>ERM stakeholder</a:t>
+            </a:r>
+            <a:endParaRPr lang="en-US" sz="1400" dirty="0"/>
+          </a:p>
+          <a:p>
+            <a:pPr indent="0" marL="0">
+              <a:buNone/>
+            </a:pPr>
+            <a:r>
+              <a:rPr lang="en-US" sz="1200" dirty="0">
+                <a:solidFill>
+                  <a:schemeClr val="tx2"/>
+                </a:solidFill>
+              </a:rPr>
+              <a:t>[Role]</a:t>
+            </a:r>
+            <a:endParaRPr lang="en-US" sz="1400" dirty="0"/>
+          </a:p>
+        </p:txBody>
+      </p:sp>
+      <p:sp>
+        <p:nvSpPr>
+          <p:cNvPr id="13" name="quote-2-card"/>
+          <p:cNvSpPr/>
+          <p:nvPr/>
+        </p:nvSpPr>
+        <p:spPr>
+          <a:xfrm>
+            <a:off x="8127797" y="1645920"/>
+            <a:ext cx="3515258" cy="4480560"/>
+          </a:xfrm>
+          <a:prstGeom prst="roundRect">
+            <a:avLst>
+              <a:gd name="adj" fmla="val 3121"/>
+            </a:avLst>
+          </a:prstGeom>
+          <a:solidFill>
+            <a:schemeClr val="bg1"/>
+          </a:solidFill>
+          <a:ln/>
+        </p:spPr>
+      </p:sp>
+      <p:sp>
+        <p:nvSpPr>
+          <p:cNvPr id="14" name="quote-2-mark"/>
+          <p:cNvSpPr txBox="1"/>
+          <p:nvPr/>
+        </p:nvSpPr>
+        <p:spPr>
+          <a:xfrm>
+            <a:off x="8402117" y="1783080"/>
+            <a:ext cx="914400" cy="731520"/>
+          </a:xfrm>
+          <a:prstGeom prst="rect">
+            <a:avLst/>
+          </a:prstGeom>
+          <a:noFill/>
+          <a:ln/>
+        </p:spPr>
+        <p:txBody>
+          <a:bodyPr wrap="square" lIns="0" tIns="0" rIns="0" bIns="0" rtlCol="0" anchor="t"/>
+          <a:lstStyle/>
+          <a:p>
+            <a:pPr indent="0" marL="0">
+              <a:buNone/>
+            </a:pPr>
+            <a:r>
+              <a:rPr lang="en-US" sz="6000" b="1" dirty="0">
+                <a:solidFill>
+                  <a:schemeClr val="accent3"/>
+                </a:solidFill>
+              </a:rPr>
+              <a:t>“</a:t>
+            </a:r>
+            <a:endParaRPr lang="en-US" sz="6000" dirty="0"/>
+          </a:p>
+        </p:txBody>
+      </p:sp>
+      <p:sp>
+        <p:nvSpPr>
+          <p:cNvPr id="15" name="quote-2-text"/>
+          <p:cNvSpPr txBox="1"/>
+          <p:nvPr/>
+        </p:nvSpPr>
+        <p:spPr>
+          <a:xfrm>
+            <a:off x="8402117" y="2514600"/>
+            <a:ext cx="2966618" cy="2606040"/>
+          </a:xfrm>
+          <a:prstGeom prst="rect">
+            <a:avLst/>
+          </a:prstGeom>
+          <a:noFill/>
+          <a:ln/>
+        </p:spPr>
+        <p:txBody>
+          <a:bodyPr wrap="square" lIns="0" tIns="0" rIns="0" bIns="0" rtlCol="0" anchor="t"/>
+          <a:lstStyle/>
+          <a:p>
+            <a:pPr indent="0" marL="0">
+              <a:buNone/>
+            </a:pPr>
+            <a:r>
+              <a:rPr lang="en-US" sz="1800" i="1" dirty="0">
+                <a:solidFill>
+                  <a:schemeClr val="tx1"/>
+                </a:solidFill>
+              </a:rPr>
+              <a:t>They built great new features that make navigation easier and give us a much clearer view of our R&amp;O data. Whenever bugs or issues came up, they fixed them quickly and efficiently.</a:t>
+            </a:r>
+            <a:endParaRPr lang="en-US" sz="1800" dirty="0"/>
+          </a:p>
+        </p:txBody>
+      </p:sp>
+      <p:sp>
+        <p:nvSpPr>
+          <p:cNvPr id="16" name="quote-2-who"/>
+          <p:cNvSpPr txBox="1"/>
+          <p:nvPr/>
+        </p:nvSpPr>
+        <p:spPr>
+          <a:xfrm>
+            <a:off x="8402117" y="5166360"/>
+            <a:ext cx="2966618" cy="731520"/>
+          </a:xfrm>
+          <a:prstGeom prst="rect">
+            <a:avLst/>
+          </a:prstGeom>
+          <a:noFill/>
+          <a:ln/>
+        </p:spPr>
+        <p:txBody>
+          <a:bodyPr wrap="square" lIns="0" tIns="0" rIns="0" bIns="0" rtlCol="0" anchor="b"/>
+          <a:lstStyle/>
+          <a:p>
+            <a:pPr indent="0" marL="0">
+              <a:buNone/>
+            </a:pPr>
+            <a:r>
+              <a:rPr lang="en-US" sz="1400" b="1" dirty="0">
+                <a:solidFill>
+                  <a:schemeClr val="tx1"/>
+                </a:solidFill>
+              </a:rPr>
+              <a:t>Risk and Opportunity Manager</a:t>
+            </a:r>
+            <a:endParaRPr lang="en-US" sz="1400" dirty="0"/>
+          </a:p>
+          <a:p>
+            <a:pPr indent="0" marL="0">
+              <a:buNone/>
+            </a:pPr>
+            <a:r>
+              <a:rPr lang="en-US" sz="1200" dirty="0">
+                <a:solidFill>
+                  <a:schemeClr val="tx2"/>
+                </a:solidFill>
+              </a:rPr>
+              <a:t>Airbus Operations GmbH, Hamburg</a:t>
+            </a:r>
+            <a:endParaRPr lang="en-US" sz="1400" dirty="0"/>
+          </a:p>
+        </p:txBody>
+      </p:sp>
+    </p:spTree>
+  </p:cSld>
+  <p:clrMapOvr>
+    <a:masterClrMapping/>
+  </p:clrMapOvr>
+  <p:transition spd="med">
+    <p:fade/>
+  </p:transition>
+  <p:timing>
+    <p:tnLst>
+      <p:par>
+        <p:cTn id="1" dur="indefinite" restart="never" nodeType="tmRoot">
+          <p:childTnLst>
+            <p:seq concurrent="1" nextAc="seek">
+              <p:cTn id="2" dur="indefinite" nodeType="mainSeq">
+                <p:childTnLst>
+                  <p:par>
+                    <p:cTn id="46" fill="hold">
+                      <p:stCondLst>
+                        <p:cond delay="indefinite"/>
+                        <p:cond evt="onBegin" delay="0">
+                          <p:tn val="2"/>
+                        </p:cond>
+                      </p:stCondLst>
+                      <p:childTnLst>
+                        <p:par>
+                          <p:cTn id="6" fill="hold">
+                            <p:stCondLst>
+                              <p:cond delay="0"/>
+                            </p:stCondLst>
+                            <p:childTnLst>
+                              <p:par>
+                                <p:cTn id="3" presetID="10" presetClass="entr" presetSubtype="0" fill="hold" grpId="0" nodeType="afterEffect">
+                                  <p:stCondLst>
+                                    <p:cond delay="0"/>
+                                  </p:stCondLst>
+                                  <p:childTnLst>
+                                    <p:set>
+                                      <p:cBhvr>
+                                        <p:cTn id="4" dur="1" fill="hold">
+                                          <p:stCondLst>
+                                            <p:cond delay="0"/>
+                                          </p:stCondLst>
+                                        </p:cTn>
+                                        <p:tgtEl>
+                                          <p:spTgt spid="4"/>
+                                        </p:tgtEl>
+                                        <p:attrNameLst>
+                                          <p:attrName>style.visibility</p:attrName>
+                                        </p:attrNameLst>
+                                      </p:cBhvr>
+                                      <p:to>
+                                        <p:strVal val="visible"/>
+                                      </p:to>
+                                    </p:set>
+                                    <p:animEffect transition="in" filter="fade">
+                                      <p:cBhvr>
+                                        <p:cTn id="5" dur="450"/>
+                                        <p:tgtEl>
+                                          <p:spTgt spid="4"/>
+                                        </p:tgtEl>
+                                      </p:cBhvr>
+                                    </p:animEffect>
+                                  </p:childTnLst>
+                                </p:cTn>
+                              </p:par>
+                            </p:childTnLst>
+                          </p:cTn>
+                        </p:par>
+                        <p:par>
+                          <p:cTn id="19" fill="hold">
+                            <p:stCondLst>
+                              <p:cond delay="600"/>
+                            </p:stCondLst>
+                            <p:childTnLst>
+                              <p:par>
+                                <p:cTn id="7" presetID="10" presetClass="entr" presetSubtype="0" fill="hold" grpId="0" nodeType="afterEffect">
+                                  <p:stCondLst>
+                                    <p:cond delay="0"/>
+                                  </p:stCondLst>
+                                  <p:childTnLst>
+                                    <p:set>
+                                      <p:cBhvr>
+                                        <p:cTn id="8" dur="1" fill="hold">
+                                          <p:stCondLst>
+                                            <p:cond delay="0"/>
+                                          </p:stCondLst>
+                                        </p:cTn>
+                                        <p:tgtEl>
+                                          <p:spTgt spid="5"/>
+                                        </p:tgtEl>
+                                        <p:attrNameLst>
+                                          <p:attrName>style.visibility</p:attrName>
+                                        </p:attrNameLst>
+                                      </p:cBhvr>
+                                      <p:to>
+                                        <p:strVal val="visible"/>
+                                      </p:to>
+                                    </p:set>
+                                    <p:animEffect transition="in" filter="fade">
+                                      <p:cBhvr>
+                                        <p:cTn id="9" dur="450"/>
+                                        <p:tgtEl>
+                                          <p:spTgt spid="5"/>
+                                        </p:tgtEl>
+                                      </p:cBhvr>
+                                    </p:animEffect>
+                                  </p:childTnLst>
+                                </p:cTn>
+                              </p:par>
+                              <p:par>
+                                <p:cTn id="10" presetID="10" presetClass="entr" presetSubtype="0" fill="hold" grpId="0" nodeType="withEffect">
+                                  <p:stCondLst>
+                                    <p:cond delay="0"/>
+                                  </p:stCondLst>
+                                  <p:childTnLst>
+                                    <p:set>
+                                      <p:cBhvr>
+                                        <p:cTn id="11" dur="1" fill="hold">
+                                          <p:stCondLst>
+                                            <p:cond delay="0"/>
+                                          </p:stCondLst>
+                                        </p:cTn>
+                                        <p:tgtEl>
+                                          <p:spTgt spid="6"/>
+                                        </p:tgtEl>
+                                        <p:attrNameLst>
+                                          <p:attrName>style.visibility</p:attrName>
+                                        </p:attrNameLst>
+                                      </p:cBhvr>
+                                      <p:to>
+                                        <p:strVal val="visible"/>
+                                      </p:to>
+                                    </p:set>
+                                    <p:animEffect transition="in" filter="fade">
+                                      <p:cBhvr>
+                                        <p:cTn id="12" dur="450"/>
+                                        <p:tgtEl>
+                                          <p:spTgt spid="6"/>
+                                        </p:tgtEl>
+                                      </p:cBhvr>
+                                    </p:animEffect>
+                                  </p:childTnLst>
+                                </p:cTn>
+                              </p:par>
+                              <p:par>
+                                <p:cTn id="13" presetID="10" presetClass="entr" presetSubtype="0" fill="hold" grpId="0" nodeType="withEffect">
+                                  <p:stCondLst>
+                                    <p:cond delay="0"/>
+                                  </p:stCondLst>
+                                  <p:childTnLst>
+                                    <p:set>
+                                      <p:cBhvr>
+                                        <p:cTn id="14" dur="1" fill="hold">
+                                          <p:stCondLst>
+                                            <p:cond delay="0"/>
+                                          </p:stCondLst>
+                                        </p:cTn>
+                                        <p:tgtEl>
+                                          <p:spTgt spid="7"/>
+                                        </p:tgtEl>
+                                        <p:attrNameLst>
+                                          <p:attrName>style.visibility</p:attrName>
+                                        </p:attrNameLst>
+                                      </p:cBhvr>
+                                      <p:to>
+                                        <p:strVal val="visible"/>
+                                      </p:to>
+                                    </p:set>
+                                    <p:animEffect transition="in" filter="fade">
+                                      <p:cBhvr>
+                                        <p:cTn id="15" dur="450"/>
+                                        <p:tgtEl>
+                                          <p:spTgt spid="7"/>
+                                        </p:tgtEl>
+                                      </p:cBhvr>
+                                    </p:animEffect>
+                                  </p:childTnLst>
+                                </p:cTn>
+                              </p:par>
+                              <p:par>
+                                <p:cTn id="16" presetID="10" presetClass="entr" presetSubtype="0" fill="hold" grpId="0" nodeType="withEffect">
+                                  <p:stCondLst>
+                                    <p:cond delay="0"/>
+                                  </p:stCondLst>
+                                  <p:childTnLst>
+                                    <p:set>
+                                      <p:cBhvr>
+                                        <p:cTn id="17" dur="1" fill="hold">
+                                          <p:stCondLst>
+                                            <p:cond delay="0"/>
+                                          </p:stCondLst>
+                                        </p:cTn>
+                                        <p:tgtEl>
+                                          <p:spTgt spid="8"/>
+                                        </p:tgtEl>
+                                        <p:attrNameLst>
+                                          <p:attrName>style.visibility</p:attrName>
+                                        </p:attrNameLst>
+                                      </p:cBhvr>
+                                      <p:to>
+                                        <p:strVal val="visible"/>
+                                      </p:to>
+                                    </p:set>
+                                    <p:animEffect transition="in" filter="fade">
+                                      <p:cBhvr>
+                                        <p:cTn id="18" dur="450"/>
+                                        <p:tgtEl>
+                                          <p:spTgt spid="8"/>
+                                        </p:tgtEl>
+                                      </p:cBhvr>
+                                    </p:animEffect>
+                                  </p:childTnLst>
+                                </p:cTn>
+                              </p:par>
+                            </p:childTnLst>
+                          </p:cTn>
+                        </p:par>
+                        <p:par>
+                          <p:cTn id="32" fill="hold">
+                            <p:stCondLst>
+                              <p:cond delay="1200"/>
+                            </p:stCondLst>
+                            <p:childTnLst>
+                              <p:par>
+                                <p:cTn id="20" presetID="10" presetClass="entr" presetSubtype="0" fill="hold" grpId="0" nodeType="afterEffect">
+                                  <p:stCondLst>
+                                    <p:cond delay="0"/>
+                                  </p:stCondLst>
+                                  <p:childTnLst>
+                                    <p:set>
+                                      <p:cBhvr>
+                                        <p:cTn id="21" dur="1" fill="hold">
+                                          <p:stCondLst>
+                                            <p:cond delay="0"/>
+                                          </p:stCondLst>
+                                        </p:cTn>
+                                        <p:tgtEl>
+                                          <p:spTgt spid="9"/>
+                                        </p:tgtEl>
+                                        <p:attrNameLst>
+                                          <p:attrName>style.visibility</p:attrName>
+                                        </p:attrNameLst>
+                                      </p:cBhvr>
+                                      <p:to>
+                                        <p:strVal val="visible"/>
+                                      </p:to>
+                                    </p:set>
+                                    <p:animEffect transition="in" filter="fade">
+                                      <p:cBhvr>
+                                        <p:cTn id="22" dur="450"/>
+                                        <p:tgtEl>
+                                          <p:spTgt spid="9"/>
+                                        </p:tgtEl>
+                                      </p:cBhvr>
+                                    </p:animEffect>
+                                  </p:childTnLst>
+                                </p:cTn>
+                              </p:par>
+                              <p:par>
+                                <p:cTn id="23" presetID="10" presetClass="entr" presetSubtype="0" fill="hold" grpId="0" nodeType="withEffect">
+                                  <p:stCondLst>
+                                    <p:cond delay="0"/>
+                                  </p:stCondLst>
+                                  <p:childTnLst>
+                                    <p:set>
+                                      <p:cBhvr>
+                                        <p:cTn id="24" dur="1" fill="hold">
+                                          <p:stCondLst>
+                                            <p:cond delay="0"/>
+                                          </p:stCondLst>
+                                        </p:cTn>
+                                        <p:tgtEl>
+                                          <p:spTgt spid="10"/>
+                                        </p:tgtEl>
+                                        <p:attrNameLst>
+                                          <p:attrName>style.visibility</p:attrName>
+                                        </p:attrNameLst>
+                                      </p:cBhvr>
+                                      <p:to>
+                                        <p:strVal val="visible"/>
+                                      </p:to>
+                                    </p:set>
+                                    <p:animEffect transition="in" filter="fade">
+                                      <p:cBhvr>
+                                        <p:cTn id="25" dur="450"/>
+                                        <p:tgtEl>
+                                          <p:spTgt spid="10"/>
+                                        </p:tgtEl>
+                                      </p:cBhvr>
+                                    </p:animEffect>
+                                  </p:childTnLst>
+                                </p:cTn>
+                              </p:par>
+                              <p:par>
+                                <p:cTn id="26" presetID="10" presetClass="entr" presetSubtype="0" fill="hold" grpId="0" nodeType="withEffect">
+                                  <p:stCondLst>
+                                    <p:cond delay="0"/>
+                                  </p:stCondLst>
+                                  <p:childTnLst>
+                                    <p:set>
+                                      <p:cBhvr>
+                                        <p:cTn id="27" dur="1" fill="hold">
+                                          <p:stCondLst>
+                                            <p:cond delay="0"/>
+                                          </p:stCondLst>
+                                        </p:cTn>
+                                        <p:tgtEl>
+                                          <p:spTgt spid="11"/>
+                                        </p:tgtEl>
+                                        <p:attrNameLst>
+                                          <p:attrName>style.visibility</p:attrName>
+                                        </p:attrNameLst>
+                                      </p:cBhvr>
+                                      <p:to>
+                                        <p:strVal val="visible"/>
+                                      </p:to>
+                                    </p:set>
+                                    <p:animEffect transition="in" filter="fade">
+                                      <p:cBhvr>
+                                        <p:cTn id="28" dur="450"/>
+                                        <p:tgtEl>
+                                          <p:spTgt spid="11"/>
+                                        </p:tgtEl>
+                                      </p:cBhvr>
+                                    </p:animEffect>
+                                  </p:childTnLst>
+                                </p:cTn>
+                              </p:par>
+                              <p:par>
+                                <p:cTn id="29" presetID="10" presetClass="entr" presetSubtype="0" fill="hold" grpId="0" nodeType="withEffect">
+                                  <p:stCondLst>
+                                    <p:cond delay="0"/>
+                                  </p:stCondLst>
+                                  <p:childTnLst>
+                                    <p:set>
+                                      <p:cBhvr>
+                                        <p:cTn id="30" dur="1" fill="hold">
+                                          <p:stCondLst>
+                                            <p:cond delay="0"/>
+                                          </p:stCondLst>
+                                        </p:cTn>
+                                        <p:tgtEl>
+                                          <p:spTgt spid="12"/>
+                                        </p:tgtEl>
+                                        <p:attrNameLst>
+                                          <p:attrName>style.visibility</p:attrName>
+                                        </p:attrNameLst>
+                                      </p:cBhvr>
+                                      <p:to>
+                                        <p:strVal val="visible"/>
+                                      </p:to>
+                                    </p:set>
+                                    <p:animEffect transition="in" filter="fade">
+                                      <p:cBhvr>
+                                        <p:cTn id="31" dur="450"/>
+                                        <p:tgtEl>
+                                          <p:spTgt spid="12"/>
+                                        </p:tgtEl>
+                                      </p:cBhvr>
+                                    </p:animEffect>
+                                  </p:childTnLst>
+                                </p:cTn>
+                              </p:par>
+                            </p:childTnLst>
+                          </p:cTn>
+                        </p:par>
+                        <p:par>
+                          <p:cTn id="45" fill="hold">
+                            <p:stCondLst>
+                              <p:cond delay="1800"/>
+                            </p:stCondLst>
+                            <p:childTnLst>
+                              <p:par>
+                                <p:cTn id="33" presetID="10" presetClass="entr" presetSubtype="0" fill="hold" grpId="0" nodeType="afterEffect">
+                                  <p:stCondLst>
+                                    <p:cond delay="0"/>
+                                  </p:stCondLst>
+                                  <p:childTnLst>
+                                    <p:set>
+                                      <p:cBhvr>
+                                        <p:cTn id="34" dur="1" fill="hold">
+                                          <p:stCondLst>
+                                            <p:cond delay="0"/>
+                                          </p:stCondLst>
+                                        </p:cTn>
+                                        <p:tgtEl>
+                                          <p:spTgt spid="13"/>
+                                        </p:tgtEl>
+                                        <p:attrNameLst>
+                                          <p:attrName>style.visibility</p:attrName>
+                                        </p:attrNameLst>
+                                      </p:cBhvr>
+                                      <p:to>
+                                        <p:strVal val="visible"/>
+                                      </p:to>
+                                    </p:set>
+                                    <p:animEffect transition="in" filter="fade">
+                                      <p:cBhvr>
+                                        <p:cTn id="35" dur="450"/>
+                                        <p:tgtEl>
+                                          <p:spTgt spid="13"/>
+                                        </p:tgtEl>
+                                      </p:cBhvr>
+                                    </p:animEffect>
+                                  </p:childTnLst>
+                                </p:cTn>
+                              </p:par>
+                              <p:par>
+                                <p:cTn id="36" presetID="10" presetClass="entr" presetSubtype="0" fill="hold" grpId="0" nodeType="withEffect">
+                                  <p:stCondLst>
+                                    <p:cond delay="0"/>
+                                  </p:stCondLst>
+                                  <p:childTnLst>
+                                    <p:set>
+                                      <p:cBhvr>
+                                        <p:cTn id="37" dur="1" fill="hold">
+                                          <p:stCondLst>
+                                            <p:cond delay="0"/>
+                                          </p:stCondLst>
+                                        </p:cTn>
+                                        <p:tgtEl>
+                                          <p:spTgt spid="14"/>
+                                        </p:tgtEl>
+                                        <p:attrNameLst>
+                                          <p:attrName>style.visibility</p:attrName>
+                                        </p:attrNameLst>
+                                      </p:cBhvr>
+                                      <p:to>
+                                        <p:strVal val="visible"/>
+                                      </p:to>
+                                    </p:set>
+                                    <p:animEffect transition="in" filter="fade">
+                                      <p:cBhvr>
+                                        <p:cTn id="38" dur="450"/>
+                                        <p:tgtEl>
+                                          <p:spTgt spid="14"/>
+                                        </p:tgtEl>
+                                      </p:cBhvr>
+                                    </p:animEffect>
+                                  </p:childTnLst>
+                                </p:cTn>
+                              </p:par>
+                              <p:par>
+                                <p:cTn id="39" presetID="10" presetClass="entr" presetSubtype="0" fill="hold" grpId="0" nodeType="withEffect">
+                                  <p:stCondLst>
+                                    <p:cond delay="0"/>
+                                  </p:stCondLst>
+                                  <p:childTnLst>
+                                    <p:set>
+                                      <p:cBhvr>
+                                        <p:cTn id="40" dur="1" fill="hold">
+                                          <p:stCondLst>
+                                            <p:cond delay="0"/>
+                                          </p:stCondLst>
+                                        </p:cTn>
+                                        <p:tgtEl>
+                                          <p:spTgt spid="15"/>
+                                        </p:tgtEl>
+                                        <p:attrNameLst>
+                                          <p:attrName>style.visibility</p:attrName>
+                                        </p:attrNameLst>
+                                      </p:cBhvr>
+                                      <p:to>
+                                        <p:strVal val="visible"/>
+                                      </p:to>
+                                    </p:set>
+                                    <p:animEffect transition="in" filter="fade">
+                                      <p:cBhvr>
+                                        <p:cTn id="41" dur="450"/>
+                                        <p:tgtEl>
+                                          <p:spTgt spid="15"/>
+                                        </p:tgtEl>
+                                      </p:cBhvr>
+                                    </p:animEffect>
+                                  </p:childTnLst>
+                                </p:cTn>
+                              </p:par>
+                              <p:par>
+                                <p:cTn id="42" presetID="10" presetClass="entr" presetSubtype="0" fill="hold" grpId="0" nodeType="withEffect">
+                                  <p:stCondLst>
+                                    <p:cond delay="0"/>
+                                  </p:stCondLst>
+                                  <p:childTnLst>
+                                    <p:set>
+                                      <p:cBhvr>
+                                        <p:cTn id="43" dur="1" fill="hold">
+                                          <p:stCondLst>
+                                            <p:cond delay="0"/>
+                                          </p:stCondLst>
+                                        </p:cTn>
+                                        <p:tgtEl>
+                                          <p:spTgt spid="16"/>
+                                        </p:tgtEl>
+                                        <p:attrNameLst>
+                                          <p:attrName>style.visibility</p:attrName>
+                                        </p:attrNameLst>
+                                      </p:cBhvr>
+                                      <p:to>
+                                        <p:strVal val="visible"/>
+                                      </p:to>
+                                    </p:set>
+                                    <p:animEffect transition="in" filter="fade">
+                                      <p:cBhvr>
+                                        <p:cTn id="44" dur="450"/>
+                                        <p:tgtEl>
+                                          <p:spTgt spid="16"/>
+                                        </p:tgtEl>
+                                      </p:cBhvr>
+                                    </p:animEffect>
+                                  </p:childTnLst>
+                                </p:cTn>
+                              </p:par>
+                            </p:childTnLst>
+                          </p:cTn>
+                        </p:par>
+                      </p:childTnLst>
+                    </p:cTn>
+                  </p:par>
+                </p:childTnLst>
+              </p:cTn>
+              <p:prevCondLst>
+                <p:cond evt="onPrev" delay="0">
+                  <p:tgtEl>
+                    <p:sldTgt/>
+                  </p:tgtEl>
+                </p:cond>
+              </p:prevCondLst>
+              <p:nextCondLst>
+                <p:cond evt="onNext" delay="0">
+                  <p:tgtEl>
+                    <p:sldTgt/>
+                  </p:tgtEl>
+                </p:cond>
+              </p:nextCondLst>
+            </p:seq>
+          </p:childTnLst>
+        </p:cTn>
+      </p:par>
+    </p:tnLst>
+    <p:bldLst>
+      <p:bldP spid="4" grpId="0" animBg="1"/>
+      <p:bldP spid="5" grpId="0" animBg="1"/>
+      <p:bldP spid="6" grpId="0" animBg="1"/>
+      <p:bldP spid="7" grpId="0" animBg="1"/>
+      <p:bldP spid="8" grpId="0" animBg="1"/>
+      <p:bldP spid="9" grpId="0" animBg="1"/>
+      <p:bldP spid="10" grpId="0" animBg="1"/>
+      <p:bldP spid="11" grpId="0" animBg="1"/>
+      <p:bldP spid="12" grpId="0" animBg="1"/>
+      <p:bldP spid="13" grpId="0" animBg="1"/>
+      <p:bldP spid="14" grpId="0" animBg="1"/>
+      <p:bldP spid="15" grpId="0" animBg="1"/>
+      <p:bldP spid="16" grpId="0" animBg="1"/>
+    </p:bldLst>
+  </p:timing>
+</p:sld>
+</file>
+
+<file path=ppt/slides/slide7.xml><?xml version="1.0" encoding="utf-8"?>
+<p:sld xmlns:a="http://schemas.openxmlformats.org/drawingml/2006/main" xmlns:r="http://schemas.openxmlformats.org/officeDocument/2006/relationships" xmlns:p="http://schemas.openxmlformats.org/presentationml/2006/main">
+  <p:cSld name="Slide 7">
+    <p:spTree>
+      <p:nvGrpSpPr>
+        <p:cNvPr id="1" name=""/>
+        <p:cNvGrpSpPr/>
+        <p:nvPr/>
+      </p:nvGrpSpPr>
+      <p:grpSpPr>
+        <a:xfrm>
+          <a:off x="0" y="0"/>
+          <a:ext cx="0" cy="0"/>
+          <a:chOff x="0" y="0"/>
+          <a:chExt cx="0" cy="0"/>
+        </a:xfrm>
+      </p:grpSpPr>
+      <p:sp>
+        <p:nvSpPr>
+          <p:cNvPr id="2" name="criterion"/>
+          <p:cNvSpPr txBox="1"/>
+          <p:nvPr/>
+        </p:nvSpPr>
+        <p:spPr>
+          <a:xfrm>
+            <a:off x="548640" y="201168"/>
+            <a:ext cx="5486400" cy="256032"/>
+          </a:xfrm>
+          <a:prstGeom prst="rect">
+            <a:avLst/>
+          </a:prstGeom>
+          <a:noFill/>
+          <a:ln/>
+        </p:spPr>
+        <p:txBody>
+          <a:bodyPr wrap="square" lIns="0" tIns="0" rIns="0" bIns="0" rtlCol="0" anchor="t"/>
+          <a:lstStyle/>
+          <a:p>
+            <a:pPr indent="0" marL="0">
+              <a:buNone/>
+            </a:pPr>
+            <a:r>
+              <a:rPr lang="en-US" sz="1100" b="1" spc="200" kern="0" dirty="0">
+                <a:solidFill>
+                  <a:schemeClr val="accent3"/>
+                </a:solidFill>
+              </a:rPr>
               <a:t>STRATEGIC FIT · TEAMWORK</a:t>
             </a:r>
             <a:endParaRPr lang="en-US" sz="1100" dirty="0"/>
@@ -10958,9 +12166,9 @@
 </p:sld>
 </file>
 
-<file path=ppt/slides/slide7.xml><?xml version="1.0" encoding="utf-8"?>
+<file path=ppt/slides/slide8.xml><?xml version="1.0" encoding="utf-8"?>
 <p:sld xmlns:a="http://schemas.openxmlformats.org/drawingml/2006/main" xmlns:r="http://schemas.openxmlformats.org/officeDocument/2006/relationships" xmlns:p="http://schemas.openxmlformats.org/presentationml/2006/main">
-  <p:cSld name="Slide 7">
+  <p:cSld name="Slide 8">
     <p:spTree>
       <p:nvGrpSpPr>
         <p:cNvPr id="1" name=""/>

</xml_diff>

<commit_message>
Fix chart x-axis labels (single-level categories) and use full month names
Co-Authored-By: Claude Opus 5.5 <noreply@anthropic.com>
Claude-Session: https://claude.ai/code/session_01HdxEbeqqWM97gKbcNqpjAq
</commit_message>
<xml_diff>
--- a/erm-migration/docs/ERM-Migration-Jury-Pitch-v2.pptx
+++ b/erm-migration/docs/ERM-Migration-Jury-Pitch-v2.pptx
@@ -116,23 +116,23 @@
   <p:extLst>
     <p:ext uri="{521415D9-36F7-43E2-AB2F-B90AF26B5E84}">
       <p14:sectionLst xmlns:p14="http://schemas.microsoft.com/office/powerpoint/2010/main">
-        <p14:section name="Answer" id="{c385cd09-5aae-0743-b1e1-68604ea84a34}">
+        <p14:section name="Answer" id="{fda03e4a-3f96-8360-bd6f-f92ba84f0605}">
           <p14:sldIdLst>
             <p14:sldId id="256"/>
           </p14:sldIdLst>
         </p14:section>
-        <p14:section name="Situation" id="{95ebc8af-8776-54ca-2e21-6222fb639e25}">
+        <p14:section name="Situation" id="{f52de3ac-c474-4628-57a5-51383a92ad35}">
           <p14:sldIdLst>
             <p14:sldId id="257"/>
             <p14:sldId id="258"/>
           </p14:sldIdLst>
         </p14:section>
-        <p14:section name="Complication" id="{39c00a09-d578-d945-fa40-f1d12ac59cab}">
+        <p14:section name="Complication" id="{b16f54f8-ce23-098b-13d7-4a10786f83b2}">
           <p14:sldIdLst>
             <p14:sldId id="259"/>
           </p14:sldIdLst>
         </p14:section>
-        <p14:section name="Answer and proof" id="{8514d95d-486b-6719-0466-aa8db855070c}">
+        <p14:section name="Answer and proof" id="{1d9add3e-d333-dacf-12f0-602acda0b6b0}">
           <p14:sldIdLst>
             <p14:sldId id="260"/>
             <p14:sldId id="261"/>
@@ -140,7 +140,7 @@
             <p14:sldId id="263"/>
           </p14:sldIdLst>
         </p14:section>
-        <p14:section name="Fit and scale" id="{1b799534-7ed1-edee-4cad-ecb7f364ec18}">
+        <p14:section name="Fit and scale" id="{91e6f10a-2647-2004-55d4-3f1ebe629cc1}">
           <p14:sldIdLst>
             <p14:sldId id="264"/>
             <p14:sldId id="265"/>
@@ -235,83 +235,81 @@
             </c:spPr>
           </c:marker>
           <c:cat>
-            <c:multiLvlStrRef>
+            <c:strRef>
               <c:f>Sheet1!$A$2:$A$24</c:f>
-              <c:multiLvlStrCache>
+              <c:strCache>
                 <c:ptCount val="23"/>
-                <c:lvl>
-                  <c:pt idx="0">
-                    <c:v>Aug 24</c:v>
-                  </c:pt>
-                  <c:pt idx="1">
-                    <c:v>Sep 24</c:v>
-                  </c:pt>
-                  <c:pt idx="2">
-                    <c:v>Oct 24</c:v>
-                  </c:pt>
-                  <c:pt idx="3">
-                    <c:v>Nov 24</c:v>
-                  </c:pt>
-                  <c:pt idx="4">
-                    <c:v>Dec 24</c:v>
-                  </c:pt>
-                  <c:pt idx="5">
-                    <c:v>Jan 25</c:v>
-                  </c:pt>
-                  <c:pt idx="6">
-                    <c:v>Feb 25</c:v>
-                  </c:pt>
-                  <c:pt idx="7">
-                    <c:v>Mar 25</c:v>
-                  </c:pt>
-                  <c:pt idx="8">
-                    <c:v>Apr 25</c:v>
-                  </c:pt>
-                  <c:pt idx="9">
-                    <c:v>May 25</c:v>
-                  </c:pt>
-                  <c:pt idx="10">
-                    <c:v>Jun 25</c:v>
-                  </c:pt>
-                  <c:pt idx="11">
-                    <c:v>Jul 25</c:v>
-                  </c:pt>
-                  <c:pt idx="12">
-                    <c:v>Aug 25</c:v>
-                  </c:pt>
-                  <c:pt idx="13">
-                    <c:v>Sep 25</c:v>
-                  </c:pt>
-                  <c:pt idx="14">
-                    <c:v>Oct 25</c:v>
-                  </c:pt>
-                  <c:pt idx="15">
-                    <c:v>Nov 25</c:v>
-                  </c:pt>
-                  <c:pt idx="16">
-                    <c:v>Dec 25</c:v>
-                  </c:pt>
-                  <c:pt idx="17">
-                    <c:v>Jan 26</c:v>
-                  </c:pt>
-                  <c:pt idx="18">
-                    <c:v>Feb 26</c:v>
-                  </c:pt>
-                  <c:pt idx="19">
-                    <c:v>Mar 26</c:v>
-                  </c:pt>
-                  <c:pt idx="20">
-                    <c:v>Apr 26</c:v>
-                  </c:pt>
-                  <c:pt idx="21">
-                    <c:v>May 26</c:v>
-                  </c:pt>
-                  <c:pt idx="22">
-                    <c:v>Jun 26</c:v>
-                  </c:pt>
-                </c:lvl>
-              </c:multiLvlStrCache>
-            </c:multiLvlStrRef>
+                <c:pt idx="0">
+                  <c:v>Aug 2024</c:v>
+                </c:pt>
+                <c:pt idx="1">
+                  <c:v>Sep 2024</c:v>
+                </c:pt>
+                <c:pt idx="2">
+                  <c:v>Oct 2024</c:v>
+                </c:pt>
+                <c:pt idx="3">
+                  <c:v>Nov 2024</c:v>
+                </c:pt>
+                <c:pt idx="4">
+                  <c:v>Dec 2024</c:v>
+                </c:pt>
+                <c:pt idx="5">
+                  <c:v>Jan 2025</c:v>
+                </c:pt>
+                <c:pt idx="6">
+                  <c:v>Feb 2025</c:v>
+                </c:pt>
+                <c:pt idx="7">
+                  <c:v>Mar 2025</c:v>
+                </c:pt>
+                <c:pt idx="8">
+                  <c:v>Apr 2025</c:v>
+                </c:pt>
+                <c:pt idx="9">
+                  <c:v>May 2025</c:v>
+                </c:pt>
+                <c:pt idx="10">
+                  <c:v>Jun 2025</c:v>
+                </c:pt>
+                <c:pt idx="11">
+                  <c:v>Jul 2025</c:v>
+                </c:pt>
+                <c:pt idx="12">
+                  <c:v>Aug 2025</c:v>
+                </c:pt>
+                <c:pt idx="13">
+                  <c:v>Sep 2025</c:v>
+                </c:pt>
+                <c:pt idx="14">
+                  <c:v>Oct 2025</c:v>
+                </c:pt>
+                <c:pt idx="15">
+                  <c:v>Nov 2025</c:v>
+                </c:pt>
+                <c:pt idx="16">
+                  <c:v>Dec 2025</c:v>
+                </c:pt>
+                <c:pt idx="17">
+                  <c:v>Jan 2026</c:v>
+                </c:pt>
+                <c:pt idx="18">
+                  <c:v>Feb 2026</c:v>
+                </c:pt>
+                <c:pt idx="19">
+                  <c:v>Mar 2026</c:v>
+                </c:pt>
+                <c:pt idx="20">
+                  <c:v>Apr 2026</c:v>
+                </c:pt>
+                <c:pt idx="21">
+                  <c:v>May 2026</c:v>
+                </c:pt>
+                <c:pt idx="22">
+                  <c:v>Jun 2026</c:v>
+                </c:pt>
+              </c:strCache>
+            </c:strRef>
           </c:cat>
           <c:val>
             <c:numRef>
@@ -461,7 +459,7 @@
         <c:crosses val="autoZero"/>
         <c:auto val="1"/>
         <c:lblAlgn val="ctr"/>
-        <c:noMultiLvlLbl val="1"/>
+        <c:noMultiLvlLbl val="0"/>
         <c:tickLblSkip val="2"/>
       </c:catAx>
       <c:valAx>
@@ -628,35 +626,33 @@
             <c:showLeaderLines val="0"/>
           </c:dLbls>
           <c:cat>
-            <c:multiLvlStrRef>
+            <c:strRef>
               <c:f>Sheet1!$A$2:$A$8</c:f>
-              <c:multiLvlStrCache>
+              <c:strCache>
                 <c:ptCount val="7"/>
-                <c:lvl>
-                  <c:pt idx="0">
-                    <c:v>B</c:v>
-                  </c:pt>
-                  <c:pt idx="1">
-                    <c:v>O</c:v>
-                  </c:pt>
-                  <c:pt idx="2">
-                    <c:v>P</c:v>
-                  </c:pt>
-                  <c:pt idx="3">
-                    <c:v>A</c:v>
-                  </c:pt>
-                  <c:pt idx="4">
-                    <c:v>L</c:v>
-                  </c:pt>
-                  <c:pt idx="5">
-                    <c:v>S</c:v>
-                  </c:pt>
-                  <c:pt idx="6">
-                    <c:v>K</c:v>
-                  </c:pt>
-                </c:lvl>
-              </c:multiLvlStrCache>
-            </c:multiLvlStrRef>
+                <c:pt idx="0">
+                  <c:v>B</c:v>
+                </c:pt>
+                <c:pt idx="1">
+                  <c:v>O</c:v>
+                </c:pt>
+                <c:pt idx="2">
+                  <c:v>P</c:v>
+                </c:pt>
+                <c:pt idx="3">
+                  <c:v>A</c:v>
+                </c:pt>
+                <c:pt idx="4">
+                  <c:v>L</c:v>
+                </c:pt>
+                <c:pt idx="5">
+                  <c:v>S</c:v>
+                </c:pt>
+                <c:pt idx="6">
+                  <c:v>K</c:v>
+                </c:pt>
+              </c:strCache>
+            </c:strRef>
           </c:cat>
           <c:val>
             <c:numRef>
@@ -758,7 +754,7 @@
         <c:crosses val="autoZero"/>
         <c:auto val="1"/>
         <c:lblAlgn val="ctr"/>
-        <c:noMultiLvlLbl val="1"/>
+        <c:noMultiLvlLbl val="0"/>
       </c:catAx>
       <c:valAx>
         <c:axId val="2094734552"/>

</xml_diff>

<commit_message>
Pitch wording: describe ERM as rebuilt and ready for go-live, not live
Co-Authored-By: Claude Opus 5.5 <noreply@anthropic.com>
Claude-Session: https://claude.ai/code/session_01HdxEbeqqWM97gKbcNqpjAq
</commit_message>
<xml_diff>
--- a/erm-migration/docs/ERM-Migration-Jury-Pitch-v2.pptx
+++ b/erm-migration/docs/ERM-Migration-Jury-Pitch-v2.pptx
@@ -116,23 +116,23 @@
   <p:extLst>
     <p:ext uri="{521415D9-36F7-43E2-AB2F-B90AF26B5E84}">
       <p14:sectionLst xmlns:p14="http://schemas.microsoft.com/office/powerpoint/2010/main">
-        <p14:section name="Answer" id="{fda03e4a-3f96-8360-bd6f-f92ba84f0605}">
+        <p14:section name="Answer" id="{f1ad123f-59fa-df52-e342-f52d3c00139c}">
           <p14:sldIdLst>
             <p14:sldId id="256"/>
           </p14:sldIdLst>
         </p14:section>
-        <p14:section name="Situation" id="{f52de3ac-c474-4628-57a5-51383a92ad35}">
+        <p14:section name="Situation" id="{efd43752-60d8-0d94-bea3-313a34134923}">
           <p14:sldIdLst>
             <p14:sldId id="257"/>
             <p14:sldId id="258"/>
           </p14:sldIdLst>
         </p14:section>
-        <p14:section name="Complication" id="{b16f54f8-ce23-098b-13d7-4a10786f83b2}">
+        <p14:section name="Complication" id="{e18ae36d-58df-8c69-2537-7404e5b8f964}">
           <p14:sldIdLst>
             <p14:sldId id="259"/>
           </p14:sldIdLst>
         </p14:section>
-        <p14:section name="Answer and proof" id="{1d9add3e-d333-dacf-12f0-602acda0b6b0}">
+        <p14:section name="Answer and proof" id="{423d1203-13d2-e588-8bf3-bfb20ac4841d}">
           <p14:sldIdLst>
             <p14:sldId id="260"/>
             <p14:sldId id="261"/>
@@ -140,7 +140,7 @@
             <p14:sldId id="263"/>
           </p14:sldIdLst>
         </p14:section>
-        <p14:section name="Fit and scale" id="{91e6f10a-2647-2004-55d4-3f1ebe629cc1}">
+        <p14:section name="Fit and scale" id="{bf09b144-95f8-cb24-ba5f-28c70428d7d5}">
           <p14:sldIdLst>
             <p14:sldId id="264"/>
             <p14:sldId id="265"/>
@@ -1844,7 +1844,7 @@
           <a:p>
             <a:r>
               <a:rPr lang="en-US" dirty="0"/>
-              <a:t>Building new features is now easy, and that keeps paying back. During the same PI we shipped 11 features Slate never had: permissions-only edit for locked versions, a web address per tab, a searchable dashboard switcher, a criticality-differs filter, category and impact-category filters, a fourth one-pager layout with custom slots, resizable columns saved per board, report classification and cover toggle, slideshow mode, one-pager selection shortcuts, and showing risks by ID or title. One change added app-wide notifications and automatic list refresh across 11 files. 25 MB of Slate configuration became about 0.8 MB of typed source in 75 files. In Slate, a feature meant wiring widgets, events, variables and functions across 8 exports, with no documentation; in React it is one typed component and one OSDK call, and pack-project.ts gives AI the whole app as context. On recurring cost: using a common rule of thumb that maintenance costs about 20% of build effort a year, a Slate-equivalent app would need about 68 person-days a year, around $21,000 at $38.50 an hour. Assuming modular, typed, documented code halves that, we save around $10,000 a year. Say clearly these are estimates.</a:t>
+              <a:t>Building new features is now easy, and that keeps paying back. During the same PI we built 11 features Slate never had: permissions-only edit for locked versions, a web address per tab, a searchable dashboard switcher, a criticality-differs filter, category and impact-category filters, a fourth one-pager layout with custom slots, resizable columns saved per board, report classification and cover toggle, slideshow mode, one-pager selection shortcuts, and showing risks by ID or title. One change added app-wide notifications and automatic list refresh across 11 files. 25 MB of Slate configuration became about 0.8 MB of typed source in 75 files. In Slate, a feature meant wiring widgets, events, variables and functions across 8 exports, with no documentation; in React it is one typed component and one OSDK call, and pack-project.ts gives AI the whole app as context. On recurring cost: using a common rule of thumb that maintenance costs about 20% of build effort a year, a Slate-equivalent app would need about 68 person-days a year, around $21,000 at $38.50 an hour. Assuming modular, typed, documented code halves that, we save around $10,000 a year. Say clearly these are estimates.</a:t>
             </a:r>
             <a:endParaRPr lang="en-US" dirty="0"/>
           </a:p>
@@ -11902,7 +11902,7 @@
                   <a:schemeClr val="tx2"/>
                 </a:solidFill>
               </a:rPr>
-              <a:t>new features Slate never had, shipped in the same PI</a:t>
+              <a:t>new features Slate never had, built in the same PI</a:t>
             </a:r>
             <a:endParaRPr lang="en-US" sz="1300" dirty="0"/>
           </a:p>

</xml_diff>

<commit_message>
Pitch wording: fixes delivered together
Co-Authored-By: Claude Opus 5.5 <noreply@anthropic.com>
Claude-Session: https://claude.ai/code/session_01HdxEbeqqWM97gKbcNqpjAq
</commit_message>
<xml_diff>
--- a/erm-migration/docs/ERM-Migration-Jury-Pitch-v2.pptx
+++ b/erm-migration/docs/ERM-Migration-Jury-Pitch-v2.pptx
@@ -116,23 +116,23 @@
   <p:extLst>
     <p:ext uri="{521415D9-36F7-43E2-AB2F-B90AF26B5E84}">
       <p14:sectionLst xmlns:p14="http://schemas.microsoft.com/office/powerpoint/2010/main">
-        <p14:section name="Answer" id="{f1ad123f-59fa-df52-e342-f52d3c00139c}">
+        <p14:section name="Answer" id="{242bce6e-a51a-bf1f-8701-741678d46096}">
           <p14:sldIdLst>
             <p14:sldId id="256"/>
           </p14:sldIdLst>
         </p14:section>
-        <p14:section name="Situation" id="{efd43752-60d8-0d94-bea3-313a34134923}">
+        <p14:section name="Situation" id="{42295f35-de75-9b23-6a0c-9aed217a550f}">
           <p14:sldIdLst>
             <p14:sldId id="257"/>
             <p14:sldId id="258"/>
           </p14:sldIdLst>
         </p14:section>
-        <p14:section name="Complication" id="{e18ae36d-58df-8c69-2537-7404e5b8f964}">
+        <p14:section name="Complication" id="{26165cdc-ed54-cfc4-2505-c2eb797c0fd6}">
           <p14:sldIdLst>
             <p14:sldId id="259"/>
           </p14:sldIdLst>
         </p14:section>
-        <p14:section name="Answer and proof" id="{423d1203-13d2-e588-8bf3-bfb20ac4841d}">
+        <p14:section name="Answer and proof" id="{8d8070da-3bf3-efb1-9c01-2ea946c92f6b}">
           <p14:sldIdLst>
             <p14:sldId id="260"/>
             <p14:sldId id="261"/>
@@ -140,7 +140,7 @@
             <p14:sldId id="263"/>
           </p14:sldIdLst>
         </p14:section>
-        <p14:section name="Fit and scale" id="{bf09b144-95f8-cb24-ba5f-28c70428d7d5}">
+        <p14:section name="Fit and scale" id="{d1f7c71b-a55a-7b1d-34c8-cc82a35b33a1}">
           <p14:sldIdLst>
             <p14:sldId id="264"/>
             <p14:sldId id="265"/>
@@ -2020,7 +2020,7 @@
           <a:p>
             <a:r>
               <a:rPr lang="en-US" dirty="0"/>
-              <a:t>This slide shows strategic fit and teamwork; the flow builds one branch at a time. One: Leverage AI to solve business problems. The AI read all 8 Slate exports and the packed React code, recovered 105 features from an undocumented app and found 31 gaps. Two: Deliver on time, on cost, on quality. Two developers delivered it in one PI, about 76% less effort than a generic manual estimate. Three: Ensure our operational performance. ERM is a business system; every one of its 105 features was tracked for parity, and it is rebuilt on standard, maintainable React and OSDK code, ready to replace the legacy Slate configuration. Four: Grow digital acumen and competencies. pack-project.ts and the playbook mean other teams can repeat this, which builds AI-assisted engineering skills across the organisation. Finally the team strip: business users confirmed the feature catalogue, data and security owners kept the restricted-view access model intact, and backend and frontend fixes shipped together. Name the people and teams here.</a:t>
+              <a:t>This slide shows strategic fit and teamwork; the flow builds one branch at a time. One: Leverage AI to solve business problems. The AI read all 8 Slate exports and the packed React code, recovered 105 features from an undocumented app and found 31 gaps. Two: Deliver on time, on cost, on quality. Two developers delivered it in one PI, about 76% less effort than a generic manual estimate. Three: Ensure our operational performance. ERM is a business system; every one of its 105 features was tracked for parity, and it is rebuilt on standard, maintainable React and OSDK code, ready to replace the legacy Slate configuration. Four: Grow digital acumen and competencies. pack-project.ts and the playbook mean other teams can repeat this, which builds AI-assisted engineering skills across the organisation. Finally the team strip: business users confirmed the feature catalogue, data and security owners kept the restricted-view access model intact, and backend and frontend fixes delivered together. Name the people and teams here.</a:t>
             </a:r>
             <a:endParaRPr lang="en-US" dirty="0"/>
           </a:p>
@@ -15426,7 +15426,7 @@
                   <a:schemeClr val="tx1"/>
                 </a:solidFill>
               </a:rPr>
-              <a:t>Business users confirmed the feature catalogue · Data and security owners kept restricted views intact · Backend and frontend fixes shipped together</a:t>
+              <a:t>Business users confirmed the feature catalogue · Data and security owners kept restricted views intact · Backend and frontend fixes delivered together</a:t>
             </a:r>
             <a:endParaRPr lang="en-US" sz="1100" dirty="0"/>
           </a:p>

</xml_diff>

<commit_message>
v2 pitch: combine adoption and usage into one stakes slide
Co-Authored-By: Claude Opus 5.5 <noreply@anthropic.com>
Claude-Session: https://claude.ai/code/session_01HdxEbeqqWM97gKbcNqpjAq
</commit_message>
<xml_diff>
--- a/erm-migration/docs/ERM-Migration-Jury-Pitch-v2.pptx
+++ b/erm-migration/docs/ERM-Migration-Jury-Pitch-v2.pptx
@@ -13,10 +13,9 @@
     <p:sldId id="261" r:id="rId7"/>
     <p:sldId id="262" r:id="rId8"/>
     <p:sldId id="263" r:id="rId9"/>
-    <p:sldId id="264" r:id="rId10"/>
   </p:sldIdLst>
   <p:notesMasterIdLst>
-    <p:notesMasterId r:id="rId11"/>
+    <p:notesMasterId r:id="rId10"/>
   </p:notesMasterIdLst>
   <p:sldSz cx="12192000" cy="6858000"/>
   <p:notesSz cx="6858000" cy="12192000"/>
@@ -115,33 +114,32 @@
   <p:extLst>
     <p:ext uri="{521415D9-36F7-43E2-AB2F-B90AF26B5E84}">
       <p14:sectionLst xmlns:p14="http://schemas.microsoft.com/office/powerpoint/2010/main">
-        <p14:section name="Answer" id="{a9bd7520-df5c-b441-ac04-643b581bb624}">
+        <p14:section name="Answer" id="{0913389d-fe40-4b35-f775-02699813e442}">
           <p14:sldIdLst>
             <p14:sldId id="256"/>
           </p14:sldIdLst>
         </p14:section>
-        <p14:section name="Situation" id="{626ad569-38b7-a086-0428-dedeaa18c6dd}">
+        <p14:section name="Situation" id="{146a4fb3-8002-73a2-d75a-f0dde4e461f6}">
           <p14:sldIdLst>
             <p14:sldId id="257"/>
+          </p14:sldIdLst>
+        </p14:section>
+        <p14:section name="Complication" id="{d885f62a-c52e-d037-7740-af94192bdde2}">
+          <p14:sldIdLst>
             <p14:sldId id="258"/>
           </p14:sldIdLst>
         </p14:section>
-        <p14:section name="Complication" id="{135e0fbc-796b-89ca-23fa-51008eff29b9}">
+        <p14:section name="Answer and proof" id="{42e58e2e-fad3-005b-75d5-487b91187fdd}">
           <p14:sldIdLst>
             <p14:sldId id="259"/>
+            <p14:sldId id="260"/>
+            <p14:sldId id="261"/>
           </p14:sldIdLst>
         </p14:section>
-        <p14:section name="Answer and proof" id="{3d2c786e-a394-9368-cc4f-25351aac8de2}">
+        <p14:section name="Fit and scale" id="{2cc562e5-8b4b-126e-e637-732b1c97a085}">
           <p14:sldIdLst>
-            <p14:sldId id="260"/>
-            <p14:sldId id="261"/>
             <p14:sldId id="262"/>
-          </p14:sldIdLst>
-        </p14:section>
-        <p14:section name="Fit and scale" id="{adf4ed7d-499e-6ede-d1ed-72e87238a9ff}">
-          <p14:sldIdLst>
             <p14:sldId id="263"/>
-            <p14:sldId id="264"/>
           </p14:sldIdLst>
         </p14:section>
       </p14:sectionLst>
@@ -217,7 +215,7 @@
           </c:dLbls>
           <c:marker>
             <c:symbol val="circle"/>
-            <c:size val="5"/>
+            <c:size val="4"/>
             <c:spPr>
               <a:solidFill>
                 <a:srgbClr val="0085CA"/>
@@ -458,7 +456,7 @@
         <c:auto val="1"/>
         <c:lblAlgn val="ctr"/>
         <c:noMultiLvlLbl val="0"/>
-        <c:tickLblSkip val="2"/>
+        <c:tickLblSkip val="5"/>
       </c:catAx>
       <c:valAx>
         <c:axId val="2094734552"/>
@@ -480,35 +478,6 @@
             </a:ln>
           </c:spPr>
         </c:majorGridlines>
-        <c:title>
-          <c:tx>
-            <c:rich>
-              <a:bodyPr/>
-              <a:lstStyle/>
-              <a:p>
-                <a:pPr>
-                  <a:defRPr sz="1000" b="0" i="0" u="none" strike="noStrike">
-                    <a:solidFill>
-                      <a:srgbClr val="4A5568"/>
-                    </a:solidFill>
-                    <a:latin typeface="Arial"/>
-                  </a:defRPr>
-                </a:pPr>
-                <a:r>
-                  <a:rPr sz="1000" b="0" i="0" u="none" strike="noStrike">
-                    <a:solidFill>
-                      <a:srgbClr val="4A5568"/>
-                    </a:solidFill>
-                    <a:latin typeface="Arial"/>
-                  </a:rPr>
-                  <a:t>Unique users</a:t>
-                </a:r>
-              </a:p>
-            </c:rich>
-          </c:tx>
-          <c:layout/>
-          <c:overlay val="0"/>
-        </c:title>
         <c:numFmt formatCode="General" sourceLinked="0"/>
         <c:majorTickMark val="out"/>
         <c:minorTickMark val="none"/>
@@ -540,7 +509,7 @@
         <c:crossAx val="2094734554"/>
         <c:crosses val="autoZero"/>
         <c:crossBetween val="between"/>
-        <c:majorUnit val="50"/>
+        <c:majorUnit val="100"/>
       </c:valAx>
       <c:spPr>
         <a:noFill/>
@@ -606,7 +575,7 @@
               <a:lstStyle/>
               <a:p>
                 <a:pPr>
-                  <a:defRPr b="0" i="0" strike="noStrike" sz="1100" u="none">
+                  <a:defRPr b="0" i="0" strike="noStrike" sz="1000" u="none">
                     <a:solidFill>
                       <a:srgbClr val="00205B"/>
                     </a:solidFill>
@@ -690,7 +659,7 @@
             <a:lstStyle/>
             <a:p>
               <a:pPr>
-                <a:defRPr b="0" i="0" strike="noStrike" sz="1100" u="none">
+                <a:defRPr b="0" i="0" strike="noStrike" sz="1000" u="none">
                   <a:solidFill>
                     <a:srgbClr val="00205B"/>
                   </a:solidFill>
@@ -707,7 +676,7 @@
           <c:showBubbleSize val="0"/>
           <c:showLeaderLines val="0"/>
         </c:dLbls>
-        <c:gapWidth val="40"/>
+        <c:gapWidth val="45"/>
         <c:overlap val="0"/>
         <c:axId val="2094734554"/>
         <c:axId val="2094734552"/>
@@ -738,7 +707,7 @@
           <a:lstStyle/>
           <a:p>
             <a:pPr>
-              <a:defRPr sz="1200" b="0" i="0" u="none" strike="noStrike">
+              <a:defRPr sz="1100" b="0" i="0" u="none" strike="noStrike">
                 <a:solidFill>
                   <a:srgbClr val="4A5568"/>
                 </a:solidFill>
@@ -761,19 +730,8 @@
           <c:max val="400"/>
           <c:min val="0"/>
         </c:scaling>
-        <c:delete val="0"/>
+        <c:delete val="1"/>
         <c:axPos val="l"/>
-        <c:majorGridlines>
-          <c:spPr>
-            <a:ln w="9525" cap="flat">
-              <a:solidFill>
-                <a:srgbClr val="DCE3EE"/>
-              </a:solidFill>
-              <a:prstDash val="solid"/>
-              <a:round/>
-            </a:ln>
-          </c:spPr>
-        </c:majorGridlines>
         <c:numFmt formatCode="General" sourceLinked="0"/>
         <c:majorTickMark val="out"/>
         <c:minorTickMark val="none"/>
@@ -792,11 +750,11 @@
           <a:lstStyle/>
           <a:p>
             <a:pPr>
-              <a:defRPr sz="1000" b="0" i="0" u="none" strike="noStrike">
-                <a:solidFill>
-                  <a:srgbClr val="4A5568"/>
-                </a:solidFill>
-                <a:latin typeface="+mn-lt"/>
+              <a:defRPr sz="1200" b="0" i="0" u="none" strike="noStrike">
+                <a:solidFill>
+                  <a:srgbClr val="000000"/>
+                </a:solidFill>
+                <a:latin typeface="Arial"/>
               </a:defRPr>
             </a:pPr>
             <a:endParaRPr lang="en-US"/>
@@ -805,7 +763,6 @@
         <c:crossAx val="2094734554"/>
         <c:crosses val="autoZero"/>
         <c:crossBetween val="between"/>
-        <c:majorUnit val="100"/>
       </c:valAx>
       <c:spPr>
         <a:noFill/>
@@ -1314,7 +1271,7 @@
           <a:p>
             <a:r>
               <a:rPr lang="en-US" dirty="0"/>
-              <a:t>Set the stakes. ERM is where Airbus risk managers manage ARM risks and opportunities: custom dashboards, live editing, trend following, governed quarterly releases and sharing across divisions. 892 people have used it; more than 320 are active in a peak month; more than 1,600 dashboards exist and more than 10 are updated every day. Usage has grown steadily since launch. So whatever we did, we could not break it.</a:t>
+              <a:t>Set the stakes in one view. ERM is where Airbus risk managers manage ARM risks and opportunities: custom dashboards, live editing, trend following, governed quarterly releases and sharing across divisions. 892 people have used it; more than 320 are active in a peak month; more than 1,600 dashboards exist and more than 10 are updated every day. Monthly users have grown steadily since launch, to around 300 in 2026. It is not one team's tool: the largest organisation, siglum B, has around 345 users, then O, P, A, L, S and K and about a dozen smaller ones; by site, Blagnac and Hamburg lead, with users in the UK, Spain, Canada and India. Chart values are read from the usage dashboard, so treat them as approximate. Whatever we did, we could not break it.</a:t>
             </a:r>
             <a:endParaRPr lang="en-US" dirty="0"/>
           </a:p>
@@ -1402,7 +1359,7 @@
           <a:p>
             <a:r>
               <a:rPr lang="en-US" dirty="0"/>
-              <a:t>ERM is not one team's tool. By organisation, the largest group, siglum B, has around 345 users, followed by O, P, A, L, S and K, and about a dozen smaller organisations. By site, Blagnac and Hamburg lead, with users in the UK, Spain, Canada and India too. The values on the organisation chart are read from the usage dashboard, so treat them as approximate. A migration that broke ERM would hit risk reporting across the company.</a:t>
+              <a:t>Here is the complication. In Slate, one simple action triggers a cascade of widgets, events, actions and variables, so any change risks breaking something unrelated, and every tab switch recalculates large variable trees. And nothing was documented: 8 exports, about 25 MB of configuration. Let the animation play: the app breaks into a shell and 7 modules, and 105 features come out of it. Then ask the question on screen: how do two developers move 105 hidden features in one PI without breaking risk reporting?</a:t>
             </a:r>
             <a:endParaRPr lang="en-US" dirty="0"/>
           </a:p>
@@ -1490,7 +1447,7 @@
           <a:p>
             <a:r>
               <a:rPr lang="en-US" dirty="0"/>
-              <a:t>Here is the complication. In Slate, one simple action triggers a cascade of widgets, events, actions and variables, so any change risks breaking something unrelated, and every tab switch recalculates large variable trees. And nothing was documented: 8 exports, about 25 MB of configuration. Let the animation play: the app breaks into a shell and 7 modules, and 105 features come out of it. Then ask the question on screen: how do two developers move 105 hidden features in one PI without breaking risk reporting?</a:t>
+              <a:t>This is the innovation. A usual migration starts with interviews and clicking through screens, reads code in fragments, finds gaps late in testing and documents afterwards, if at all. We flipped it. The AI read all 8 Slate exports and catalogued 105 features. Our script, pack-project.ts, packs the whole React app into one dated file, so the AI sees every component and OSDK call at once. The AI then checked every feature against the code and found 31 gaps; people reviewed, fixed and deployed. The diagrams were produced alongside the work. AI drafts, people verify. If time allows, show the live app here for 60 seconds.</a:t>
             </a:r>
             <a:endParaRPr lang="en-US" dirty="0"/>
           </a:p>
@@ -1578,7 +1535,7 @@
           <a:p>
             <a:r>
               <a:rPr lang="en-US" dirty="0"/>
-              <a:t>This is the innovation. A usual migration starts with interviews and clicking through screens, reads code in fragments, finds gaps late in testing and documents afterwards, if at all. We flipped it. The AI read all 8 Slate exports and catalogued 105 features. Our script, pack-project.ts, packs the whole React app into one dated file, so the AI sees every component and OSDK call at once. The AI then checked every feature against the code and found 31 gaps; people reviewed, fixed and deployed. The diagrams were produced alongside the work. AI drafts, people verify. If time allows, show the live app here for 60 seconds.</a:t>
+              <a:t>The proof, hard facts first. One PI. Two developers. All 105 features carried over and checked. The AI review found and prioritised 31 gaps, including 7 security and data-integrity issues, all caught in review; the dashboard sharing-access fix is deployed. We also built 11 features Slate never had: permissions-only edit for locked versions, a web address per tab, a searchable dashboard switcher, a criticality-differs filter, category and impact-category filters, a fourth one-pager layout with custom slots, resizable columns saved per board, report classification and cover toggle, slideshow mode, one-pager selection shortcuts, and showing risks by ID or title. Documentation went from nothing to 10 documents. Building features is now easy: in Slate a feature meant wiring widgets, events and variables across 8 exports with no documentation; in React it is one typed component and one OSDK call, pack-project.ts gives AI the whole app, and 25 MB of Slate configuration became 0.8 MB of typed code. On cost: against a generic estimate of about 340 person-days, roughly 17 sprints for two developers, we used 4 sprints, about 76% less effort; at $38.50 per developer hour that is roughly $105,000 against $25,000, around $80,000 saved. Maintenance: with a rule of thumb of 20% of build effort a year, a Slate-equivalent app needs about $21,000 a year; assuming modular, typed, documented code halves that, we save around $10,000 a year. Say clearly these are estimates. Security and data-integrity findings caught in review: stored cross-site scripting from unsanitised rich HTML in 5 places; permission checks that matched e-mails by substring instead of exactly; sharing payload arrays misaligned with the wrong fields; settings JSON overwritten whole from a stale copy; reports printing shared risks the legacy app left out; no 100-risk print cap, a legacy cybersecurity limit; and children edits in the risk drawer silently discarded.</a:t>
             </a:r>
             <a:endParaRPr lang="en-US" dirty="0"/>
           </a:p>
@@ -1666,7 +1623,7 @@
           <a:p>
             <a:r>
               <a:rPr lang="en-US" dirty="0"/>
-              <a:t>The proof, hard facts first. One PI. Two developers. All 105 features carried over and checked. The AI review found and prioritised 31 gaps, including 7 security and data-integrity issues, all caught in review; the dashboard sharing-access fix is deployed. We also built 11 features Slate never had: permissions-only edit for locked versions, a web address per tab, a searchable dashboard switcher, a criticality-differs filter, category and impact-category filters, a fourth one-pager layout with custom slots, resizable columns saved per board, report classification and cover toggle, slideshow mode, one-pager selection shortcuts, and showing risks by ID or title. Documentation went from nothing to 10 documents. Building features is now easy: in Slate a feature meant wiring widgets, events and variables across 8 exports with no documentation; in React it is one typed component and one OSDK call, pack-project.ts gives AI the whole app, and 25 MB of Slate configuration became 0.8 MB of typed code. On cost: against a generic estimate of about 340 person-days, roughly 17 sprints for two developers, we used 4 sprints, about 76% less effort; at $38.50 per developer hour that is roughly $105,000 against $25,000, around $80,000 saved. Maintenance: with a rule of thumb of 20% of build effort a year, a Slate-equivalent app needs about $21,000 a year; assuming modular, typed, documented code halves that, we save around $10,000 a year. Say clearly these are estimates. Security and data-integrity findings caught in review: stored cross-site scripting from unsanitised rich HTML in 5 places; permission checks that matched e-mails by substring instead of exactly; sharing payload arrays misaligned with the wrong fields; settings JSON overwritten whole from a stale copy; reports printing shared risks the legacy app left out; no 100-risk print cap, a legacy cybersecurity limit; and children edits in the risk drawer silently discarded.</a:t>
+              <a:t>Let the business speak. These are testimonials sent by ERM stakeholders in September 2026 about the team and the ERM tool. A member of the ERM centre of competence: teamwork with the business and strong IT skills turned an idea into a user-friendly industrial solution, ERM reports are now generated in a much more automated way, and the user interface and performance have significantly improved. An ERM stakeholder: the ERM dashboard is a tremendous addition to the ERM toolset, and more and more users prepare and run their risk and opportunity reviews with it. A Risk and Opportunity Manager in Hamburg: new features made navigation easier and gave a much clearer view of R&amp;O data, and issues were fixed quickly. Make clear these speak about the team and the tool overall.</a:t>
             </a:r>
             <a:endParaRPr lang="en-US" dirty="0"/>
           </a:p>
@@ -1754,7 +1711,7 @@
           <a:p>
             <a:r>
               <a:rPr lang="en-US" dirty="0"/>
-              <a:t>Let the business speak. These are testimonials sent by ERM stakeholders in September 2026 about the team and the ERM tool. A member of the ERM centre of competence: teamwork with the business and strong IT skills turned an idea into a user-friendly industrial solution, ERM reports are now generated in a much more automated way, and the user interface and performance have significantly improved. An ERM stakeholder: the ERM dashboard is a tremendous addition to the ERM toolset, and more and more users prepare and run their risk and opportunity reviews with it. A Risk and Opportunity Manager in Hamburg: new features made navigation easier and gave a much clearer view of R&amp;O data, and issues were fixed quickly. Make clear these speak about the team and the tool overall.</a:t>
+              <a:t>This slide shows strategic fit and teamwork; the flow builds one branch at a time. One: Leverage AI to solve business problems. The AI read all 8 Slate exports and the packed React code, recovered 105 features from an undocumented app and found 31 gaps. Two: Deliver on time, on cost, on quality. Two developers delivered it in one PI, about 76% less effort than a generic manual estimate. Three: Ensure our operational performance. ERM is a business system; every one of its 105 features was tracked for parity, and it is rebuilt on standard, maintainable React and OSDK code, ready to replace the legacy Slate configuration. Four: Grow digital acumen and competencies. pack-project.ts and the playbook mean other teams can repeat this, which builds AI-assisted engineering skills across the organisation. Finally the team strip: business users confirmed the feature catalogue, data and security owners kept the restricted-view access model intact, and backend and frontend fixes delivered together. Name the people and teams here.</a:t>
             </a:r>
             <a:endParaRPr lang="en-US" dirty="0"/>
           </a:p>
@@ -1842,7 +1799,7 @@
           <a:p>
             <a:r>
               <a:rPr lang="en-US" dirty="0"/>
-              <a:t>This slide shows strategic fit and teamwork; the flow builds one branch at a time. One: Leverage AI to solve business problems. The AI read all 8 Slate exports and the packed React code, recovered 105 features from an undocumented app and found 31 gaps. Two: Deliver on time, on cost, on quality. Two developers delivered it in one PI, about 76% less effort than a generic manual estimate. Three: Ensure our operational performance. ERM is a business system; every one of its 105 features was tracked for parity, and it is rebuilt on standard, maintainable React and OSDK code, ready to replace the legacy Slate configuration. Four: Grow digital acumen and competencies. pack-project.ts and the playbook mean other teams can repeat this, which builds AI-assisted engineering skills across the organisation. Finally the team strip: business users confirmed the feature catalogue, data and security owners kept the restricted-view access model intact, and backend and frontend fixes delivered together. Name the people and teams here.</a:t>
+              <a:t>Close on scale and make an ask. The method is five steps: pack, extract, compare, fix, document. The pieces are ready to reuse: pack-project.ts, the comparison template and the diagram formats. It fits other Slate apps and any low-code tool with little documentation. Then the ask: endorse the playbook as a DevX pattern. We have already aligned with [Architect] to propose it at the architecture sync, so functions beyond DMS can use it; name the first team outside DMS if you have one. End on the line on screen and invite questions.</a:t>
             </a:r>
             <a:endParaRPr lang="en-US" dirty="0"/>
           </a:p>
@@ -1866,94 +1823,6 @@
             <a:fld id="{F7021451-1387-4CA6-816F-3879F97B5CBC}" type="slidenum">
               <a:rPr lang="en-US"/>
               <a:t>8</a:t>
-            </a:fld>
-            <a:endParaRPr lang="en-US"/>
-          </a:p>
-        </p:txBody>
-      </p:sp>
-    </p:spTree>
-    <p:extLst>
-      <p:ext uri="{BB962C8B-B14F-4D97-AF65-F5344CB8AC3E}">
-        <p14:creationId xmlns:p14="http://schemas.microsoft.com/office/powerpoint/2010/main" val="1024086991"/>
-      </p:ext>
-    </p:extLst>
-  </p:cSld>
-  <p:clrMapOvr>
-    <a:masterClrMapping/>
-  </p:clrMapOvr>
-</p:notes>
-</file>
-
-<file path=ppt/notesSlides/notesSlide9.xml><?xml version="1.0" encoding="utf-8"?>
-<p:notes xmlns:a="http://schemas.openxmlformats.org/drawingml/2006/main" xmlns:r="http://schemas.openxmlformats.org/officeDocument/2006/relationships" xmlns:p="http://schemas.openxmlformats.org/presentationml/2006/main">
-  <p:cSld>
-    <p:spTree>
-      <p:nvGrpSpPr>
-        <p:cNvPr id="1" name=""/>
-        <p:cNvGrpSpPr/>
-        <p:nvPr/>
-      </p:nvGrpSpPr>
-      <p:grpSpPr>
-        <a:xfrm>
-          <a:off x="0" y="0"/>
-          <a:ext cx="0" cy="0"/>
-          <a:chOff x="0" y="0"/>
-          <a:chExt cx="0" cy="0"/>
-        </a:xfrm>
-      </p:grpSpPr>
-      <p:sp>
-        <p:nvSpPr>
-          <p:cNvPr id="2" name="Slide Image Placeholder 1"/>
-          <p:cNvSpPr>
-            <a:spLocks noGrp="1" noRot="1" noChangeAspect="1"/>
-          </p:cNvSpPr>
-          <p:nvPr>
-            <p:ph type="sldImg"/>
-          </p:nvPr>
-        </p:nvSpPr>
-        <p:spPr/>
-      </p:sp>
-      <p:sp>
-        <p:nvSpPr>
-          <p:cNvPr id="3" name="Notes Placeholder 2"/>
-          <p:cNvSpPr>
-            <a:spLocks noGrp="1"/>
-          </p:cNvSpPr>
-          <p:nvPr>
-            <p:ph type="body" idx="1"/>
-          </p:nvPr>
-        </p:nvSpPr>
-        <p:spPr/>
-        <p:txBody>
-          <a:bodyPr/>
-          <a:lstStyle/>
-          <a:p>
-            <a:r>
-              <a:rPr lang="en-US" dirty="0"/>
-              <a:t>Close on scale and make an ask. The method is five steps: pack, extract, compare, fix, document. The pieces are ready to reuse: pack-project.ts, the comparison template and the diagram formats. It fits other Slate apps and any low-code tool with little documentation. Then the ask: endorse the playbook as a DevX pattern. We have already aligned with [Architect] to propose it at the architecture sync, so functions beyond DMS can use it; name the first team outside DMS if you have one. End on the line on screen and invite questions.</a:t>
-            </a:r>
-            <a:endParaRPr lang="en-US" dirty="0"/>
-          </a:p>
-        </p:txBody>
-      </p:sp>
-      <p:sp>
-        <p:nvSpPr>
-          <p:cNvPr id="4" name="Slide Number Placeholder 3"/>
-          <p:cNvSpPr>
-            <a:spLocks noGrp="1"/>
-          </p:cNvSpPr>
-          <p:nvPr>
-            <p:ph type="sldNum" sz="quarter" idx="10"/>
-          </p:nvPr>
-        </p:nvSpPr>
-        <p:spPr/>
-        <p:txBody>
-          <a:bodyPr/>
-          <a:lstStyle/>
-          <a:p>
-            <a:fld id="{F7021451-1387-4CA6-816F-3879F97B5CBC}" type="slidenum">
-              <a:rPr lang="en-US"/>
-              <a:t>9</a:t>
             </a:fld>
             <a:endParaRPr lang="en-US"/>
           </a:p>
@@ -2901,7 +2770,7 @@
                   <a:schemeClr val="tx1"/>
                 </a:solidFill>
               </a:rPr>
-              <a:t>ERM is business-critical for 892 risk managers</a:t>
+              <a:t>ERM is business-critical for 892 users</a:t>
             </a:r>
             <a:endParaRPr lang="en-US" sz="3600" dirty="0"/>
           </a:p>
@@ -2909,18 +2778,54 @@
       </p:sp>
       <p:sp>
         <p:nvSpPr>
-          <p:cNvPr id="4" name="kpi-0-card"/>
+          <p:cNvPr id="4" name="kpi-sub"/>
+          <p:cNvSpPr txBox="1"/>
+          <p:nvPr/>
+        </p:nvSpPr>
+        <p:spPr>
+          <a:xfrm>
+            <a:off x="548640" y="1115568"/>
+            <a:ext cx="11094415" cy="320040"/>
+          </a:xfrm>
+          <a:prstGeom prst="rect">
+            <a:avLst/>
+          </a:prstGeom>
+          <a:noFill/>
+          <a:ln/>
+        </p:spPr>
+        <p:txBody>
+          <a:bodyPr wrap="square" lIns="0" tIns="0" rIns="0" bIns="0" rtlCol="0" anchor="t"/>
+          <a:lstStyle/>
+          <a:p>
+            <a:pPr indent="0" marL="0">
+              <a:buNone/>
+            </a:pPr>
+            <a:r>
+              <a:rPr lang="en-US" sz="1400" dirty="0">
+                <a:solidFill>
+                  <a:schemeClr val="tx2"/>
+                </a:solidFill>
+              </a:rPr>
+              <a:t>One place to manage ARM risks and opportunities: dashboards, live editing, trends, releases and sharing</a:t>
+            </a:r>
+            <a:endParaRPr lang="en-US" sz="1400" dirty="0"/>
+          </a:p>
+        </p:txBody>
+      </p:sp>
+      <p:sp>
+        <p:nvSpPr>
+          <p:cNvPr id="5" name="kpi-0-card"/>
           <p:cNvSpPr/>
           <p:nvPr/>
         </p:nvSpPr>
         <p:spPr>
           <a:xfrm>
-            <a:off x="548640" y="1371600"/>
-            <a:ext cx="2567864" cy="1417320"/>
+            <a:off x="548640" y="1536192"/>
+            <a:ext cx="2567864" cy="987552"/>
           </a:xfrm>
           <a:prstGeom prst="roundRect">
             <a:avLst>
-              <a:gd name="adj" fmla="val 7742"/>
+              <a:gd name="adj" fmla="val 11111"/>
             </a:avLst>
           </a:prstGeom>
           <a:solidFill>
@@ -2931,14 +2836,14 @@
       </p:sp>
       <p:sp>
         <p:nvSpPr>
-          <p:cNvPr id="5" name="kpi-0-label"/>
+          <p:cNvPr id="6" name="kpi-0-value"/>
           <p:cNvSpPr txBox="1"/>
           <p:nvPr/>
         </p:nvSpPr>
         <p:spPr>
           <a:xfrm>
-            <a:off x="749808" y="1481328"/>
-            <a:ext cx="2165528" cy="256032"/>
+            <a:off x="749808" y="1591056"/>
+            <a:ext cx="2165528" cy="502920"/>
           </a:xfrm>
           <a:prstGeom prst="rect">
             <a:avLst/>
@@ -2954,27 +2859,27 @@
               <a:buNone/>
             </a:pPr>
             <a:r>
-              <a:rPr lang="en-US" sz="1000" b="1" spc="100" kern="0" dirty="0">
-                <a:solidFill>
-                  <a:schemeClr val="accent5"/>
-                </a:solidFill>
-              </a:rPr>
-              <a:t>LIFETIME UNIQUE USERS</a:t>
-            </a:r>
-            <a:endParaRPr lang="en-US" sz="1000" dirty="0"/>
+              <a:rPr lang="en-US" sz="2800" b="1" dirty="0">
+                <a:solidFill>
+                  <a:schemeClr val="bg1"/>
+                </a:solidFill>
+              </a:rPr>
+              <a:t>892</a:t>
+            </a:r>
+            <a:endParaRPr lang="en-US" sz="2800" dirty="0"/>
           </a:p>
         </p:txBody>
       </p:sp>
       <p:sp>
         <p:nvSpPr>
-          <p:cNvPr id="6" name="kpi-0-value"/>
+          <p:cNvPr id="7" name="kpi-0-desc"/>
           <p:cNvSpPr txBox="1"/>
           <p:nvPr/>
         </p:nvSpPr>
         <p:spPr>
           <a:xfrm>
-            <a:off x="749808" y="1737360"/>
-            <a:ext cx="2165528" cy="594360"/>
+            <a:off x="749808" y="2103120"/>
+            <a:ext cx="2165528" cy="320040"/>
           </a:xfrm>
           <a:prstGeom prst="rect">
             <a:avLst/>
@@ -2990,27 +2895,49 @@
               <a:buNone/>
             </a:pPr>
             <a:r>
-              <a:rPr lang="en-US" sz="3400" b="1" dirty="0">
-                <a:solidFill>
-                  <a:schemeClr val="bg1"/>
-                </a:solidFill>
-              </a:rPr>
-              <a:t>892</a:t>
-            </a:r>
-            <a:endParaRPr lang="en-US" sz="3400" dirty="0"/>
+              <a:rPr lang="en-US" sz="1300" dirty="0">
+                <a:solidFill>
+                  <a:schemeClr val="accent5"/>
+                </a:solidFill>
+              </a:rPr>
+              <a:t>lifetime unique users</a:t>
+            </a:r>
+            <a:endParaRPr lang="en-US" sz="1300" dirty="0"/>
           </a:p>
         </p:txBody>
       </p:sp>
       <p:sp>
         <p:nvSpPr>
-          <p:cNvPr id="7" name="kpi-0-desc"/>
+          <p:cNvPr id="8" name="kpi-1-card"/>
+          <p:cNvSpPr/>
+          <p:nvPr/>
+        </p:nvSpPr>
+        <p:spPr>
+          <a:xfrm>
+            <a:off x="3390824" y="1536192"/>
+            <a:ext cx="2567864" cy="987552"/>
+          </a:xfrm>
+          <a:prstGeom prst="roundRect">
+            <a:avLst>
+              <a:gd name="adj" fmla="val 11111"/>
+            </a:avLst>
+          </a:prstGeom>
+          <a:solidFill>
+            <a:schemeClr val="bg1"/>
+          </a:solidFill>
+          <a:ln/>
+        </p:spPr>
+      </p:sp>
+      <p:sp>
+        <p:nvSpPr>
+          <p:cNvPr id="9" name="kpi-1-value"/>
           <p:cNvSpPr txBox="1"/>
           <p:nvPr/>
         </p:nvSpPr>
         <p:spPr>
           <a:xfrm>
-            <a:off x="749808" y="2331720"/>
-            <a:ext cx="2165528" cy="365760"/>
+            <a:off x="3591992" y="1591056"/>
+            <a:ext cx="2165528" cy="502920"/>
           </a:xfrm>
           <a:prstGeom prst="rect">
             <a:avLst/>
@@ -3026,31 +2953,67 @@
               <a:buNone/>
             </a:pPr>
             <a:r>
-              <a:rPr lang="en-US" sz="1200" dirty="0">
-                <a:solidFill>
-                  <a:schemeClr val="accent5"/>
-                </a:solidFill>
-              </a:rPr>
-              <a:t>Across engineering, programmes and operations</a:t>
-            </a:r>
-            <a:endParaRPr lang="en-US" sz="1200" dirty="0"/>
+              <a:rPr lang="en-US" sz="2800" b="1" dirty="0">
+                <a:solidFill>
+                  <a:schemeClr val="tx1"/>
+                </a:solidFill>
+              </a:rPr>
+              <a:t>320+</a:t>
+            </a:r>
+            <a:endParaRPr lang="en-US" sz="2800" dirty="0"/>
           </a:p>
         </p:txBody>
       </p:sp>
       <p:sp>
         <p:nvSpPr>
-          <p:cNvPr id="8" name="kpi-1-card"/>
+          <p:cNvPr id="10" name="kpi-1-desc"/>
+          <p:cNvSpPr txBox="1"/>
+          <p:nvPr/>
+        </p:nvSpPr>
+        <p:spPr>
+          <a:xfrm>
+            <a:off x="3591992" y="2103120"/>
+            <a:ext cx="2165528" cy="320040"/>
+          </a:xfrm>
+          <a:prstGeom prst="rect">
+            <a:avLst/>
+          </a:prstGeom>
+          <a:noFill/>
+          <a:ln/>
+        </p:spPr>
+        <p:txBody>
+          <a:bodyPr wrap="square" lIns="0" tIns="0" rIns="0" bIns="0" rtlCol="0" anchor="t"/>
+          <a:lstStyle/>
+          <a:p>
+            <a:pPr indent="0" marL="0">
+              <a:buNone/>
+            </a:pPr>
+            <a:r>
+              <a:rPr lang="en-US" sz="1300" dirty="0">
+                <a:solidFill>
+                  <a:schemeClr val="tx2"/>
+                </a:solidFill>
+              </a:rPr>
+              <a:t>active in a peak month</a:t>
+            </a:r>
+            <a:endParaRPr lang="en-US" sz="1300" dirty="0"/>
+          </a:p>
+        </p:txBody>
+      </p:sp>
+      <p:sp>
+        <p:nvSpPr>
+          <p:cNvPr id="11" name="kpi-2-card"/>
           <p:cNvSpPr/>
           <p:nvPr/>
         </p:nvSpPr>
         <p:spPr>
           <a:xfrm>
-            <a:off x="3390824" y="1371600"/>
-            <a:ext cx="2567864" cy="1417320"/>
+            <a:off x="6233008" y="1536192"/>
+            <a:ext cx="2567864" cy="987552"/>
           </a:xfrm>
           <a:prstGeom prst="roundRect">
             <a:avLst>
-              <a:gd name="adj" fmla="val 7742"/>
+              <a:gd name="adj" fmla="val 11111"/>
             </a:avLst>
           </a:prstGeom>
           <a:solidFill>
@@ -3061,14 +3024,14 @@
       </p:sp>
       <p:sp>
         <p:nvSpPr>
-          <p:cNvPr id="9" name="kpi-1-label"/>
+          <p:cNvPr id="12" name="kpi-2-value"/>
           <p:cNvSpPr txBox="1"/>
           <p:nvPr/>
         </p:nvSpPr>
         <p:spPr>
           <a:xfrm>
-            <a:off x="3591992" y="1481328"/>
-            <a:ext cx="2165528" cy="256032"/>
+            <a:off x="6434176" y="1591056"/>
+            <a:ext cx="2165528" cy="502920"/>
           </a:xfrm>
           <a:prstGeom prst="rect">
             <a:avLst/>
@@ -3084,27 +3047,27 @@
               <a:buNone/>
             </a:pPr>
             <a:r>
-              <a:rPr lang="en-US" sz="1000" b="1" spc="100" kern="0" dirty="0">
-                <a:solidFill>
-                  <a:schemeClr val="tx2"/>
-                </a:solidFill>
-              </a:rPr>
-              <a:t>MONTHLY ACTIVE PEAK</a:t>
-            </a:r>
-            <a:endParaRPr lang="en-US" sz="1000" dirty="0"/>
+              <a:rPr lang="en-US" sz="2800" b="1" dirty="0">
+                <a:solidFill>
+                  <a:schemeClr val="tx1"/>
+                </a:solidFill>
+              </a:rPr>
+              <a:t>1,600+</a:t>
+            </a:r>
+            <a:endParaRPr lang="en-US" sz="2800" dirty="0"/>
           </a:p>
         </p:txBody>
       </p:sp>
       <p:sp>
         <p:nvSpPr>
-          <p:cNvPr id="10" name="kpi-1-value"/>
+          <p:cNvPr id="13" name="kpi-2-desc"/>
           <p:cNvSpPr txBox="1"/>
           <p:nvPr/>
         </p:nvSpPr>
         <p:spPr>
           <a:xfrm>
-            <a:off x="3591992" y="1737360"/>
-            <a:ext cx="2165528" cy="594360"/>
+            <a:off x="6434176" y="2103120"/>
+            <a:ext cx="2165528" cy="320040"/>
           </a:xfrm>
           <a:prstGeom prst="rect">
             <a:avLst/>
@@ -3120,27 +3083,49 @@
               <a:buNone/>
             </a:pPr>
             <a:r>
-              <a:rPr lang="en-US" sz="3400" b="1" dirty="0">
-                <a:solidFill>
-                  <a:schemeClr val="tx1"/>
-                </a:solidFill>
-              </a:rPr>
-              <a:t>320+</a:t>
-            </a:r>
-            <a:endParaRPr lang="en-US" sz="3400" dirty="0"/>
+              <a:rPr lang="en-US" sz="1300" dirty="0">
+                <a:solidFill>
+                  <a:schemeClr val="tx2"/>
+                </a:solidFill>
+              </a:rPr>
+              <a:t>dashboards created</a:t>
+            </a:r>
+            <a:endParaRPr lang="en-US" sz="1300" dirty="0"/>
           </a:p>
         </p:txBody>
       </p:sp>
       <p:sp>
         <p:nvSpPr>
-          <p:cNvPr id="11" name="kpi-1-desc"/>
+          <p:cNvPr id="14" name="kpi-3-card"/>
+          <p:cNvSpPr/>
+          <p:nvPr/>
+        </p:nvSpPr>
+        <p:spPr>
+          <a:xfrm>
+            <a:off x="9075191" y="1536192"/>
+            <a:ext cx="2567864" cy="987552"/>
+          </a:xfrm>
+          <a:prstGeom prst="roundRect">
+            <a:avLst>
+              <a:gd name="adj" fmla="val 11111"/>
+            </a:avLst>
+          </a:prstGeom>
+          <a:solidFill>
+            <a:schemeClr val="bg1"/>
+          </a:solidFill>
+          <a:ln/>
+        </p:spPr>
+      </p:sp>
+      <p:sp>
+        <p:nvSpPr>
+          <p:cNvPr id="15" name="kpi-3-value"/>
           <p:cNvSpPr txBox="1"/>
           <p:nvPr/>
         </p:nvSpPr>
         <p:spPr>
           <a:xfrm>
-            <a:off x="3591992" y="2331720"/>
-            <a:ext cx="2165528" cy="365760"/>
+            <a:off x="9276359" y="1591056"/>
+            <a:ext cx="2165528" cy="502920"/>
           </a:xfrm>
           <a:prstGeom prst="rect">
             <a:avLst/>
@@ -3156,31 +3141,67 @@
               <a:buNone/>
             </a:pPr>
             <a:r>
-              <a:rPr lang="en-US" sz="1200" dirty="0">
+              <a:rPr lang="en-US" sz="2800" b="1" dirty="0">
+                <a:solidFill>
+                  <a:schemeClr val="tx1"/>
+                </a:solidFill>
+              </a:rPr>
+              <a:t>10+</a:t>
+            </a:r>
+            <a:endParaRPr lang="en-US" sz="2800" dirty="0"/>
+          </a:p>
+        </p:txBody>
+      </p:sp>
+      <p:sp>
+        <p:nvSpPr>
+          <p:cNvPr id="16" name="kpi-3-desc"/>
+          <p:cNvSpPr txBox="1"/>
+          <p:nvPr/>
+        </p:nvSpPr>
+        <p:spPr>
+          <a:xfrm>
+            <a:off x="9276359" y="2103120"/>
+            <a:ext cx="2165528" cy="320040"/>
+          </a:xfrm>
+          <a:prstGeom prst="rect">
+            <a:avLst/>
+          </a:prstGeom>
+          <a:noFill/>
+          <a:ln/>
+        </p:spPr>
+        <p:txBody>
+          <a:bodyPr wrap="square" lIns="0" tIns="0" rIns="0" bIns="0" rtlCol="0" anchor="t"/>
+          <a:lstStyle/>
+          <a:p>
+            <a:pPr indent="0" marL="0">
+              <a:buNone/>
+            </a:pPr>
+            <a:r>
+              <a:rPr lang="en-US" sz="1300" dirty="0">
                 <a:solidFill>
                   <a:schemeClr val="tx2"/>
                 </a:solidFill>
               </a:rPr>
-              <a:t>Active risk managers per reporting month</a:t>
-            </a:r>
-            <a:endParaRPr lang="en-US" sz="1200" dirty="0"/>
+              <a:t>updated every day</a:t>
+            </a:r>
+            <a:endParaRPr lang="en-US" sz="1300" dirty="0"/>
           </a:p>
         </p:txBody>
       </p:sp>
       <p:sp>
         <p:nvSpPr>
-          <p:cNvPr id="12" name="kpi-2-card"/>
+          <p:cNvPr id="17" name="trend-card"/>
           <p:cNvSpPr/>
           <p:nvPr/>
         </p:nvSpPr>
         <p:spPr>
           <a:xfrm>
-            <a:off x="6233008" y="1371600"/>
-            <a:ext cx="2567864" cy="1417320"/>
+            <a:off x="548640" y="2697480"/>
+            <a:ext cx="4572000" cy="3749040"/>
           </a:xfrm>
           <a:prstGeom prst="roundRect">
             <a:avLst>
-              <a:gd name="adj" fmla="val 7742"/>
+              <a:gd name="adj" fmla="val 2927"/>
             </a:avLst>
           </a:prstGeom>
           <a:solidFill>
@@ -3191,14 +3212,14 @@
       </p:sp>
       <p:sp>
         <p:nvSpPr>
-          <p:cNvPr id="13" name="kpi-2-label"/>
+          <p:cNvPr id="18" name="trend-title"/>
           <p:cNvSpPr txBox="1"/>
           <p:nvPr/>
         </p:nvSpPr>
         <p:spPr>
           <a:xfrm>
-            <a:off x="6434176" y="1481328"/>
-            <a:ext cx="2165528" cy="256032"/>
+            <a:off x="731520" y="2807208"/>
+            <a:ext cx="4206240" cy="256032"/>
           </a:xfrm>
           <a:prstGeom prst="rect">
             <a:avLst/>
@@ -3216,284 +3237,24 @@
             <a:r>
               <a:rPr lang="en-US" sz="1000" b="1" spc="100" kern="0" dirty="0">
                 <a:solidFill>
-                  <a:schemeClr val="tx2"/>
-                </a:solidFill>
-              </a:rPr>
-              <a:t>DASHBOARDS CREATED</a:t>
+                  <a:schemeClr val="tx1"/>
+                </a:solidFill>
+              </a:rPr>
+              <a:t>MONTHLY UNIQUE USERS</a:t>
             </a:r>
             <a:endParaRPr lang="en-US" sz="1000" dirty="0"/>
-          </a:p>
-        </p:txBody>
-      </p:sp>
-      <p:sp>
-        <p:nvSpPr>
-          <p:cNvPr id="14" name="kpi-2-value"/>
-          <p:cNvSpPr txBox="1"/>
-          <p:nvPr/>
-        </p:nvSpPr>
-        <p:spPr>
-          <a:xfrm>
-            <a:off x="6434176" y="1737360"/>
-            <a:ext cx="2165528" cy="594360"/>
-          </a:xfrm>
-          <a:prstGeom prst="rect">
-            <a:avLst/>
-          </a:prstGeom>
-          <a:noFill/>
-          <a:ln/>
-        </p:spPr>
-        <p:txBody>
-          <a:bodyPr wrap="square" lIns="0" tIns="0" rIns="0" bIns="0" rtlCol="0" anchor="t"/>
-          <a:lstStyle/>
-          <a:p>
-            <a:pPr indent="0" marL="0">
-              <a:buNone/>
-            </a:pPr>
-            <a:r>
-              <a:rPr lang="en-US" sz="3400" b="1" dirty="0">
-                <a:solidFill>
-                  <a:schemeClr val="tx1"/>
-                </a:solidFill>
-              </a:rPr>
-              <a:t>1,600+</a:t>
-            </a:r>
-            <a:endParaRPr lang="en-US" sz="3400" dirty="0"/>
-          </a:p>
-        </p:txBody>
-      </p:sp>
-      <p:sp>
-        <p:nvSpPr>
-          <p:cNvPr id="15" name="kpi-2-desc"/>
-          <p:cNvSpPr txBox="1"/>
-          <p:nvPr/>
-        </p:nvSpPr>
-        <p:spPr>
-          <a:xfrm>
-            <a:off x="6434176" y="2331720"/>
-            <a:ext cx="2165528" cy="365760"/>
-          </a:xfrm>
-          <a:prstGeom prst="rect">
-            <a:avLst/>
-          </a:prstGeom>
-          <a:noFill/>
-          <a:ln/>
-        </p:spPr>
-        <p:txBody>
-          <a:bodyPr wrap="square" lIns="0" tIns="0" rIns="0" bIns="0" rtlCol="0" anchor="t"/>
-          <a:lstStyle/>
-          <a:p>
-            <a:pPr indent="0" marL="0">
-              <a:buNone/>
-            </a:pPr>
-            <a:r>
-              <a:rPr lang="en-US" sz="1200" dirty="0">
-                <a:solidFill>
-                  <a:schemeClr val="tx2"/>
-                </a:solidFill>
-              </a:rPr>
-              <a:t>Custom dashboards created to date</a:t>
-            </a:r>
-            <a:endParaRPr lang="en-US" sz="1200" dirty="0"/>
-          </a:p>
-        </p:txBody>
-      </p:sp>
-      <p:sp>
-        <p:nvSpPr>
-          <p:cNvPr id="16" name="kpi-3-card"/>
-          <p:cNvSpPr/>
-          <p:nvPr/>
-        </p:nvSpPr>
-        <p:spPr>
-          <a:xfrm>
-            <a:off x="9075191" y="1371600"/>
-            <a:ext cx="2567864" cy="1417320"/>
-          </a:xfrm>
-          <a:prstGeom prst="roundRect">
-            <a:avLst>
-              <a:gd name="adj" fmla="val 7742"/>
-            </a:avLst>
-          </a:prstGeom>
-          <a:solidFill>
-            <a:schemeClr val="bg1"/>
-          </a:solidFill>
-          <a:ln/>
-        </p:spPr>
-      </p:sp>
-      <p:sp>
-        <p:nvSpPr>
-          <p:cNvPr id="17" name="kpi-3-label"/>
-          <p:cNvSpPr txBox="1"/>
-          <p:nvPr/>
-        </p:nvSpPr>
-        <p:spPr>
-          <a:xfrm>
-            <a:off x="9276359" y="1481328"/>
-            <a:ext cx="2165528" cy="256032"/>
-          </a:xfrm>
-          <a:prstGeom prst="rect">
-            <a:avLst/>
-          </a:prstGeom>
-          <a:noFill/>
-          <a:ln/>
-        </p:spPr>
-        <p:txBody>
-          <a:bodyPr wrap="square" lIns="0" tIns="0" rIns="0" bIns="0" rtlCol="0" anchor="t"/>
-          <a:lstStyle/>
-          <a:p>
-            <a:pPr indent="0" marL="0">
-              <a:buNone/>
-            </a:pPr>
-            <a:r>
-              <a:rPr lang="en-US" sz="1000" b="1" spc="100" kern="0" dirty="0">
-                <a:solidFill>
-                  <a:schemeClr val="tx2"/>
-                </a:solidFill>
-              </a:rPr>
-              <a:t>UPDATED DAILY</a:t>
-            </a:r>
-            <a:endParaRPr lang="en-US" sz="1000" dirty="0"/>
-          </a:p>
-        </p:txBody>
-      </p:sp>
-      <p:sp>
-        <p:nvSpPr>
-          <p:cNvPr id="18" name="kpi-3-value"/>
-          <p:cNvSpPr txBox="1"/>
-          <p:nvPr/>
-        </p:nvSpPr>
-        <p:spPr>
-          <a:xfrm>
-            <a:off x="9276359" y="1737360"/>
-            <a:ext cx="2165528" cy="594360"/>
-          </a:xfrm>
-          <a:prstGeom prst="rect">
-            <a:avLst/>
-          </a:prstGeom>
-          <a:noFill/>
-          <a:ln/>
-        </p:spPr>
-        <p:txBody>
-          <a:bodyPr wrap="square" lIns="0" tIns="0" rIns="0" bIns="0" rtlCol="0" anchor="t"/>
-          <a:lstStyle/>
-          <a:p>
-            <a:pPr indent="0" marL="0">
-              <a:buNone/>
-            </a:pPr>
-            <a:r>
-              <a:rPr lang="en-US" sz="3400" b="1" dirty="0">
-                <a:solidFill>
-                  <a:schemeClr val="tx1"/>
-                </a:solidFill>
-              </a:rPr>
-              <a:t>10+</a:t>
-            </a:r>
-            <a:endParaRPr lang="en-US" sz="3400" dirty="0"/>
-          </a:p>
-        </p:txBody>
-      </p:sp>
-      <p:sp>
-        <p:nvSpPr>
-          <p:cNvPr id="19" name="kpi-3-desc"/>
-          <p:cNvSpPr txBox="1"/>
-          <p:nvPr/>
-        </p:nvSpPr>
-        <p:spPr>
-          <a:xfrm>
-            <a:off x="9276359" y="2331720"/>
-            <a:ext cx="2165528" cy="365760"/>
-          </a:xfrm>
-          <a:prstGeom prst="rect">
-            <a:avLst/>
-          </a:prstGeom>
-          <a:noFill/>
-          <a:ln/>
-        </p:spPr>
-        <p:txBody>
-          <a:bodyPr wrap="square" lIns="0" tIns="0" rIns="0" bIns="0" rtlCol="0" anchor="t"/>
-          <a:lstStyle/>
-          <a:p>
-            <a:pPr indent="0" marL="0">
-              <a:buNone/>
-            </a:pPr>
-            <a:r>
-              <a:rPr lang="en-US" sz="1200" dirty="0">
-                <a:solidFill>
-                  <a:schemeClr val="tx2"/>
-                </a:solidFill>
-              </a:rPr>
-              <a:t>Maintained continuously by risk owners</a:t>
-            </a:r>
-            <a:endParaRPr lang="en-US" sz="1200" dirty="0"/>
-          </a:p>
-        </p:txBody>
-      </p:sp>
-      <p:sp>
-        <p:nvSpPr>
-          <p:cNvPr id="20" name="trend-card"/>
-          <p:cNvSpPr/>
-          <p:nvPr/>
-        </p:nvSpPr>
-        <p:spPr>
-          <a:xfrm>
-            <a:off x="548640" y="3017520"/>
-            <a:ext cx="6583680" cy="3429000"/>
-          </a:xfrm>
-          <a:prstGeom prst="roundRect">
-            <a:avLst>
-              <a:gd name="adj" fmla="val 3200"/>
-            </a:avLst>
-          </a:prstGeom>
-          <a:solidFill>
-            <a:schemeClr val="bg1"/>
-          </a:solidFill>
-          <a:ln/>
-        </p:spPr>
-      </p:sp>
-      <p:sp>
-        <p:nvSpPr>
-          <p:cNvPr id="21" name="trend-title"/>
-          <p:cNvSpPr txBox="1"/>
-          <p:nvPr/>
-        </p:nvSpPr>
-        <p:spPr>
-          <a:xfrm>
-            <a:off x="777240" y="3127248"/>
-            <a:ext cx="6126480" cy="274320"/>
-          </a:xfrm>
-          <a:prstGeom prst="rect">
-            <a:avLst/>
-          </a:prstGeom>
-          <a:noFill/>
-          <a:ln/>
-        </p:spPr>
-        <p:txBody>
-          <a:bodyPr wrap="square" lIns="0" tIns="0" rIns="0" bIns="0" rtlCol="0" anchor="t"/>
-          <a:lstStyle/>
-          <a:p>
-            <a:pPr indent="0" marL="0">
-              <a:buNone/>
-            </a:pPr>
-            <a:r>
-              <a:rPr lang="en-US" sz="1100" b="1" spc="100" kern="0" dirty="0">
-                <a:solidFill>
-                  <a:schemeClr val="tx1"/>
-                </a:solidFill>
-              </a:rPr>
-              <a:t>MONTHLY UNIQUE USERS TREND</a:t>
-            </a:r>
-            <a:endParaRPr lang="en-US" sz="1100" dirty="0"/>
           </a:p>
         </p:txBody>
       </p:sp>
       <p:graphicFrame>
         <p:nvGraphicFramePr>
-          <p:cNvPr id="22" name="users-trend" descr=""/>
+          <p:cNvPr id="19" name="users-trend" descr=""/>
           <p:cNvGraphicFramePr/>
           <p:nvPr/>
         </p:nvGraphicFramePr>
         <p:xfrm>
-          <a:off x="640080" y="3429000"/>
-          <a:ext cx="6400800" cy="2743200"/>
+          <a:off x="594360" y="3063240"/>
+          <a:ext cx="4480560" cy="2971800"/>
         </p:xfrm>
         <a:graphic xmlns:a="http://schemas.openxmlformats.org/drawingml/2006/main">
           <a:graphicData uri="http://schemas.openxmlformats.org/drawingml/2006/chart">
@@ -3503,14 +3264,14 @@
       </p:graphicFrame>
       <p:sp>
         <p:nvSpPr>
-          <p:cNvPr id="23" name="trend-caption"/>
+          <p:cNvPr id="20" name="trend-caption"/>
           <p:cNvSpPr txBox="1"/>
           <p:nvPr/>
         </p:nvSpPr>
         <p:spPr>
           <a:xfrm>
-            <a:off x="777240" y="6190488"/>
-            <a:ext cx="6126480" cy="228600"/>
+            <a:off x="731520" y="6099048"/>
+            <a:ext cx="4206240" cy="237744"/>
           </a:xfrm>
           <a:prstGeom prst="rect">
             <a:avLst/>
@@ -3531,7 +3292,7 @@
                   <a:schemeClr val="tx2"/>
                 </a:solidFill>
               </a:rPr>
-              <a:t>Approximate monthly values, read from the ERM usage chart</a:t>
+              <a:t>Approximate, read from the ERM usage chart</a:t>
             </a:r>
             <a:endParaRPr lang="en-US" sz="1000" dirty="0"/>
           </a:p>
@@ -3539,18 +3300,18 @@
       </p:sp>
       <p:sp>
         <p:nvSpPr>
-          <p:cNvPr id="24" name="erm-card"/>
+          <p:cNvPr id="21" name="org-card"/>
           <p:cNvSpPr/>
           <p:nvPr/>
         </p:nvSpPr>
         <p:spPr>
           <a:xfrm>
-            <a:off x="7406640" y="3017520"/>
-            <a:ext cx="4233672" cy="3429000"/>
+            <a:off x="5349240" y="2697480"/>
+            <a:ext cx="3840480" cy="3749040"/>
           </a:xfrm>
           <a:prstGeom prst="roundRect">
             <a:avLst>
-              <a:gd name="adj" fmla="val 3200"/>
+              <a:gd name="adj" fmla="val 2927"/>
             </a:avLst>
           </a:prstGeom>
           <a:solidFill>
@@ -3561,14 +3322,14 @@
       </p:sp>
       <p:sp>
         <p:nvSpPr>
-          <p:cNvPr id="25" name="erm-text"/>
+          <p:cNvPr id="22" name="org-title"/>
           <p:cNvSpPr txBox="1"/>
           <p:nvPr/>
         </p:nvSpPr>
         <p:spPr>
           <a:xfrm>
-            <a:off x="7635240" y="3154680"/>
-            <a:ext cx="3794760" cy="3154680"/>
+            <a:off x="5532120" y="2807208"/>
+            <a:ext cx="3474720" cy="256032"/>
           </a:xfrm>
           <a:prstGeom prst="rect">
             <a:avLst/>
@@ -3584,45 +3345,332 @@
               <a:buNone/>
             </a:pPr>
             <a:r>
-              <a:rPr lang="en-US" sz="1100" b="1" spc="100" kern="0" dirty="0">
+              <a:rPr lang="en-US" sz="1000" b="1" spc="100" kern="0" dirty="0">
                 <a:solidFill>
                   <a:schemeClr val="tx1"/>
                 </a:solidFill>
               </a:rPr>
-              <a:t>WHAT ERM DOES</a:t>
-            </a:r>
-            <a:endParaRPr lang="en-US" sz="1100" dirty="0"/>
+              <a:t>USERS BY ORGANISATION (SIGLUM 1)</a:t>
+            </a:r>
+            <a:endParaRPr lang="en-US" sz="1000" dirty="0"/>
+          </a:p>
+        </p:txBody>
+      </p:sp>
+      <p:graphicFrame>
+        <p:nvGraphicFramePr>
+          <p:cNvPr id="23" name="org-chart" descr=""/>
+          <p:cNvGraphicFramePr/>
+          <p:nvPr/>
+        </p:nvGraphicFramePr>
+        <p:xfrm>
+          <a:off x="5394960" y="3063240"/>
+          <a:ext cx="3749040" cy="2971800"/>
+        </p:xfrm>
+        <a:graphic xmlns:a="http://schemas.openxmlformats.org/drawingml/2006/main">
+          <a:graphicData uri="http://schemas.openxmlformats.org/drawingml/2006/chart">
+            <c:chart xmlns:c="http://schemas.openxmlformats.org/drawingml/2006/chart" r:id="rId2"/>
+          </a:graphicData>
+        </a:graphic>
+      </p:graphicFrame>
+      <p:sp>
+        <p:nvSpPr>
+          <p:cNvPr id="24" name="org-caption"/>
+          <p:cNvSpPr txBox="1"/>
+          <p:nvPr/>
+        </p:nvSpPr>
+        <p:spPr>
+          <a:xfrm>
+            <a:off x="5532120" y="6099048"/>
+            <a:ext cx="3474720" cy="237744"/>
+          </a:xfrm>
+          <a:prstGeom prst="rect">
+            <a:avLst/>
+          </a:prstGeom>
+          <a:noFill/>
+          <a:ln/>
+        </p:spPr>
+        <p:txBody>
+          <a:bodyPr wrap="square" lIns="0" tIns="0" rIns="0" bIns="0" rtlCol="0" anchor="t"/>
+          <a:lstStyle/>
+          <a:p>
+            <a:pPr indent="0" marL="0">
+              <a:buNone/>
+            </a:pPr>
+            <a:r>
+              <a:rPr lang="en-US" sz="1000" i="1" dirty="0">
+                <a:solidFill>
+                  <a:schemeClr val="tx2"/>
+                </a:solidFill>
+              </a:rPr>
+              <a:t>Plus about 12 smaller organisations. Approximate</a:t>
+            </a:r>
+            <a:endParaRPr lang="en-US" sz="1000" dirty="0"/>
+          </a:p>
+        </p:txBody>
+      </p:sp>
+      <p:sp>
+        <p:nvSpPr>
+          <p:cNvPr id="25" name="loc-card"/>
+          <p:cNvSpPr/>
+          <p:nvPr/>
+        </p:nvSpPr>
+        <p:spPr>
+          <a:xfrm>
+            <a:off x="9418320" y="2697480"/>
+            <a:ext cx="2224735" cy="3749040"/>
+          </a:xfrm>
+          <a:prstGeom prst="roundRect">
+            <a:avLst>
+              <a:gd name="adj" fmla="val 4932"/>
+            </a:avLst>
+          </a:prstGeom>
+          <a:solidFill>
+            <a:schemeClr val="tx1"/>
+          </a:solidFill>
+          <a:ln/>
+        </p:spPr>
+      </p:sp>
+      <p:sp>
+        <p:nvSpPr>
+          <p:cNvPr id="26" name="loc-title"/>
+          <p:cNvSpPr txBox="1"/>
+          <p:nvPr/>
+        </p:nvSpPr>
+        <p:spPr>
+          <a:xfrm>
+            <a:off x="9601200" y="2807208"/>
+            <a:ext cx="1858975" cy="256032"/>
+          </a:xfrm>
+          <a:prstGeom prst="rect">
+            <a:avLst/>
+          </a:prstGeom>
+          <a:noFill/>
+          <a:ln/>
+        </p:spPr>
+        <p:txBody>
+          <a:bodyPr wrap="square" lIns="0" tIns="0" rIns="0" bIns="0" rtlCol="0" anchor="t"/>
+          <a:lstStyle/>
+          <a:p>
+            <a:pPr indent="0" marL="0">
+              <a:buNone/>
+            </a:pPr>
+            <a:r>
+              <a:rPr lang="en-US" sz="1000" b="1" spc="100" kern="0" dirty="0">
+                <a:solidFill>
+                  <a:schemeClr val="accent5"/>
+                </a:solidFill>
+              </a:rPr>
+              <a:t>LOCATION PROFILE</a:t>
+            </a:r>
+            <a:endParaRPr lang="en-US" sz="1000" dirty="0"/>
+          </a:p>
+        </p:txBody>
+      </p:sp>
+      <p:sp>
+        <p:nvSpPr>
+          <p:cNvPr id="27" name="loc-list"/>
+          <p:cNvSpPr txBox="1"/>
+          <p:nvPr/>
+        </p:nvSpPr>
+        <p:spPr>
+          <a:xfrm>
+            <a:off x="9601200" y="3154680"/>
+            <a:ext cx="1858975" cy="3154680"/>
+          </a:xfrm>
+          <a:prstGeom prst="rect">
+            <a:avLst/>
+          </a:prstGeom>
+          <a:noFill/>
+          <a:ln/>
+        </p:spPr>
+        <p:txBody>
+          <a:bodyPr wrap="square" lIns="0" tIns="0" rIns="0" bIns="0" rtlCol="0" anchor="t"/>
+          <a:lstStyle/>
+          <a:p>
+            <a:pPr indent="0" marL="0">
+              <a:buNone/>
+            </a:pPr>
+            <a:r>
+              <a:rPr lang="en-US" sz="1200" b="1" dirty="0">
+                <a:solidFill>
+                  <a:schemeClr val="bg1"/>
+                </a:solidFill>
+              </a:rPr>
+              <a:t>France</a:t>
+            </a:r>
+            <a:endParaRPr lang="en-US" sz="1200" dirty="0"/>
           </a:p>
           <a:p>
             <a:pPr indent="0" marL="0">
               <a:spcAft>
-                <a:spcPts val="1000"/>
+                <a:spcPts val="600"/>
               </a:spcAft>
               <a:buNone/>
             </a:pPr>
             <a:r>
-              <a:rPr lang="en-US" sz="1500" dirty="0">
-                <a:solidFill>
-                  <a:schemeClr val="tx2"/>
-                </a:solidFill>
-              </a:rPr>
-              <a:t>One place to manage ARM risks and opportunities: custom dashboards, live editing, trend following, governed quarterly releases and cross-division sharing.</a:t>
-            </a:r>
-            <a:endParaRPr lang="en-US" sz="1100" dirty="0"/>
+              <a:rPr lang="en-US" sz="1100" dirty="0">
+                <a:solidFill>
+                  <a:schemeClr val="accent5"/>
+                </a:solidFill>
+              </a:rPr>
+              <a:t>Blagnac 271, Saint-Martin 43</a:t>
+            </a:r>
+            <a:endParaRPr lang="en-US" sz="1200" dirty="0"/>
           </a:p>
           <a:p>
             <a:pPr indent="0" marL="0">
               <a:buNone/>
             </a:pPr>
             <a:r>
-              <a:rPr lang="en-US" sz="1500" b="1" dirty="0">
-                <a:solidFill>
-                  <a:schemeClr val="tx1"/>
-                </a:solidFill>
-              </a:rPr>
-              <a:t>Every risk and opportunity review in ERM depends on it working.</a:t>
-            </a:r>
-            <a:endParaRPr lang="en-US" sz="1100" dirty="0"/>
+              <a:rPr lang="en-US" sz="1200" b="1" dirty="0">
+                <a:solidFill>
+                  <a:schemeClr val="bg1"/>
+                </a:solidFill>
+              </a:rPr>
+              <a:t>Germany</a:t>
+            </a:r>
+            <a:endParaRPr lang="en-US" sz="1200" dirty="0"/>
+          </a:p>
+          <a:p>
+            <a:pPr indent="0" marL="0">
+              <a:spcAft>
+                <a:spcPts val="600"/>
+              </a:spcAft>
+              <a:buNone/>
+            </a:pPr>
+            <a:r>
+              <a:rPr lang="en-US" sz="1100" dirty="0">
+                <a:solidFill>
+                  <a:schemeClr val="accent5"/>
+                </a:solidFill>
+              </a:rPr>
+              <a:t>Hamburg 205</a:t>
+            </a:r>
+            <a:endParaRPr lang="en-US" sz="1200" dirty="0"/>
+          </a:p>
+          <a:p>
+            <a:pPr indent="0" marL="0">
+              <a:buNone/>
+            </a:pPr>
+            <a:r>
+              <a:rPr lang="en-US" sz="1200" b="1" dirty="0">
+                <a:solidFill>
+                  <a:schemeClr val="bg1"/>
+                </a:solidFill>
+              </a:rPr>
+              <a:t>United Kingdom</a:t>
+            </a:r>
+            <a:endParaRPr lang="en-US" sz="1200" dirty="0"/>
+          </a:p>
+          <a:p>
+            <a:pPr indent="0" marL="0">
+              <a:spcAft>
+                <a:spcPts val="600"/>
+              </a:spcAft>
+              <a:buNone/>
+            </a:pPr>
+            <a:r>
+              <a:rPr lang="en-US" sz="1100" dirty="0">
+                <a:solidFill>
+                  <a:schemeClr val="accent5"/>
+                </a:solidFill>
+              </a:rPr>
+              <a:t>Broughton 32, Filton 26</a:t>
+            </a:r>
+            <a:endParaRPr lang="en-US" sz="1200" dirty="0"/>
+          </a:p>
+          <a:p>
+            <a:pPr indent="0" marL="0">
+              <a:buNone/>
+            </a:pPr>
+            <a:r>
+              <a:rPr lang="en-US" sz="1200" b="1" dirty="0">
+                <a:solidFill>
+                  <a:schemeClr val="bg1"/>
+                </a:solidFill>
+              </a:rPr>
+              <a:t>Spain</a:t>
+            </a:r>
+            <a:endParaRPr lang="en-US" sz="1200" dirty="0"/>
+          </a:p>
+          <a:p>
+            <a:pPr indent="0" marL="0">
+              <a:spcAft>
+                <a:spcPts val="600"/>
+              </a:spcAft>
+              <a:buNone/>
+            </a:pPr>
+            <a:r>
+              <a:rPr lang="en-US" sz="1100" dirty="0">
+                <a:solidFill>
+                  <a:schemeClr val="accent5"/>
+                </a:solidFill>
+              </a:rPr>
+              <a:t>Getafe 25</a:t>
+            </a:r>
+            <a:endParaRPr lang="en-US" sz="1200" dirty="0"/>
+          </a:p>
+          <a:p>
+            <a:pPr indent="0" marL="0">
+              <a:buNone/>
+            </a:pPr>
+            <a:r>
+              <a:rPr lang="en-US" sz="1200" b="1" dirty="0">
+                <a:solidFill>
+                  <a:schemeClr val="bg1"/>
+                </a:solidFill>
+              </a:rPr>
+              <a:t>Canada</a:t>
+            </a:r>
+            <a:endParaRPr lang="en-US" sz="1200" dirty="0"/>
+          </a:p>
+          <a:p>
+            <a:pPr indent="0" marL="0">
+              <a:spcAft>
+                <a:spcPts val="600"/>
+              </a:spcAft>
+              <a:buNone/>
+            </a:pPr>
+            <a:r>
+              <a:rPr lang="en-US" sz="1100" dirty="0">
+                <a:solidFill>
+                  <a:schemeClr val="accent5"/>
+                </a:solidFill>
+              </a:rPr>
+              <a:t>Mirabel 12</a:t>
+            </a:r>
+            <a:endParaRPr lang="en-US" sz="1200" dirty="0"/>
+          </a:p>
+          <a:p>
+            <a:pPr indent="0" marL="0">
+              <a:buNone/>
+            </a:pPr>
+            <a:r>
+              <a:rPr lang="en-US" sz="1200" b="1" dirty="0">
+                <a:solidFill>
+                  <a:schemeClr val="bg1"/>
+                </a:solidFill>
+              </a:rPr>
+              <a:t>India</a:t>
+            </a:r>
+            <a:endParaRPr lang="en-US" sz="1200" dirty="0"/>
+          </a:p>
+          <a:p>
+            <a:pPr indent="0" marL="0">
+              <a:spcAft>
+                <a:spcPts val="600"/>
+              </a:spcAft>
+              <a:buNone/>
+            </a:pPr>
+            <a:r>
+              <a:rPr lang="en-US" sz="1100" dirty="0">
+                <a:solidFill>
+                  <a:schemeClr val="accent5"/>
+                </a:solidFill>
+              </a:rPr>
+              <a:t>Bangalore 7</a:t>
+            </a:r>
+            <a:endParaRPr lang="en-US" sz="1200" dirty="0"/>
           </a:p>
         </p:txBody>
       </p:sp>
@@ -3643,7 +3691,7 @@
               <p:cTn id="2" dur="indefinite" nodeType="mainSeq">
                 <p:childTnLst>
                   <p:par>
-                    <p:cTn id="75" fill="hold">
+                    <p:cTn id="83" fill="hold">
                       <p:stCondLst>
                         <p:cond delay="indefinite"/>
                         <p:cond evt="onBegin" delay="0">
@@ -3652,7 +3700,7 @@
                       </p:stCondLst>
                       <p:childTnLst>
                         <p:par>
-                          <p:cTn id="15" fill="hold">
+                          <p:cTn id="6" fill="hold">
                             <p:stCondLst>
                               <p:cond delay="0"/>
                             </p:stCondLst>
@@ -3692,15 +3740,24 @@
                                   </p:childTnLst>
                                 </p:cTn>
                               </p:par>
+                            </p:childTnLst>
+                          </p:cTn>
+                        </p:par>
+                        <p:par>
+                          <p:cTn id="16" fill="hold">
+                            <p:stCondLst>
+                              <p:cond delay="400"/>
+                            </p:stCondLst>
+                            <p:childTnLst>
                               <p:par>
-                                <p:cTn id="6" presetID="10" presetClass="entr" presetSubtype="0" fill="hold" grpId="0" nodeType="withEffect">
+                                <p:cTn id="7" presetID="10" presetClass="entr" presetSubtype="0" fill="hold" grpId="0" nodeType="afterEffect">
                                   <p:stCondLst>
                                     <p:cond delay="0"/>
                                   </p:stCondLst>
                                   <p:childTnLst>
                                     <p:set>
                                       <p:cBhvr>
-                                        <p:cTn id="7" dur="1" fill="hold">
+                                        <p:cTn id="8" dur="1" fill="hold">
                                           <p:stCondLst>
                                             <p:cond delay="0"/>
                                           </p:stCondLst>
@@ -3718,7 +3775,7 @@
                                     </p:set>
                                     <p:animEffect transition="in" filter="fade">
                                       <p:cBhvr>
-                                        <p:cTn id="8" dur="450"/>
+                                        <p:cTn id="9" dur="450"/>
                                         <p:tgtEl>
                                           <p:spTgt spid="5"/>
                                         </p:tgtEl>
@@ -3728,14 +3785,14 @@
                                 </p:cTn>
                               </p:par>
                               <p:par>
-                                <p:cTn id="9" presetID="10" presetClass="entr" presetSubtype="0" fill="hold" grpId="0" nodeType="withEffect">
+                                <p:cTn id="10" presetID="10" presetClass="entr" presetSubtype="0" fill="hold" grpId="0" nodeType="withEffect">
                                   <p:stCondLst>
                                     <p:cond delay="0"/>
                                   </p:stCondLst>
                                   <p:childTnLst>
                                     <p:set>
                                       <p:cBhvr>
-                                        <p:cTn id="10" dur="1" fill="hold">
+                                        <p:cTn id="11" dur="1" fill="hold">
                                           <p:stCondLst>
                                             <p:cond delay="0"/>
                                           </p:stCondLst>
@@ -3753,7 +3810,7 @@
                                     </p:set>
                                     <p:animEffect transition="in" filter="fade">
                                       <p:cBhvr>
-                                        <p:cTn id="11" dur="450"/>
+                                        <p:cTn id="12" dur="450"/>
                                         <p:tgtEl>
                                           <p:spTgt spid="6"/>
                                         </p:tgtEl>
@@ -3763,14 +3820,14 @@
                                 </p:cTn>
                               </p:par>
                               <p:par>
-                                <p:cTn id="12" presetID="10" presetClass="entr" presetSubtype="0" fill="hold" grpId="0" nodeType="withEffect">
+                                <p:cTn id="13" presetID="10" presetClass="entr" presetSubtype="0" fill="hold" grpId="0" nodeType="withEffect">
                                   <p:stCondLst>
                                     <p:cond delay="0"/>
                                   </p:stCondLst>
                                   <p:childTnLst>
                                     <p:set>
                                       <p:cBhvr>
-                                        <p:cTn id="13" dur="1" fill="hold">
+                                        <p:cTn id="14" dur="1" fill="hold">
                                           <p:stCondLst>
                                             <p:cond delay="0"/>
                                           </p:stCondLst>
@@ -3788,7 +3845,7 @@
                                     </p:set>
                                     <p:animEffect transition="in" filter="fade">
                                       <p:cBhvr>
-                                        <p:cTn id="14" dur="450"/>
+                                        <p:cTn id="15" dur="450"/>
                                         <p:tgtEl>
                                           <p:spTgt spid="7"/>
                                         </p:tgtEl>
@@ -3801,20 +3858,20 @@
                           </p:cTn>
                         </p:par>
                         <p:par>
-                          <p:cTn id="28" fill="hold">
+                          <p:cTn id="26" fill="hold">
                             <p:stCondLst>
-                              <p:cond delay="400"/>
+                              <p:cond delay="800"/>
                             </p:stCondLst>
                             <p:childTnLst>
                               <p:par>
-                                <p:cTn id="16" presetID="10" presetClass="entr" presetSubtype="0" fill="hold" grpId="0" nodeType="afterEffect">
+                                <p:cTn id="17" presetID="10" presetClass="entr" presetSubtype="0" fill="hold" grpId="0" nodeType="afterEffect">
                                   <p:stCondLst>
                                     <p:cond delay="0"/>
                                   </p:stCondLst>
                                   <p:childTnLst>
                                     <p:set>
                                       <p:cBhvr>
-                                        <p:cTn id="17" dur="1" fill="hold">
+                                        <p:cTn id="18" dur="1" fill="hold">
                                           <p:stCondLst>
                                             <p:cond delay="0"/>
                                           </p:stCondLst>
@@ -3832,7 +3889,7 @@
                                     </p:set>
                                     <p:animEffect transition="in" filter="fade">
                                       <p:cBhvr>
-                                        <p:cTn id="18" dur="450"/>
+                                        <p:cTn id="19" dur="450"/>
                                         <p:tgtEl>
                                           <p:spTgt spid="8"/>
                                         </p:tgtEl>
@@ -3842,14 +3899,14 @@
                                 </p:cTn>
                               </p:par>
                               <p:par>
-                                <p:cTn id="19" presetID="10" presetClass="entr" presetSubtype="0" fill="hold" grpId="0" nodeType="withEffect">
+                                <p:cTn id="20" presetID="10" presetClass="entr" presetSubtype="0" fill="hold" grpId="0" nodeType="withEffect">
                                   <p:stCondLst>
                                     <p:cond delay="0"/>
                                   </p:stCondLst>
                                   <p:childTnLst>
                                     <p:set>
                                       <p:cBhvr>
-                                        <p:cTn id="20" dur="1" fill="hold">
+                                        <p:cTn id="21" dur="1" fill="hold">
                                           <p:stCondLst>
                                             <p:cond delay="0"/>
                                           </p:stCondLst>
@@ -3867,7 +3924,7 @@
                                     </p:set>
                                     <p:animEffect transition="in" filter="fade">
                                       <p:cBhvr>
-                                        <p:cTn id="21" dur="450"/>
+                                        <p:cTn id="22" dur="450"/>
                                         <p:tgtEl>
                                           <p:spTgt spid="9"/>
                                         </p:tgtEl>
@@ -3877,14 +3934,14 @@
                                 </p:cTn>
                               </p:par>
                               <p:par>
-                                <p:cTn id="22" presetID="10" presetClass="entr" presetSubtype="0" fill="hold" grpId="0" nodeType="withEffect">
+                                <p:cTn id="23" presetID="10" presetClass="entr" presetSubtype="0" fill="hold" grpId="0" nodeType="withEffect">
                                   <p:stCondLst>
                                     <p:cond delay="0"/>
                                   </p:stCondLst>
                                   <p:childTnLst>
                                     <p:set>
                                       <p:cBhvr>
-                                        <p:cTn id="23" dur="1" fill="hold">
+                                        <p:cTn id="24" dur="1" fill="hold">
                                           <p:stCondLst>
                                             <p:cond delay="0"/>
                                           </p:stCondLst>
@@ -3902,44 +3959,9 @@
                                     </p:set>
                                     <p:animEffect transition="in" filter="fade">
                                       <p:cBhvr>
-                                        <p:cTn id="24" dur="450"/>
+                                        <p:cTn id="25" dur="450"/>
                                         <p:tgtEl>
                                           <p:spTgt spid="10"/>
-                                        </p:tgtEl>
-                                      </p:cBhvr>
-                                    </p:animEffect>
-                                  </p:childTnLst>
-                                </p:cTn>
-                              </p:par>
-                              <p:par>
-                                <p:cTn id="25" presetID="10" presetClass="entr" presetSubtype="0" fill="hold" grpId="0" nodeType="withEffect">
-                                  <p:stCondLst>
-                                    <p:cond delay="0"/>
-                                  </p:stCondLst>
-                                  <p:childTnLst>
-                                    <p:set>
-                                      <p:cBhvr>
-                                        <p:cTn id="26" dur="1" fill="hold">
-                                          <p:stCondLst>
-                                            <p:cond delay="0"/>
-                                          </p:stCondLst>
-                                        </p:cTn>
-                                        <p:tgtEl>
-                                          <p:spTgt spid="11"/>
-                                        </p:tgtEl>
-                                        <p:attrNameLst>
-                                          <p:attrName>style.visibility</p:attrName>
-                                        </p:attrNameLst>
-                                      </p:cBhvr>
-                                      <p:to>
-                                        <p:strVal val="visible"/>
-                                      </p:to>
-                                    </p:set>
-                                    <p:animEffect transition="in" filter="fade">
-                                      <p:cBhvr>
-                                        <p:cTn id="27" dur="450"/>
-                                        <p:tgtEl>
-                                          <p:spTgt spid="11"/>
                                         </p:tgtEl>
                                       </p:cBhvr>
                                     </p:animEffect>
@@ -3950,26 +3972,26 @@
                           </p:cTn>
                         </p:par>
                         <p:par>
-                          <p:cTn id="41" fill="hold">
+                          <p:cTn id="36" fill="hold">
                             <p:stCondLst>
-                              <p:cond delay="800"/>
+                              <p:cond delay="1200"/>
                             </p:stCondLst>
                             <p:childTnLst>
                               <p:par>
-                                <p:cTn id="29" presetID="10" presetClass="entr" presetSubtype="0" fill="hold" grpId="0" nodeType="afterEffect">
+                                <p:cTn id="27" presetID="10" presetClass="entr" presetSubtype="0" fill="hold" grpId="0" nodeType="afterEffect">
                                   <p:stCondLst>
                                     <p:cond delay="0"/>
                                   </p:stCondLst>
                                   <p:childTnLst>
                                     <p:set>
                                       <p:cBhvr>
-                                        <p:cTn id="30" dur="1" fill="hold">
+                                        <p:cTn id="28" dur="1" fill="hold">
                                           <p:stCondLst>
                                             <p:cond delay="0"/>
                                           </p:stCondLst>
                                         </p:cTn>
                                         <p:tgtEl>
-                                          <p:spTgt spid="12"/>
+                                          <p:spTgt spid="11"/>
                                         </p:tgtEl>
                                         <p:attrNameLst>
                                           <p:attrName>style.visibility</p:attrName>
@@ -3981,9 +4003,9 @@
                                     </p:set>
                                     <p:animEffect transition="in" filter="fade">
                                       <p:cBhvr>
-                                        <p:cTn id="31" dur="450"/>
-                                        <p:tgtEl>
-                                          <p:spTgt spid="12"/>
+                                        <p:cTn id="29" dur="450"/>
+                                        <p:tgtEl>
+                                          <p:spTgt spid="11"/>
                                         </p:tgtEl>
                                       </p:cBhvr>
                                     </p:animEffect>
@@ -3991,20 +4013,20 @@
                                 </p:cTn>
                               </p:par>
                               <p:par>
-                                <p:cTn id="32" presetID="10" presetClass="entr" presetSubtype="0" fill="hold" grpId="0" nodeType="withEffect">
+                                <p:cTn id="30" presetID="10" presetClass="entr" presetSubtype="0" fill="hold" grpId="0" nodeType="withEffect">
                                   <p:stCondLst>
                                     <p:cond delay="0"/>
                                   </p:stCondLst>
                                   <p:childTnLst>
                                     <p:set>
                                       <p:cBhvr>
-                                        <p:cTn id="33" dur="1" fill="hold">
+                                        <p:cTn id="31" dur="1" fill="hold">
                                           <p:stCondLst>
                                             <p:cond delay="0"/>
                                           </p:stCondLst>
                                         </p:cTn>
                                         <p:tgtEl>
-                                          <p:spTgt spid="13"/>
+                                          <p:spTgt spid="12"/>
                                         </p:tgtEl>
                                         <p:attrNameLst>
                                           <p:attrName>style.visibility</p:attrName>
@@ -4016,9 +4038,9 @@
                                     </p:set>
                                     <p:animEffect transition="in" filter="fade">
                                       <p:cBhvr>
-                                        <p:cTn id="34" dur="450"/>
-                                        <p:tgtEl>
-                                          <p:spTgt spid="13"/>
+                                        <p:cTn id="32" dur="450"/>
+                                        <p:tgtEl>
+                                          <p:spTgt spid="12"/>
                                         </p:tgtEl>
                                       </p:cBhvr>
                                     </p:animEffect>
@@ -4026,20 +4048,20 @@
                                 </p:cTn>
                               </p:par>
                               <p:par>
-                                <p:cTn id="35" presetID="10" presetClass="entr" presetSubtype="0" fill="hold" grpId="0" nodeType="withEffect">
+                                <p:cTn id="33" presetID="10" presetClass="entr" presetSubtype="0" fill="hold" grpId="0" nodeType="withEffect">
                                   <p:stCondLst>
                                     <p:cond delay="0"/>
                                   </p:stCondLst>
                                   <p:childTnLst>
                                     <p:set>
                                       <p:cBhvr>
-                                        <p:cTn id="36" dur="1" fill="hold">
+                                        <p:cTn id="34" dur="1" fill="hold">
                                           <p:stCondLst>
                                             <p:cond delay="0"/>
                                           </p:stCondLst>
                                         </p:cTn>
                                         <p:tgtEl>
-                                          <p:spTgt spid="14"/>
+                                          <p:spTgt spid="13"/>
                                         </p:tgtEl>
                                         <p:attrNameLst>
                                           <p:attrName>style.visibility</p:attrName>
@@ -4051,44 +4073,9 @@
                                     </p:set>
                                     <p:animEffect transition="in" filter="fade">
                                       <p:cBhvr>
-                                        <p:cTn id="37" dur="450"/>
-                                        <p:tgtEl>
-                                          <p:spTgt spid="14"/>
-                                        </p:tgtEl>
-                                      </p:cBhvr>
-                                    </p:animEffect>
-                                  </p:childTnLst>
-                                </p:cTn>
-                              </p:par>
-                              <p:par>
-                                <p:cTn id="38" presetID="10" presetClass="entr" presetSubtype="0" fill="hold" grpId="0" nodeType="withEffect">
-                                  <p:stCondLst>
-                                    <p:cond delay="0"/>
-                                  </p:stCondLst>
-                                  <p:childTnLst>
-                                    <p:set>
-                                      <p:cBhvr>
-                                        <p:cTn id="39" dur="1" fill="hold">
-                                          <p:stCondLst>
-                                            <p:cond delay="0"/>
-                                          </p:stCondLst>
-                                        </p:cTn>
-                                        <p:tgtEl>
-                                          <p:spTgt spid="15"/>
-                                        </p:tgtEl>
-                                        <p:attrNameLst>
-                                          <p:attrName>style.visibility</p:attrName>
-                                        </p:attrNameLst>
-                                      </p:cBhvr>
-                                      <p:to>
-                                        <p:strVal val="visible"/>
-                                      </p:to>
-                                    </p:set>
-                                    <p:animEffect transition="in" filter="fade">
-                                      <p:cBhvr>
-                                        <p:cTn id="40" dur="450"/>
-                                        <p:tgtEl>
-                                          <p:spTgt spid="15"/>
+                                        <p:cTn id="35" dur="450"/>
+                                        <p:tgtEl>
+                                          <p:spTgt spid="13"/>
                                         </p:tgtEl>
                                       </p:cBhvr>
                                     </p:animEffect>
@@ -4099,26 +4086,26 @@
                           </p:cTn>
                         </p:par>
                         <p:par>
-                          <p:cTn id="54" fill="hold">
+                          <p:cTn id="46" fill="hold">
                             <p:stCondLst>
-                              <p:cond delay="1200"/>
+                              <p:cond delay="1600"/>
                             </p:stCondLst>
                             <p:childTnLst>
                               <p:par>
-                                <p:cTn id="42" presetID="10" presetClass="entr" presetSubtype="0" fill="hold" grpId="0" nodeType="afterEffect">
+                                <p:cTn id="37" presetID="10" presetClass="entr" presetSubtype="0" fill="hold" grpId="0" nodeType="afterEffect">
                                   <p:stCondLst>
                                     <p:cond delay="0"/>
                                   </p:stCondLst>
                                   <p:childTnLst>
                                     <p:set>
                                       <p:cBhvr>
-                                        <p:cTn id="43" dur="1" fill="hold">
+                                        <p:cTn id="38" dur="1" fill="hold">
                                           <p:stCondLst>
                                             <p:cond delay="0"/>
                                           </p:stCondLst>
                                         </p:cTn>
                                         <p:tgtEl>
-                                          <p:spTgt spid="16"/>
+                                          <p:spTgt spid="14"/>
                                         </p:tgtEl>
                                         <p:attrNameLst>
                                           <p:attrName>style.visibility</p:attrName>
@@ -4130,9 +4117,9 @@
                                     </p:set>
                                     <p:animEffect transition="in" filter="fade">
                                       <p:cBhvr>
-                                        <p:cTn id="44" dur="450"/>
-                                        <p:tgtEl>
-                                          <p:spTgt spid="16"/>
+                                        <p:cTn id="39" dur="450"/>
+                                        <p:tgtEl>
+                                          <p:spTgt spid="14"/>
                                         </p:tgtEl>
                                       </p:cBhvr>
                                     </p:animEffect>
@@ -4140,20 +4127,20 @@
                                 </p:cTn>
                               </p:par>
                               <p:par>
-                                <p:cTn id="45" presetID="10" presetClass="entr" presetSubtype="0" fill="hold" grpId="0" nodeType="withEffect">
+                                <p:cTn id="40" presetID="10" presetClass="entr" presetSubtype="0" fill="hold" grpId="0" nodeType="withEffect">
                                   <p:stCondLst>
                                     <p:cond delay="0"/>
                                   </p:stCondLst>
                                   <p:childTnLst>
                                     <p:set>
                                       <p:cBhvr>
-                                        <p:cTn id="46" dur="1" fill="hold">
+                                        <p:cTn id="41" dur="1" fill="hold">
                                           <p:stCondLst>
                                             <p:cond delay="0"/>
                                           </p:stCondLst>
                                         </p:cTn>
                                         <p:tgtEl>
-                                          <p:spTgt spid="17"/>
+                                          <p:spTgt spid="15"/>
                                         </p:tgtEl>
                                         <p:attrNameLst>
                                           <p:attrName>style.visibility</p:attrName>
@@ -4165,9 +4152,9 @@
                                     </p:set>
                                     <p:animEffect transition="in" filter="fade">
                                       <p:cBhvr>
-                                        <p:cTn id="47" dur="450"/>
-                                        <p:tgtEl>
-                                          <p:spTgt spid="17"/>
+                                        <p:cTn id="42" dur="450"/>
+                                        <p:tgtEl>
+                                          <p:spTgt spid="15"/>
                                         </p:tgtEl>
                                       </p:cBhvr>
                                     </p:animEffect>
@@ -4175,20 +4162,20 @@
                                 </p:cTn>
                               </p:par>
                               <p:par>
-                                <p:cTn id="48" presetID="10" presetClass="entr" presetSubtype="0" fill="hold" grpId="0" nodeType="withEffect">
+                                <p:cTn id="43" presetID="10" presetClass="entr" presetSubtype="0" fill="hold" grpId="0" nodeType="withEffect">
                                   <p:stCondLst>
                                     <p:cond delay="0"/>
                                   </p:stCondLst>
                                   <p:childTnLst>
                                     <p:set>
                                       <p:cBhvr>
-                                        <p:cTn id="49" dur="1" fill="hold">
+                                        <p:cTn id="44" dur="1" fill="hold">
                                           <p:stCondLst>
                                             <p:cond delay="0"/>
                                           </p:stCondLst>
                                         </p:cTn>
                                         <p:tgtEl>
-                                          <p:spTgt spid="18"/>
+                                          <p:spTgt spid="16"/>
                                         </p:tgtEl>
                                         <p:attrNameLst>
                                           <p:attrName>style.visibility</p:attrName>
@@ -4200,44 +4187,9 @@
                                     </p:set>
                                     <p:animEffect transition="in" filter="fade">
                                       <p:cBhvr>
-                                        <p:cTn id="50" dur="450"/>
-                                        <p:tgtEl>
-                                          <p:spTgt spid="18"/>
-                                        </p:tgtEl>
-                                      </p:cBhvr>
-                                    </p:animEffect>
-                                  </p:childTnLst>
-                                </p:cTn>
-                              </p:par>
-                              <p:par>
-                                <p:cTn id="51" presetID="10" presetClass="entr" presetSubtype="0" fill="hold" grpId="0" nodeType="withEffect">
-                                  <p:stCondLst>
-                                    <p:cond delay="0"/>
-                                  </p:stCondLst>
-                                  <p:childTnLst>
-                                    <p:set>
-                                      <p:cBhvr>
-                                        <p:cTn id="52" dur="1" fill="hold">
-                                          <p:stCondLst>
-                                            <p:cond delay="0"/>
-                                          </p:stCondLst>
-                                        </p:cTn>
-                                        <p:tgtEl>
-                                          <p:spTgt spid="19"/>
-                                        </p:tgtEl>
-                                        <p:attrNameLst>
-                                          <p:attrName>style.visibility</p:attrName>
-                                        </p:attrNameLst>
-                                      </p:cBhvr>
-                                      <p:to>
-                                        <p:strVal val="visible"/>
-                                      </p:to>
-                                    </p:set>
-                                    <p:animEffect transition="in" filter="fade">
-                                      <p:cBhvr>
-                                        <p:cTn id="53" dur="450"/>
-                                        <p:tgtEl>
-                                          <p:spTgt spid="19"/>
+                                        <p:cTn id="45" dur="450"/>
+                                        <p:tgtEl>
+                                          <p:spTgt spid="16"/>
                                         </p:tgtEl>
                                       </p:cBhvr>
                                     </p:animEffect>
@@ -4248,26 +4200,26 @@
                           </p:cTn>
                         </p:par>
                         <p:par>
-                          <p:cTn id="67" fill="hold">
+                          <p:cTn id="59" fill="hold">
                             <p:stCondLst>
-                              <p:cond delay="1600"/>
+                              <p:cond delay="2000"/>
                             </p:stCondLst>
                             <p:childTnLst>
                               <p:par>
-                                <p:cTn id="55" presetID="10" presetClass="entr" presetSubtype="0" fill="hold" grpId="0" nodeType="afterEffect">
+                                <p:cTn id="47" presetID="10" presetClass="entr" presetSubtype="0" fill="hold" grpId="0" nodeType="afterEffect">
                                   <p:stCondLst>
                                     <p:cond delay="0"/>
                                   </p:stCondLst>
                                   <p:childTnLst>
                                     <p:set>
                                       <p:cBhvr>
-                                        <p:cTn id="56" dur="1" fill="hold">
+                                        <p:cTn id="48" dur="1" fill="hold">
                                           <p:stCondLst>
                                             <p:cond delay="0"/>
                                           </p:stCondLst>
                                         </p:cTn>
                                         <p:tgtEl>
-                                          <p:spTgt spid="20"/>
+                                          <p:spTgt spid="17"/>
                                         </p:tgtEl>
                                         <p:attrNameLst>
                                           <p:attrName>style.visibility</p:attrName>
@@ -4279,9 +4231,9 @@
                                     </p:set>
                                     <p:animEffect transition="in" filter="fade">
                                       <p:cBhvr>
-                                        <p:cTn id="57" dur="450"/>
-                                        <p:tgtEl>
-                                          <p:spTgt spid="20"/>
+                                        <p:cTn id="49" dur="450"/>
+                                        <p:tgtEl>
+                                          <p:spTgt spid="17"/>
                                         </p:tgtEl>
                                       </p:cBhvr>
                                     </p:animEffect>
@@ -4289,20 +4241,20 @@
                                 </p:cTn>
                               </p:par>
                               <p:par>
-                                <p:cTn id="58" presetID="10" presetClass="entr" presetSubtype="0" fill="hold" grpId="0" nodeType="withEffect">
+                                <p:cTn id="50" presetID="10" presetClass="entr" presetSubtype="0" fill="hold" grpId="0" nodeType="withEffect">
                                   <p:stCondLst>
                                     <p:cond delay="0"/>
                                   </p:stCondLst>
                                   <p:childTnLst>
                                     <p:set>
                                       <p:cBhvr>
-                                        <p:cTn id="59" dur="1" fill="hold">
+                                        <p:cTn id="51" dur="1" fill="hold">
                                           <p:stCondLst>
                                             <p:cond delay="0"/>
                                           </p:stCondLst>
                                         </p:cTn>
                                         <p:tgtEl>
-                                          <p:spTgt spid="21"/>
+                                          <p:spTgt spid="18"/>
                                         </p:tgtEl>
                                         <p:attrNameLst>
                                           <p:attrName>style.visibility</p:attrName>
@@ -4314,9 +4266,9 @@
                                     </p:set>
                                     <p:animEffect transition="in" filter="fade">
                                       <p:cBhvr>
-                                        <p:cTn id="60" dur="450"/>
-                                        <p:tgtEl>
-                                          <p:spTgt spid="21"/>
+                                        <p:cTn id="52" dur="450"/>
+                                        <p:tgtEl>
+                                          <p:spTgt spid="18"/>
                                         </p:tgtEl>
                                       </p:cBhvr>
                                     </p:animEffect>
@@ -4324,20 +4276,20 @@
                                 </p:cTn>
                               </p:par>
                               <p:par>
-                                <p:cTn id="61" presetID="10" presetClass="entr" presetSubtype="0" fill="hold" grpId="0" nodeType="withEffect">
+                                <p:cTn id="53" presetID="10" presetClass="entr" presetSubtype="0" fill="hold" grpId="0" nodeType="withEffect">
                                   <p:stCondLst>
                                     <p:cond delay="0"/>
                                   </p:stCondLst>
                                   <p:childTnLst>
                                     <p:set>
                                       <p:cBhvr>
-                                        <p:cTn id="62" dur="1" fill="hold">
+                                        <p:cTn id="54" dur="1" fill="hold">
                                           <p:stCondLst>
                                             <p:cond delay="0"/>
                                           </p:stCondLst>
                                         </p:cTn>
                                         <p:tgtEl>
-                                          <p:spTgt spid="23"/>
+                                          <p:spTgt spid="20"/>
                                         </p:tgtEl>
                                         <p:attrNameLst>
                                           <p:attrName>style.visibility</p:attrName>
@@ -4349,9 +4301,9 @@
                                     </p:set>
                                     <p:animEffect transition="in" filter="fade">
                                       <p:cBhvr>
-                                        <p:cTn id="63" dur="450"/>
-                                        <p:tgtEl>
-                                          <p:spTgt spid="23"/>
+                                        <p:cTn id="55" dur="450"/>
+                                        <p:tgtEl>
+                                          <p:spTgt spid="20"/>
                                         </p:tgtEl>
                                       </p:cBhvr>
                                     </p:animEffect>
@@ -4359,20 +4311,20 @@
                                 </p:cTn>
                               </p:par>
                               <p:par>
-                                <p:cTn id="64" presetID="22" presetClass="entr" presetSubtype="8" fill="hold" grpId="0" nodeType="withEffect">
+                                <p:cTn id="56" presetID="22" presetClass="entr" presetSubtype="8" fill="hold" grpId="0" nodeType="withEffect">
                                   <p:stCondLst>
                                     <p:cond delay="200"/>
                                   </p:stCondLst>
                                   <p:childTnLst>
                                     <p:set>
                                       <p:cBhvr>
-                                        <p:cTn id="65" dur="1" fill="hold">
+                                        <p:cTn id="57" dur="1" fill="hold">
                                           <p:stCondLst>
                                             <p:cond delay="0"/>
                                           </p:stCondLst>
                                         </p:cTn>
                                         <p:tgtEl>
-                                          <p:spTgt spid="22"/>
+                                          <p:spTgt spid="19"/>
                                         </p:tgtEl>
                                         <p:attrNameLst>
                                           <p:attrName>style.visibility</p:attrName>
@@ -4384,9 +4336,9 @@
                                     </p:set>
                                     <p:animEffect transition="in" filter="wipe(left)">
                                       <p:cBhvr>
-                                        <p:cTn id="66" dur="450"/>
-                                        <p:tgtEl>
-                                          <p:spTgt spid="22"/>
+                                        <p:cTn id="58" dur="450"/>
+                                        <p:tgtEl>
+                                          <p:spTgt spid="19"/>
                                         </p:tgtEl>
                                       </p:cBhvr>
                                     </p:animEffect>
@@ -4397,26 +4349,26 @@
                           </p:cTn>
                         </p:par>
                         <p:par>
-                          <p:cTn id="74" fill="hold">
+                          <p:cTn id="72" fill="hold">
                             <p:stCondLst>
-                              <p:cond delay="2000"/>
+                              <p:cond delay="2400"/>
                             </p:stCondLst>
                             <p:childTnLst>
                               <p:par>
-                                <p:cTn id="68" presetID="10" presetClass="entr" presetSubtype="0" fill="hold" grpId="0" nodeType="afterEffect">
+                                <p:cTn id="60" presetID="10" presetClass="entr" presetSubtype="0" fill="hold" grpId="0" nodeType="afterEffect">
                                   <p:stCondLst>
                                     <p:cond delay="0"/>
                                   </p:stCondLst>
                                   <p:childTnLst>
                                     <p:set>
                                       <p:cBhvr>
-                                        <p:cTn id="69" dur="1" fill="hold">
+                                        <p:cTn id="61" dur="1" fill="hold">
                                           <p:stCondLst>
                                             <p:cond delay="0"/>
                                           </p:stCondLst>
                                         </p:cTn>
                                         <p:tgtEl>
-                                          <p:spTgt spid="24"/>
+                                          <p:spTgt spid="21"/>
                                         </p:tgtEl>
                                         <p:attrNameLst>
                                           <p:attrName>style.visibility</p:attrName>
@@ -4428,9 +4380,9 @@
                                     </p:set>
                                     <p:animEffect transition="in" filter="fade">
                                       <p:cBhvr>
-                                        <p:cTn id="70" dur="450"/>
-                                        <p:tgtEl>
-                                          <p:spTgt spid="24"/>
+                                        <p:cTn id="62" dur="450"/>
+                                        <p:tgtEl>
+                                          <p:spTgt spid="21"/>
                                         </p:tgtEl>
                                       </p:cBhvr>
                                     </p:animEffect>
@@ -4438,20 +4390,20 @@
                                 </p:cTn>
                               </p:par>
                               <p:par>
-                                <p:cTn id="71" presetID="10" presetClass="entr" presetSubtype="0" fill="hold" grpId="0" nodeType="withEffect">
+                                <p:cTn id="63" presetID="10" presetClass="entr" presetSubtype="0" fill="hold" grpId="0" nodeType="withEffect">
                                   <p:stCondLst>
                                     <p:cond delay="0"/>
                                   </p:stCondLst>
                                   <p:childTnLst>
                                     <p:set>
                                       <p:cBhvr>
-                                        <p:cTn id="72" dur="1" fill="hold">
+                                        <p:cTn id="64" dur="1" fill="hold">
                                           <p:stCondLst>
                                             <p:cond delay="0"/>
                                           </p:stCondLst>
                                         </p:cTn>
                                         <p:tgtEl>
-                                          <p:spTgt spid="25"/>
+                                          <p:spTgt spid="22"/>
                                         </p:tgtEl>
                                         <p:attrNameLst>
                                           <p:attrName>style.visibility</p:attrName>
@@ -4463,9 +4415,193 @@
                                     </p:set>
                                     <p:animEffect transition="in" filter="fade">
                                       <p:cBhvr>
-                                        <p:cTn id="73" dur="450"/>
+                                        <p:cTn id="65" dur="450"/>
+                                        <p:tgtEl>
+                                          <p:spTgt spid="22"/>
+                                        </p:tgtEl>
+                                      </p:cBhvr>
+                                    </p:animEffect>
+                                  </p:childTnLst>
+                                </p:cTn>
+                              </p:par>
+                              <p:par>
+                                <p:cTn id="66" presetID="10" presetClass="entr" presetSubtype="0" fill="hold" grpId="0" nodeType="withEffect">
+                                  <p:stCondLst>
+                                    <p:cond delay="0"/>
+                                  </p:stCondLst>
+                                  <p:childTnLst>
+                                    <p:set>
+                                      <p:cBhvr>
+                                        <p:cTn id="67" dur="1" fill="hold">
+                                          <p:stCondLst>
+                                            <p:cond delay="0"/>
+                                          </p:stCondLst>
+                                        </p:cTn>
+                                        <p:tgtEl>
+                                          <p:spTgt spid="23"/>
+                                        </p:tgtEl>
+                                        <p:attrNameLst>
+                                          <p:attrName>style.visibility</p:attrName>
+                                        </p:attrNameLst>
+                                      </p:cBhvr>
+                                      <p:to>
+                                        <p:strVal val="visible"/>
+                                      </p:to>
+                                    </p:set>
+                                    <p:animEffect transition="in" filter="fade">
+                                      <p:cBhvr>
+                                        <p:cTn id="68" dur="450"/>
+                                        <p:tgtEl>
+                                          <p:spTgt spid="23"/>
+                                        </p:tgtEl>
+                                      </p:cBhvr>
+                                    </p:animEffect>
+                                  </p:childTnLst>
+                                </p:cTn>
+                              </p:par>
+                              <p:par>
+                                <p:cTn id="69" presetID="10" presetClass="entr" presetSubtype="0" fill="hold" grpId="0" nodeType="withEffect">
+                                  <p:stCondLst>
+                                    <p:cond delay="0"/>
+                                  </p:stCondLst>
+                                  <p:childTnLst>
+                                    <p:set>
+                                      <p:cBhvr>
+                                        <p:cTn id="70" dur="1" fill="hold">
+                                          <p:stCondLst>
+                                            <p:cond delay="0"/>
+                                          </p:stCondLst>
+                                        </p:cTn>
+                                        <p:tgtEl>
+                                          <p:spTgt spid="24"/>
+                                        </p:tgtEl>
+                                        <p:attrNameLst>
+                                          <p:attrName>style.visibility</p:attrName>
+                                        </p:attrNameLst>
+                                      </p:cBhvr>
+                                      <p:to>
+                                        <p:strVal val="visible"/>
+                                      </p:to>
+                                    </p:set>
+                                    <p:animEffect transition="in" filter="fade">
+                                      <p:cBhvr>
+                                        <p:cTn id="71" dur="450"/>
+                                        <p:tgtEl>
+                                          <p:spTgt spid="24"/>
+                                        </p:tgtEl>
+                                      </p:cBhvr>
+                                    </p:animEffect>
+                                  </p:childTnLst>
+                                </p:cTn>
+                              </p:par>
+                            </p:childTnLst>
+                          </p:cTn>
+                        </p:par>
+                        <p:par>
+                          <p:cTn id="82" fill="hold">
+                            <p:stCondLst>
+                              <p:cond delay="2800"/>
+                            </p:stCondLst>
+                            <p:childTnLst>
+                              <p:par>
+                                <p:cTn id="73" presetID="10" presetClass="entr" presetSubtype="0" fill="hold" grpId="0" nodeType="afterEffect">
+                                  <p:stCondLst>
+                                    <p:cond delay="0"/>
+                                  </p:stCondLst>
+                                  <p:childTnLst>
+                                    <p:set>
+                                      <p:cBhvr>
+                                        <p:cTn id="74" dur="1" fill="hold">
+                                          <p:stCondLst>
+                                            <p:cond delay="0"/>
+                                          </p:stCondLst>
+                                        </p:cTn>
                                         <p:tgtEl>
                                           <p:spTgt spid="25"/>
+                                        </p:tgtEl>
+                                        <p:attrNameLst>
+                                          <p:attrName>style.visibility</p:attrName>
+                                        </p:attrNameLst>
+                                      </p:cBhvr>
+                                      <p:to>
+                                        <p:strVal val="visible"/>
+                                      </p:to>
+                                    </p:set>
+                                    <p:animEffect transition="in" filter="fade">
+                                      <p:cBhvr>
+                                        <p:cTn id="75" dur="450"/>
+                                        <p:tgtEl>
+                                          <p:spTgt spid="25"/>
+                                        </p:tgtEl>
+                                      </p:cBhvr>
+                                    </p:animEffect>
+                                  </p:childTnLst>
+                                </p:cTn>
+                              </p:par>
+                              <p:par>
+                                <p:cTn id="76" presetID="10" presetClass="entr" presetSubtype="0" fill="hold" grpId="0" nodeType="withEffect">
+                                  <p:stCondLst>
+                                    <p:cond delay="0"/>
+                                  </p:stCondLst>
+                                  <p:childTnLst>
+                                    <p:set>
+                                      <p:cBhvr>
+                                        <p:cTn id="77" dur="1" fill="hold">
+                                          <p:stCondLst>
+                                            <p:cond delay="0"/>
+                                          </p:stCondLst>
+                                        </p:cTn>
+                                        <p:tgtEl>
+                                          <p:spTgt spid="26"/>
+                                        </p:tgtEl>
+                                        <p:attrNameLst>
+                                          <p:attrName>style.visibility</p:attrName>
+                                        </p:attrNameLst>
+                                      </p:cBhvr>
+                                      <p:to>
+                                        <p:strVal val="visible"/>
+                                      </p:to>
+                                    </p:set>
+                                    <p:animEffect transition="in" filter="fade">
+                                      <p:cBhvr>
+                                        <p:cTn id="78" dur="450"/>
+                                        <p:tgtEl>
+                                          <p:spTgt spid="26"/>
+                                        </p:tgtEl>
+                                      </p:cBhvr>
+                                    </p:animEffect>
+                                  </p:childTnLst>
+                                </p:cTn>
+                              </p:par>
+                              <p:par>
+                                <p:cTn id="79" presetID="10" presetClass="entr" presetSubtype="0" fill="hold" grpId="0" nodeType="withEffect">
+                                  <p:stCondLst>
+                                    <p:cond delay="0"/>
+                                  </p:stCondLst>
+                                  <p:childTnLst>
+                                    <p:set>
+                                      <p:cBhvr>
+                                        <p:cTn id="80" dur="1" fill="hold">
+                                          <p:stCondLst>
+                                            <p:cond delay="0"/>
+                                          </p:stCondLst>
+                                        </p:cTn>
+                                        <p:tgtEl>
+                                          <p:spTgt spid="27"/>
+                                        </p:tgtEl>
+                                        <p:attrNameLst>
+                                          <p:attrName>style.visibility</p:attrName>
+                                        </p:attrNameLst>
+                                      </p:cBhvr>
+                                      <p:to>
+                                        <p:strVal val="visible"/>
+                                      </p:to>
+                                    </p:set>
+                                    <p:animEffect transition="in" filter="fade">
+                                      <p:cBhvr>
+                                        <p:cTn id="81" dur="450"/>
+                                        <p:tgtEl>
+                                          <p:spTgt spid="27"/>
                                         </p:tgtEl>
                                       </p:cBhvr>
                                     </p:animEffect>
@@ -4515,12 +4651,13 @@
       <p:bldP spid="16" grpId="0" animBg="1"/>
       <p:bldP spid="17" grpId="0" animBg="1"/>
       <p:bldP spid="18" grpId="0" animBg="1"/>
-      <p:bldP spid="19" grpId="0" animBg="1"/>
       <p:bldP spid="20" grpId="0" animBg="1"/>
       <p:bldP spid="21" grpId="0" animBg="1"/>
-      <p:bldP spid="23" grpId="0" animBg="1"/>
+      <p:bldP spid="22" grpId="0" animBg="1"/>
       <p:bldP spid="24" grpId="0" animBg="1"/>
       <p:bldP spid="25" grpId="0" animBg="1"/>
+      <p:bldP spid="26" grpId="0" animBg="1"/>
+      <p:bldP spid="27" grpId="0" animBg="1"/>
     </p:bldLst>
   </p:timing>
 </p:sld>
@@ -4529,878 +4666,6 @@
 <file path=ppt/slides/slide3.xml><?xml version="1.0" encoding="utf-8"?>
 <p:sld xmlns:a="http://schemas.openxmlformats.org/drawingml/2006/main" xmlns:r="http://schemas.openxmlformats.org/officeDocument/2006/relationships" xmlns:p="http://schemas.openxmlformats.org/presentationml/2006/main">
   <p:cSld name="Slide 3">
-    <p:spTree>
-      <p:nvGrpSpPr>
-        <p:cNvPr id="1" name=""/>
-        <p:cNvGrpSpPr/>
-        <p:nvPr/>
-      </p:nvGrpSpPr>
-      <p:grpSpPr>
-        <a:xfrm>
-          <a:off x="0" y="0"/>
-          <a:ext cx="0" cy="0"/>
-          <a:chOff x="0" y="0"/>
-          <a:chExt cx="0" cy="0"/>
-        </a:xfrm>
-      </p:grpSpPr>
-      <p:sp>
-        <p:nvSpPr>
-          <p:cNvPr id="2" name="criterion"/>
-          <p:cNvSpPr txBox="1"/>
-          <p:nvPr/>
-        </p:nvSpPr>
-        <p:spPr>
-          <a:xfrm>
-            <a:off x="548640" y="201168"/>
-            <a:ext cx="5486400" cy="256032"/>
-          </a:xfrm>
-          <a:prstGeom prst="rect">
-            <a:avLst/>
-          </a:prstGeom>
-          <a:noFill/>
-          <a:ln/>
-        </p:spPr>
-        <p:txBody>
-          <a:bodyPr wrap="square" lIns="0" tIns="0" rIns="0" bIns="0" rtlCol="0" anchor="t"/>
-          <a:lstStyle/>
-          <a:p>
-            <a:pPr indent="0" marL="0">
-              <a:buNone/>
-            </a:pPr>
-            <a:r>
-              <a:rPr lang="en-US" sz="1100" b="1" spc="200" kern="0" dirty="0">
-                <a:solidFill>
-                  <a:schemeClr val="accent3"/>
-                </a:solidFill>
-              </a:rPr>
-              <a:t>THE STAKES · IMPACT</a:t>
-            </a:r>
-            <a:endParaRPr lang="en-US" sz="1100" dirty="0"/>
-          </a:p>
-        </p:txBody>
-      </p:sp>
-      <p:sp>
-        <p:nvSpPr>
-          <p:cNvPr id="3" name="Text 1"/>
-          <p:cNvSpPr/>
-          <p:nvPr>
-            <p:ph idx="101" type="title" hasCustomPrompt="1"/>
-          </p:nvPr>
-        </p:nvSpPr>
-        <p:spPr>
-          <a:xfrm>
-            <a:off x="548640" y="502920"/>
-            <a:ext cx="11094415" cy="822960"/>
-          </a:xfrm>
-          <a:prstGeom prst="rect">
-            <a:avLst/>
-          </a:prstGeom>
-          <a:noFill/>
-          <a:ln/>
-        </p:spPr>
-        <p:txBody>
-          <a:bodyPr wrap="square" lIns="0" tIns="0" rIns="0" bIns="0" rtlCol="0" anchor="t"/>
-          <a:lstStyle/>
-          <a:p>
-            <a:pPr algn="l" indent="0" marL="0">
-              <a:buNone/>
-            </a:pPr>
-            <a:r>
-              <a:rPr lang="en-US" sz="3600" b="1" dirty="0">
-                <a:solidFill>
-                  <a:schemeClr val="tx1"/>
-                </a:solidFill>
-              </a:rPr>
-              <a:t>Used across Airbus organisations and sites</a:t>
-            </a:r>
-            <a:endParaRPr lang="en-US" sz="3600" dirty="0"/>
-          </a:p>
-        </p:txBody>
-      </p:sp>
-      <p:sp>
-        <p:nvSpPr>
-          <p:cNvPr id="4" name="org-sub"/>
-          <p:cNvSpPr txBox="1"/>
-          <p:nvPr/>
-        </p:nvSpPr>
-        <p:spPr>
-          <a:xfrm>
-            <a:off x="548640" y="1115568"/>
-            <a:ext cx="11094415" cy="320040"/>
-          </a:xfrm>
-          <a:prstGeom prst="rect">
-            <a:avLst/>
-          </a:prstGeom>
-          <a:noFill/>
-          <a:ln/>
-        </p:spPr>
-        <p:txBody>
-          <a:bodyPr wrap="square" lIns="0" tIns="0" rIns="0" bIns="0" rtlCol="0" anchor="t"/>
-          <a:lstStyle/>
-          <a:p>
-            <a:pPr indent="0" marL="0">
-              <a:buNone/>
-            </a:pPr>
-            <a:r>
-              <a:rPr lang="en-US" sz="1400" dirty="0">
-                <a:solidFill>
-                  <a:schemeClr val="tx2"/>
-                </a:solidFill>
-              </a:rPr>
-              <a:t>More than half of ERM users work outside its largest organisation, across 6 countries</a:t>
-            </a:r>
-            <a:endParaRPr lang="en-US" sz="1400" dirty="0"/>
-          </a:p>
-        </p:txBody>
-      </p:sp>
-      <p:sp>
-        <p:nvSpPr>
-          <p:cNvPr id="5" name="org-card"/>
-          <p:cNvSpPr/>
-          <p:nvPr/>
-        </p:nvSpPr>
-        <p:spPr>
-          <a:xfrm>
-            <a:off x="548640" y="1600200"/>
-            <a:ext cx="6766560" cy="4846320"/>
-          </a:xfrm>
-          <a:prstGeom prst="roundRect">
-            <a:avLst>
-              <a:gd name="adj" fmla="val 2264"/>
-            </a:avLst>
-          </a:prstGeom>
-          <a:solidFill>
-            <a:schemeClr val="bg2"/>
-          </a:solidFill>
-          <a:ln/>
-        </p:spPr>
-      </p:sp>
-      <p:sp>
-        <p:nvSpPr>
-          <p:cNvPr id="6" name="org-title"/>
-          <p:cNvSpPr txBox="1"/>
-          <p:nvPr/>
-        </p:nvSpPr>
-        <p:spPr>
-          <a:xfrm>
-            <a:off x="777240" y="1709928"/>
-            <a:ext cx="6309360" cy="274320"/>
-          </a:xfrm>
-          <a:prstGeom prst="rect">
-            <a:avLst/>
-          </a:prstGeom>
-          <a:noFill/>
-          <a:ln/>
-        </p:spPr>
-        <p:txBody>
-          <a:bodyPr wrap="square" lIns="0" tIns="0" rIns="0" bIns="0" rtlCol="0" anchor="t"/>
-          <a:lstStyle/>
-          <a:p>
-            <a:pPr indent="0" marL="0">
-              <a:buNone/>
-            </a:pPr>
-            <a:r>
-              <a:rPr lang="en-US" sz="1100" b="1" spc="100" kern="0" dirty="0">
-                <a:solidFill>
-                  <a:schemeClr val="tx1"/>
-                </a:solidFill>
-              </a:rPr>
-              <a:t>UNIQUE USERS BY ORGANISATION (SIGLUM 1)</a:t>
-            </a:r>
-            <a:endParaRPr lang="en-US" sz="1100" dirty="0"/>
-          </a:p>
-        </p:txBody>
-      </p:sp>
-      <p:graphicFrame>
-        <p:nvGraphicFramePr>
-          <p:cNvPr id="7" name="org-chart" descr=""/>
-          <p:cNvGraphicFramePr/>
-          <p:nvPr/>
-        </p:nvGraphicFramePr>
-        <p:xfrm>
-          <a:off x="640080" y="2011680"/>
-          <a:ext cx="6583680" cy="3794760"/>
-        </p:xfrm>
-        <a:graphic xmlns:a="http://schemas.openxmlformats.org/drawingml/2006/main">
-          <a:graphicData uri="http://schemas.openxmlformats.org/drawingml/2006/chart">
-            <c:chart xmlns:c="http://schemas.openxmlformats.org/drawingml/2006/chart" r:id="rId1"/>
-          </a:graphicData>
-        </a:graphic>
-      </p:graphicFrame>
-      <p:sp>
-        <p:nvSpPr>
-          <p:cNvPr id="8" name="org-caption"/>
-          <p:cNvSpPr txBox="1"/>
-          <p:nvPr/>
-        </p:nvSpPr>
-        <p:spPr>
-          <a:xfrm>
-            <a:off x="777240" y="5852160"/>
-            <a:ext cx="6309360" cy="457200"/>
-          </a:xfrm>
-          <a:prstGeom prst="rect">
-            <a:avLst/>
-          </a:prstGeom>
-          <a:noFill/>
-          <a:ln/>
-        </p:spPr>
-        <p:txBody>
-          <a:bodyPr wrap="square" lIns="0" tIns="0" rIns="0" bIns="0" rtlCol="0" anchor="t"/>
-          <a:lstStyle/>
-          <a:p>
-            <a:pPr indent="0" marL="0">
-              <a:buNone/>
-            </a:pPr>
-            <a:r>
-              <a:rPr lang="en-US" sz="1000" i="1" dirty="0">
-                <a:solidFill>
-                  <a:schemeClr val="tx2"/>
-                </a:solidFill>
-              </a:rPr>
-              <a:t>Plus about 12 smaller organisations (D, M, Z, Q, G, F, H, I, V, E, T…). Approximate values, read from the ERM usage chart</a:t>
-            </a:r>
-            <a:endParaRPr lang="en-US" sz="1000" dirty="0"/>
-          </a:p>
-        </p:txBody>
-      </p:sp>
-      <p:sp>
-        <p:nvSpPr>
-          <p:cNvPr id="9" name="loc-card"/>
-          <p:cNvSpPr/>
-          <p:nvPr/>
-        </p:nvSpPr>
-        <p:spPr>
-          <a:xfrm>
-            <a:off x="7589520" y="1600200"/>
-            <a:ext cx="4050792" cy="4846320"/>
-          </a:xfrm>
-          <a:prstGeom prst="roundRect">
-            <a:avLst>
-              <a:gd name="adj" fmla="val 2709"/>
-            </a:avLst>
-          </a:prstGeom>
-          <a:solidFill>
-            <a:schemeClr val="tx1"/>
-          </a:solidFill>
-          <a:ln/>
-        </p:spPr>
-      </p:sp>
-      <p:sp>
-        <p:nvSpPr>
-          <p:cNvPr id="10" name="loc-title"/>
-          <p:cNvSpPr txBox="1"/>
-          <p:nvPr/>
-        </p:nvSpPr>
-        <p:spPr>
-          <a:xfrm>
-            <a:off x="7818120" y="1737360"/>
-            <a:ext cx="3657600" cy="274320"/>
-          </a:xfrm>
-          <a:prstGeom prst="rect">
-            <a:avLst/>
-          </a:prstGeom>
-          <a:noFill/>
-          <a:ln/>
-        </p:spPr>
-        <p:txBody>
-          <a:bodyPr wrap="square" lIns="0" tIns="0" rIns="0" bIns="0" rtlCol="0" anchor="t"/>
-          <a:lstStyle/>
-          <a:p>
-            <a:pPr indent="0" marL="0">
-              <a:buNone/>
-            </a:pPr>
-            <a:r>
-              <a:rPr lang="en-US" sz="1100" b="1" spc="200" kern="0" dirty="0">
-                <a:solidFill>
-                  <a:schemeClr val="accent5"/>
-                </a:solidFill>
-              </a:rPr>
-              <a:t>LOCATION PROFILE</a:t>
-            </a:r>
-            <a:endParaRPr lang="en-US" sz="1100" dirty="0"/>
-          </a:p>
-        </p:txBody>
-      </p:sp>
-      <p:sp>
-        <p:nvSpPr>
-          <p:cNvPr id="11" name="loc-list"/>
-          <p:cNvSpPr txBox="1"/>
-          <p:nvPr/>
-        </p:nvSpPr>
-        <p:spPr>
-          <a:xfrm>
-            <a:off x="7818120" y="2148840"/>
-            <a:ext cx="3657600" cy="4114800"/>
-          </a:xfrm>
-          <a:prstGeom prst="rect">
-            <a:avLst/>
-          </a:prstGeom>
-          <a:noFill/>
-          <a:ln/>
-        </p:spPr>
-        <p:txBody>
-          <a:bodyPr wrap="square" lIns="0" tIns="0" rIns="0" bIns="0" rtlCol="0" anchor="t"/>
-          <a:lstStyle/>
-          <a:p>
-            <a:pPr indent="0" marL="0">
-              <a:buNone/>
-            </a:pPr>
-            <a:r>
-              <a:rPr lang="en-US" sz="1500" b="1" dirty="0">
-                <a:solidFill>
-                  <a:schemeClr val="bg1"/>
-                </a:solidFill>
-              </a:rPr>
-              <a:t>France</a:t>
-            </a:r>
-            <a:endParaRPr lang="en-US" sz="1500" dirty="0"/>
-          </a:p>
-          <a:p>
-            <a:pPr indent="0" marL="0">
-              <a:spcAft>
-                <a:spcPts val="900"/>
-              </a:spcAft>
-              <a:buNone/>
-            </a:pPr>
-            <a:r>
-              <a:rPr lang="en-US" sz="1300" dirty="0">
-                <a:solidFill>
-                  <a:schemeClr val="accent5"/>
-                </a:solidFill>
-              </a:rPr>
-              <a:t>Blagnac Wings Campus 271, Saint-Martin 43 users</a:t>
-            </a:r>
-            <a:endParaRPr lang="en-US" sz="1500" dirty="0"/>
-          </a:p>
-          <a:p>
-            <a:pPr indent="0" marL="0">
-              <a:buNone/>
-            </a:pPr>
-            <a:r>
-              <a:rPr lang="en-US" sz="1500" b="1" dirty="0">
-                <a:solidFill>
-                  <a:schemeClr val="bg1"/>
-                </a:solidFill>
-              </a:rPr>
-              <a:t>Germany</a:t>
-            </a:r>
-            <a:endParaRPr lang="en-US" sz="1500" dirty="0"/>
-          </a:p>
-          <a:p>
-            <a:pPr indent="0" marL="0">
-              <a:spcAft>
-                <a:spcPts val="900"/>
-              </a:spcAft>
-              <a:buNone/>
-            </a:pPr>
-            <a:r>
-              <a:rPr lang="en-US" sz="1300" dirty="0">
-                <a:solidFill>
-                  <a:schemeClr val="accent5"/>
-                </a:solidFill>
-              </a:rPr>
-              <a:t>Hamburg Finkenwerder 205 users</a:t>
-            </a:r>
-            <a:endParaRPr lang="en-US" sz="1500" dirty="0"/>
-          </a:p>
-          <a:p>
-            <a:pPr indent="0" marL="0">
-              <a:buNone/>
-            </a:pPr>
-            <a:r>
-              <a:rPr lang="en-US" sz="1500" b="1" dirty="0">
-                <a:solidFill>
-                  <a:schemeClr val="bg1"/>
-                </a:solidFill>
-              </a:rPr>
-              <a:t>United Kingdom</a:t>
-            </a:r>
-            <a:endParaRPr lang="en-US" sz="1500" dirty="0"/>
-          </a:p>
-          <a:p>
-            <a:pPr indent="0" marL="0">
-              <a:spcAft>
-                <a:spcPts val="900"/>
-              </a:spcAft>
-              <a:buNone/>
-            </a:pPr>
-            <a:r>
-              <a:rPr lang="en-US" sz="1300" dirty="0">
-                <a:solidFill>
-                  <a:schemeClr val="accent5"/>
-                </a:solidFill>
-              </a:rPr>
-              <a:t>Broughton 32, Filton 26 users</a:t>
-            </a:r>
-            <a:endParaRPr lang="en-US" sz="1500" dirty="0"/>
-          </a:p>
-          <a:p>
-            <a:pPr indent="0" marL="0">
-              <a:buNone/>
-            </a:pPr>
-            <a:r>
-              <a:rPr lang="en-US" sz="1500" b="1" dirty="0">
-                <a:solidFill>
-                  <a:schemeClr val="bg1"/>
-                </a:solidFill>
-              </a:rPr>
-              <a:t>Spain</a:t>
-            </a:r>
-            <a:endParaRPr lang="en-US" sz="1500" dirty="0"/>
-          </a:p>
-          <a:p>
-            <a:pPr indent="0" marL="0">
-              <a:spcAft>
-                <a:spcPts val="900"/>
-              </a:spcAft>
-              <a:buNone/>
-            </a:pPr>
-            <a:r>
-              <a:rPr lang="en-US" sz="1300" dirty="0">
-                <a:solidFill>
-                  <a:schemeClr val="accent5"/>
-                </a:solidFill>
-              </a:rPr>
-              <a:t>Getafe 25 users</a:t>
-            </a:r>
-            <a:endParaRPr lang="en-US" sz="1500" dirty="0"/>
-          </a:p>
-          <a:p>
-            <a:pPr indent="0" marL="0">
-              <a:buNone/>
-            </a:pPr>
-            <a:r>
-              <a:rPr lang="en-US" sz="1500" b="1" dirty="0">
-                <a:solidFill>
-                  <a:schemeClr val="bg1"/>
-                </a:solidFill>
-              </a:rPr>
-              <a:t>Canada</a:t>
-            </a:r>
-            <a:endParaRPr lang="en-US" sz="1500" dirty="0"/>
-          </a:p>
-          <a:p>
-            <a:pPr indent="0" marL="0">
-              <a:spcAft>
-                <a:spcPts val="900"/>
-              </a:spcAft>
-              <a:buNone/>
-            </a:pPr>
-            <a:r>
-              <a:rPr lang="en-US" sz="1300" dirty="0">
-                <a:solidFill>
-                  <a:schemeClr val="accent5"/>
-                </a:solidFill>
-              </a:rPr>
-              <a:t>Mirabel 12 users</a:t>
-            </a:r>
-            <a:endParaRPr lang="en-US" sz="1500" dirty="0"/>
-          </a:p>
-          <a:p>
-            <a:pPr indent="0" marL="0">
-              <a:buNone/>
-            </a:pPr>
-            <a:r>
-              <a:rPr lang="en-US" sz="1500" b="1" dirty="0">
-                <a:solidFill>
-                  <a:schemeClr val="bg1"/>
-                </a:solidFill>
-              </a:rPr>
-              <a:t>India</a:t>
-            </a:r>
-            <a:endParaRPr lang="en-US" sz="1500" dirty="0"/>
-          </a:p>
-          <a:p>
-            <a:pPr indent="0" marL="0">
-              <a:spcAft>
-                <a:spcPts val="900"/>
-              </a:spcAft>
-              <a:buNone/>
-            </a:pPr>
-            <a:r>
-              <a:rPr lang="en-US" sz="1300" dirty="0">
-                <a:solidFill>
-                  <a:schemeClr val="accent5"/>
-                </a:solidFill>
-              </a:rPr>
-              <a:t>Bangalore 7 users</a:t>
-            </a:r>
-            <a:endParaRPr lang="en-US" sz="1500" dirty="0"/>
-          </a:p>
-        </p:txBody>
-      </p:sp>
-    </p:spTree>
-  </p:cSld>
-  <p:clrMapOvr>
-    <a:masterClrMapping/>
-  </p:clrMapOvr>
-  <p:transition spd="med">
-    <p:fade/>
-  </p:transition>
-  <p:timing>
-    <p:tnLst>
-      <p:par>
-        <p:cTn id="1" dur="indefinite" restart="never" nodeType="tmRoot">
-          <p:childTnLst>
-            <p:seq concurrent="1" nextAc="seek">
-              <p:cTn id="2" dur="indefinite" nodeType="mainSeq">
-                <p:childTnLst>
-                  <p:par>
-                    <p:cTn id="30" fill="hold">
-                      <p:stCondLst>
-                        <p:cond delay="indefinite"/>
-                        <p:cond evt="onBegin" delay="0">
-                          <p:tn val="2"/>
-                        </p:cond>
-                      </p:stCondLst>
-                      <p:childTnLst>
-                        <p:par>
-                          <p:cTn id="6" fill="hold">
-                            <p:stCondLst>
-                              <p:cond delay="0"/>
-                            </p:stCondLst>
-                            <p:childTnLst>
-                              <p:par>
-                                <p:cTn id="3" presetID="10" presetClass="entr" presetSubtype="0" fill="hold" grpId="0" nodeType="afterEffect">
-                                  <p:stCondLst>
-                                    <p:cond delay="0"/>
-                                  </p:stCondLst>
-                                  <p:childTnLst>
-                                    <p:set>
-                                      <p:cBhvr>
-                                        <p:cTn id="4" dur="1" fill="hold">
-                                          <p:stCondLst>
-                                            <p:cond delay="0"/>
-                                          </p:stCondLst>
-                                        </p:cTn>
-                                        <p:tgtEl>
-                                          <p:spTgt spid="4"/>
-                                        </p:tgtEl>
-                                        <p:attrNameLst>
-                                          <p:attrName>style.visibility</p:attrName>
-                                        </p:attrNameLst>
-                                      </p:cBhvr>
-                                      <p:to>
-                                        <p:strVal val="visible"/>
-                                      </p:to>
-                                    </p:set>
-                                    <p:animEffect transition="in" filter="fade">
-                                      <p:cBhvr>
-                                        <p:cTn id="5" dur="450"/>
-                                        <p:tgtEl>
-                                          <p:spTgt spid="4"/>
-                                        </p:tgtEl>
-                                      </p:cBhvr>
-                                    </p:animEffect>
-                                  </p:childTnLst>
-                                </p:cTn>
-                              </p:par>
-                            </p:childTnLst>
-                          </p:cTn>
-                        </p:par>
-                        <p:par>
-                          <p:cTn id="19" fill="hold">
-                            <p:stCondLst>
-                              <p:cond delay="500"/>
-                            </p:stCondLst>
-                            <p:childTnLst>
-                              <p:par>
-                                <p:cTn id="7" presetID="10" presetClass="entr" presetSubtype="0" fill="hold" grpId="0" nodeType="afterEffect">
-                                  <p:stCondLst>
-                                    <p:cond delay="0"/>
-                                  </p:stCondLst>
-                                  <p:childTnLst>
-                                    <p:set>
-                                      <p:cBhvr>
-                                        <p:cTn id="8" dur="1" fill="hold">
-                                          <p:stCondLst>
-                                            <p:cond delay="0"/>
-                                          </p:stCondLst>
-                                        </p:cTn>
-                                        <p:tgtEl>
-                                          <p:spTgt spid="5"/>
-                                        </p:tgtEl>
-                                        <p:attrNameLst>
-                                          <p:attrName>style.visibility</p:attrName>
-                                        </p:attrNameLst>
-                                      </p:cBhvr>
-                                      <p:to>
-                                        <p:strVal val="visible"/>
-                                      </p:to>
-                                    </p:set>
-                                    <p:animEffect transition="in" filter="fade">
-                                      <p:cBhvr>
-                                        <p:cTn id="9" dur="450"/>
-                                        <p:tgtEl>
-                                          <p:spTgt spid="5"/>
-                                        </p:tgtEl>
-                                      </p:cBhvr>
-                                    </p:animEffect>
-                                  </p:childTnLst>
-                                </p:cTn>
-                              </p:par>
-                              <p:par>
-                                <p:cTn id="10" presetID="10" presetClass="entr" presetSubtype="0" fill="hold" grpId="0" nodeType="withEffect">
-                                  <p:stCondLst>
-                                    <p:cond delay="0"/>
-                                  </p:stCondLst>
-                                  <p:childTnLst>
-                                    <p:set>
-                                      <p:cBhvr>
-                                        <p:cTn id="11" dur="1" fill="hold">
-                                          <p:stCondLst>
-                                            <p:cond delay="0"/>
-                                          </p:stCondLst>
-                                        </p:cTn>
-                                        <p:tgtEl>
-                                          <p:spTgt spid="6"/>
-                                        </p:tgtEl>
-                                        <p:attrNameLst>
-                                          <p:attrName>style.visibility</p:attrName>
-                                        </p:attrNameLst>
-                                      </p:cBhvr>
-                                      <p:to>
-                                        <p:strVal val="visible"/>
-                                      </p:to>
-                                    </p:set>
-                                    <p:animEffect transition="in" filter="fade">
-                                      <p:cBhvr>
-                                        <p:cTn id="12" dur="450"/>
-                                        <p:tgtEl>
-                                          <p:spTgt spid="6"/>
-                                        </p:tgtEl>
-                                      </p:cBhvr>
-                                    </p:animEffect>
-                                  </p:childTnLst>
-                                </p:cTn>
-                              </p:par>
-                              <p:par>
-                                <p:cTn id="13" presetID="22" presetClass="entr" presetSubtype="8" fill="hold" grpId="0" nodeType="withEffect">
-                                  <p:stCondLst>
-                                    <p:cond delay="200"/>
-                                  </p:stCondLst>
-                                  <p:childTnLst>
-                                    <p:set>
-                                      <p:cBhvr>
-                                        <p:cTn id="14" dur="1" fill="hold">
-                                          <p:stCondLst>
-                                            <p:cond delay="0"/>
-                                          </p:stCondLst>
-                                        </p:cTn>
-                                        <p:tgtEl>
-                                          <p:spTgt spid="7"/>
-                                        </p:tgtEl>
-                                        <p:attrNameLst>
-                                          <p:attrName>style.visibility</p:attrName>
-                                        </p:attrNameLst>
-                                      </p:cBhvr>
-                                      <p:to>
-                                        <p:strVal val="visible"/>
-                                      </p:to>
-                                    </p:set>
-                                    <p:animEffect transition="in" filter="wipe(left)">
-                                      <p:cBhvr>
-                                        <p:cTn id="15" dur="450"/>
-                                        <p:tgtEl>
-                                          <p:spTgt spid="7"/>
-                                        </p:tgtEl>
-                                      </p:cBhvr>
-                                    </p:animEffect>
-                                  </p:childTnLst>
-                                </p:cTn>
-                              </p:par>
-                              <p:par>
-                                <p:cTn id="16" presetID="10" presetClass="entr" presetSubtype="0" fill="hold" grpId="0" nodeType="withEffect">
-                                  <p:stCondLst>
-                                    <p:cond delay="200"/>
-                                  </p:stCondLst>
-                                  <p:childTnLst>
-                                    <p:set>
-                                      <p:cBhvr>
-                                        <p:cTn id="17" dur="1" fill="hold">
-                                          <p:stCondLst>
-                                            <p:cond delay="0"/>
-                                          </p:stCondLst>
-                                        </p:cTn>
-                                        <p:tgtEl>
-                                          <p:spTgt spid="8"/>
-                                        </p:tgtEl>
-                                        <p:attrNameLst>
-                                          <p:attrName>style.visibility</p:attrName>
-                                        </p:attrNameLst>
-                                      </p:cBhvr>
-                                      <p:to>
-                                        <p:strVal val="visible"/>
-                                      </p:to>
-                                    </p:set>
-                                    <p:animEffect transition="in" filter="fade">
-                                      <p:cBhvr>
-                                        <p:cTn id="18" dur="450"/>
-                                        <p:tgtEl>
-                                          <p:spTgt spid="8"/>
-                                        </p:tgtEl>
-                                      </p:cBhvr>
-                                    </p:animEffect>
-                                  </p:childTnLst>
-                                </p:cTn>
-                              </p:par>
-                            </p:childTnLst>
-                          </p:cTn>
-                        </p:par>
-                        <p:par>
-                          <p:cTn id="29" fill="hold">
-                            <p:stCondLst>
-                              <p:cond delay="1000"/>
-                            </p:stCondLst>
-                            <p:childTnLst>
-                              <p:par>
-                                <p:cTn id="20" presetID="10" presetClass="entr" presetSubtype="0" fill="hold" grpId="0" nodeType="afterEffect">
-                                  <p:stCondLst>
-                                    <p:cond delay="0"/>
-                                  </p:stCondLst>
-                                  <p:childTnLst>
-                                    <p:set>
-                                      <p:cBhvr>
-                                        <p:cTn id="21" dur="1" fill="hold">
-                                          <p:stCondLst>
-                                            <p:cond delay="0"/>
-                                          </p:stCondLst>
-                                        </p:cTn>
-                                        <p:tgtEl>
-                                          <p:spTgt spid="9"/>
-                                        </p:tgtEl>
-                                        <p:attrNameLst>
-                                          <p:attrName>style.visibility</p:attrName>
-                                        </p:attrNameLst>
-                                      </p:cBhvr>
-                                      <p:to>
-                                        <p:strVal val="visible"/>
-                                      </p:to>
-                                    </p:set>
-                                    <p:animEffect transition="in" filter="fade">
-                                      <p:cBhvr>
-                                        <p:cTn id="22" dur="450"/>
-                                        <p:tgtEl>
-                                          <p:spTgt spid="9"/>
-                                        </p:tgtEl>
-                                      </p:cBhvr>
-                                    </p:animEffect>
-                                  </p:childTnLst>
-                                </p:cTn>
-                              </p:par>
-                              <p:par>
-                                <p:cTn id="23" presetID="10" presetClass="entr" presetSubtype="0" fill="hold" grpId="0" nodeType="withEffect">
-                                  <p:stCondLst>
-                                    <p:cond delay="0"/>
-                                  </p:stCondLst>
-                                  <p:childTnLst>
-                                    <p:set>
-                                      <p:cBhvr>
-                                        <p:cTn id="24" dur="1" fill="hold">
-                                          <p:stCondLst>
-                                            <p:cond delay="0"/>
-                                          </p:stCondLst>
-                                        </p:cTn>
-                                        <p:tgtEl>
-                                          <p:spTgt spid="10"/>
-                                        </p:tgtEl>
-                                        <p:attrNameLst>
-                                          <p:attrName>style.visibility</p:attrName>
-                                        </p:attrNameLst>
-                                      </p:cBhvr>
-                                      <p:to>
-                                        <p:strVal val="visible"/>
-                                      </p:to>
-                                    </p:set>
-                                    <p:animEffect transition="in" filter="fade">
-                                      <p:cBhvr>
-                                        <p:cTn id="25" dur="450"/>
-                                        <p:tgtEl>
-                                          <p:spTgt spid="10"/>
-                                        </p:tgtEl>
-                                      </p:cBhvr>
-                                    </p:animEffect>
-                                  </p:childTnLst>
-                                </p:cTn>
-                              </p:par>
-                              <p:par>
-                                <p:cTn id="26" presetID="10" presetClass="entr" presetSubtype="0" fill="hold" grpId="0" nodeType="withEffect">
-                                  <p:stCondLst>
-                                    <p:cond delay="0"/>
-                                  </p:stCondLst>
-                                  <p:childTnLst>
-                                    <p:set>
-                                      <p:cBhvr>
-                                        <p:cTn id="27" dur="1" fill="hold">
-                                          <p:stCondLst>
-                                            <p:cond delay="0"/>
-                                          </p:stCondLst>
-                                        </p:cTn>
-                                        <p:tgtEl>
-                                          <p:spTgt spid="11"/>
-                                        </p:tgtEl>
-                                        <p:attrNameLst>
-                                          <p:attrName>style.visibility</p:attrName>
-                                        </p:attrNameLst>
-                                      </p:cBhvr>
-                                      <p:to>
-                                        <p:strVal val="visible"/>
-                                      </p:to>
-                                    </p:set>
-                                    <p:animEffect transition="in" filter="fade">
-                                      <p:cBhvr>
-                                        <p:cTn id="28" dur="450"/>
-                                        <p:tgtEl>
-                                          <p:spTgt spid="11"/>
-                                        </p:tgtEl>
-                                      </p:cBhvr>
-                                    </p:animEffect>
-                                  </p:childTnLst>
-                                </p:cTn>
-                              </p:par>
-                            </p:childTnLst>
-                          </p:cTn>
-                        </p:par>
-                      </p:childTnLst>
-                    </p:cTn>
-                  </p:par>
-                </p:childTnLst>
-              </p:cTn>
-              <p:prevCondLst>
-                <p:cond evt="onPrev" delay="0">
-                  <p:tgtEl>
-                    <p:sldTgt/>
-                  </p:tgtEl>
-                </p:cond>
-              </p:prevCondLst>
-              <p:nextCondLst>
-                <p:cond evt="onNext" delay="0">
-                  <p:tgtEl>
-                    <p:sldTgt/>
-                  </p:tgtEl>
-                </p:cond>
-              </p:nextCondLst>
-            </p:seq>
-          </p:childTnLst>
-        </p:cTn>
-      </p:par>
-    </p:tnLst>
-    <p:bldLst>
-      <p:bldP spid="4" grpId="0" animBg="1"/>
-      <p:bldP spid="5" grpId="0" animBg="1"/>
-      <p:bldP spid="6" grpId="0" animBg="1"/>
-      <p:bldP spid="8" grpId="0" animBg="1"/>
-      <p:bldP spid="9" grpId="0" animBg="1"/>
-      <p:bldP spid="10" grpId="0" animBg="1"/>
-      <p:bldP spid="11" grpId="0" animBg="1"/>
-    </p:bldLst>
-  </p:timing>
-</p:sld>
-</file>
-
-<file path=ppt/slides/slide4.xml><?xml version="1.0" encoding="utf-8"?>
-<p:sld xmlns:a="http://schemas.openxmlformats.org/drawingml/2006/main" xmlns:r="http://schemas.openxmlformats.org/officeDocument/2006/relationships" xmlns:p="http://schemas.openxmlformats.org/presentationml/2006/main">
-  <p:cSld name="Slide 4">
     <p:spTree>
       <p:nvGrpSpPr>
         <p:cNvPr id="1" name=""/>
@@ -6333,9 +5598,9 @@
 </p:sld>
 </file>
 
-<file path=ppt/slides/slide5.xml><?xml version="1.0" encoding="utf-8"?>
+<file path=ppt/slides/slide4.xml><?xml version="1.0" encoding="utf-8"?>
 <p:sld xmlns:a="http://schemas.openxmlformats.org/drawingml/2006/main" xmlns:r="http://schemas.openxmlformats.org/officeDocument/2006/relationships" xmlns:p="http://schemas.openxmlformats.org/presentationml/2006/main">
-  <p:cSld name="Slide 5">
+  <p:cSld name="Slide 4">
     <p:spTree>
       <p:nvGrpSpPr>
         <p:cNvPr id="1" name=""/>
@@ -7997,9 +7262,9 @@
 </p:sld>
 </file>
 
-<file path=ppt/slides/slide6.xml><?xml version="1.0" encoding="utf-8"?>
+<file path=ppt/slides/slide5.xml><?xml version="1.0" encoding="utf-8"?>
 <p:sld xmlns:a="http://schemas.openxmlformats.org/drawingml/2006/main" xmlns:r="http://schemas.openxmlformats.org/officeDocument/2006/relationships" xmlns:p="http://schemas.openxmlformats.org/presentationml/2006/main">
-  <p:cSld name="Slide 6">
+  <p:cSld name="Slide 5">
     <p:spTree>
       <p:nvGrpSpPr>
         <p:cNvPr id="1" name=""/>
@@ -10111,9 +9376,9 @@
 </p:sld>
 </file>
 
-<file path=ppt/slides/slide7.xml><?xml version="1.0" encoding="utf-8"?>
+<file path=ppt/slides/slide6.xml><?xml version="1.0" encoding="utf-8"?>
 <p:sld xmlns:a="http://schemas.openxmlformats.org/drawingml/2006/main" xmlns:r="http://schemas.openxmlformats.org/officeDocument/2006/relationships" xmlns:p="http://schemas.openxmlformats.org/presentationml/2006/main">
-  <p:cSld name="Slide 7">
+  <p:cSld name="Slide 6">
     <p:spTree>
       <p:nvGrpSpPr>
         <p:cNvPr id="1" name=""/>
@@ -11229,9 +10494,9 @@
 </p:sld>
 </file>
 
-<file path=ppt/slides/slide8.xml><?xml version="1.0" encoding="utf-8"?>
+<file path=ppt/slides/slide7.xml><?xml version="1.0" encoding="utf-8"?>
 <p:sld xmlns:a="http://schemas.openxmlformats.org/drawingml/2006/main" xmlns:r="http://schemas.openxmlformats.org/officeDocument/2006/relationships" xmlns:p="http://schemas.openxmlformats.org/presentationml/2006/main">
-  <p:cSld name="Slide 8">
+  <p:cSld name="Slide 7">
     <p:spTree>
       <p:nvGrpSpPr>
         <p:cNvPr id="1" name=""/>
@@ -13440,9 +12705,9 @@
 </p:sld>
 </file>
 
-<file path=ppt/slides/slide9.xml><?xml version="1.0" encoding="utf-8"?>
+<file path=ppt/slides/slide8.xml><?xml version="1.0" encoding="utf-8"?>
 <p:sld xmlns:a="http://schemas.openxmlformats.org/drawingml/2006/main" xmlns:r="http://schemas.openxmlformats.org/officeDocument/2006/relationships" xmlns:p="http://schemas.openxmlformats.org/presentationml/2006/main">
-  <p:cSld name="Slide 9">
+  <p:cSld name="Slide 8">
     <p:spTree>
       <p:nvGrpSpPr>
         <p:cNvPr id="1" name=""/>

</xml_diff>

<commit_message>
Make 76% the hero figure on the jury pitch effort slides
Highlight 76% over $80K and reduce the other figures, per review comment.

Co-Authored-By: Claude Opus 5.5 <noreply@anthropic.com>
Claude-Session: https://claude.ai/code/session_01HdxEbeqqWM97gKbcNqpjAq
</commit_message>
<xml_diff>
--- a/erm-migration/docs/ERM-Migration-Jury-Pitch-v2.pptx
+++ b/erm-migration/docs/ERM-Migration-Jury-Pitch-v2.pptx
@@ -114,29 +114,29 @@
   <p:extLst>
     <p:ext uri="{521415D9-36F7-43E2-AB2F-B90AF26B5E84}">
       <p14:sectionLst xmlns:p14="http://schemas.microsoft.com/office/powerpoint/2010/main">
-        <p14:section name="Answer" id="{0913389d-fe40-4b35-f775-02699813e442}">
+        <p14:section name="Answer" id="{0c9102bd-de24-1a40-3cd7-66899d9b8a4d}">
           <p14:sldIdLst>
             <p14:sldId id="256"/>
           </p14:sldIdLst>
         </p14:section>
-        <p14:section name="Situation" id="{146a4fb3-8002-73a2-d75a-f0dde4e461f6}">
+        <p14:section name="Situation" id="{575cb915-eda1-78be-e9c9-ed63045de3c0}">
           <p14:sldIdLst>
             <p14:sldId id="257"/>
           </p14:sldIdLst>
         </p14:section>
-        <p14:section name="Complication" id="{d885f62a-c52e-d037-7740-af94192bdde2}">
+        <p14:section name="Complication" id="{998a9552-1738-d842-bff5-906e599fcd7b}">
           <p14:sldIdLst>
             <p14:sldId id="258"/>
           </p14:sldIdLst>
         </p14:section>
-        <p14:section name="Answer and proof" id="{42e58e2e-fad3-005b-75d5-487b91187fdd}">
+        <p14:section name="Answer and proof" id="{67216c52-7a96-fa12-0a94-9bd6b26eeb0f}">
           <p14:sldIdLst>
             <p14:sldId id="259"/>
             <p14:sldId id="260"/>
             <p14:sldId id="261"/>
           </p14:sldIdLst>
         </p14:section>
-        <p14:section name="Fit and scale" id="{2cc562e5-8b4b-126e-e637-732b1c97a085}">
+        <p14:section name="Fit and scale" id="{96c0e62f-2d65-037d-ac8b-1eddce0c0a57}">
           <p14:sldIdLst>
             <p14:sldId id="262"/>
             <p14:sldId id="263"/>
@@ -1535,7 +1535,7 @@
           <a:p>
             <a:r>
               <a:rPr lang="en-US" dirty="0"/>
-              <a:t>The proof, hard facts first. One PI. Two developers. All 105 features carried over and checked. The AI review found and prioritised 31 gaps, including 7 security and data-integrity issues, all caught in review; the dashboard sharing-access fix is deployed. We also built 11 features Slate never had: permissions-only edit for locked versions, a web address per tab, a searchable dashboard switcher, a criticality-differs filter, category and impact-category filters, a fourth one-pager layout with custom slots, resizable columns saved per board, report classification and cover toggle, slideshow mode, one-pager selection shortcuts, and showing risks by ID or title. Documentation went from nothing to 10 documents. Building features is now easy: in Slate a feature meant wiring widgets, events and variables across 8 exports with no documentation; in React it is one typed component and one OSDK call, pack-project.ts gives AI the whole app, and 25 MB of Slate configuration became 0.8 MB of typed code. On cost: against a generic estimate of about 340 person-days, roughly 17 sprints for two developers, we used 4 sprints, about 76% less effort; at $38.50 per developer hour that is roughly $105,000 against $25,000, around $80,000 saved. Maintenance: with a rule of thumb of 20% of build effort a year, a Slate-equivalent app needs about $21,000 a year; assuming modular, typed, documented code halves that, we save around $10,000 a year. Say clearly these are estimates. Security and data-integrity findings caught in review: stored cross-site scripting from unsanitised rich HTML in 5 places; permission checks that matched e-mails by substring instead of exactly; sharing payload arrays misaligned with the wrong fields; settings JSON overwritten whole from a stale copy; reports printing shared risks the legacy app left out; no 100-risk print cap, a legacy cybersecurity limit; and children edits in the risk drawer silently discarded.</a:t>
+              <a:t>The proof, hard facts first. One PI. Two developers. All 105 features carried over and checked. The AI review found and prioritised 31 gaps, including 7 security and data-integrity issues, all caught in review; the dashboard sharing-access fix is deployed. We also built 11 features Slate never had: permissions-only edit for locked versions, a web address per tab, a searchable dashboard switcher, a criticality-differs filter, category and impact-category filters, a fourth one-pager layout with custom slots, resizable columns saved per board, report classification and cover toggle, slideshow mode, one-pager selection shortcuts, and showing risks by ID or title. Documentation went from nothing to 10 documents. Building features is now easy: in Slate a feature meant wiring widgets, events and variables across 8 exports with no documentation; in React it is one typed component and one OSDK call, pack-project.ts gives AI the whole app, and 25 MB of Slate configuration became 0.8 MB of typed code. On cost, the headline is 76%: against a generic estimate of about 340 person-days, roughly 17 sprints for two developers, we used 4 sprints, about 76% less effort; at $38.50 per developer hour that is roughly $105,000 against $25,000, around $80,000 saved. Maintenance: with a rule of thumb of 20% of build effort a year, a Slate-equivalent app needs about $21,000 a year; assuming modular, typed, documented code halves that, we save around $10,000 a year. Say clearly these are estimates. Security and data-integrity findings caught in review: stored cross-site scripting from unsanitised rich HTML in 5 places; permission checks that matched e-mails by substring instead of exactly; sharing payload arrays misaligned with the wrong fields; settings JSON overwritten whole from a stale copy; reports printing shared risks the legacy app left out; no 100-risk print cap, a legacy cybersecurity limit; and children edits in the risk drawer silently discarded.</a:t>
             </a:r>
             <a:endParaRPr lang="en-US" dirty="0"/>
           </a:p>
@@ -7400,14 +7400,14 @@
               <a:buNone/>
             </a:pPr>
             <a:r>
-              <a:rPr lang="en-US" sz="3000" b="1" dirty="0">
+              <a:rPr lang="en-US" sz="2200" b="1" dirty="0">
                 <a:solidFill>
                   <a:schemeClr val="tx1"/>
                 </a:solidFill>
               </a:rPr>
               <a:t>1 PI</a:t>
             </a:r>
-            <a:endParaRPr lang="en-US" sz="3000" dirty="0"/>
+            <a:endParaRPr lang="en-US" sz="2200" dirty="0"/>
           </a:p>
         </p:txBody>
       </p:sp>
@@ -7419,8 +7419,8 @@
         </p:nvSpPr>
         <p:spPr>
           <a:xfrm>
-            <a:off x="713232" y="2103120"/>
-            <a:ext cx="1367485" cy="640080"/>
+            <a:off x="713232" y="2011680"/>
+            <a:ext cx="1367485" cy="685800"/>
           </a:xfrm>
           <a:prstGeom prst="rect">
             <a:avLst/>
@@ -7436,14 +7436,14 @@
               <a:buNone/>
             </a:pPr>
             <a:r>
-              <a:rPr lang="en-US" sz="1300" dirty="0">
+              <a:rPr lang="en-US" sz="1200" dirty="0">
                 <a:solidFill>
                   <a:schemeClr val="tx2"/>
                 </a:solidFill>
               </a:rPr>
               <a:t>2 developers, whole migration</a:t>
             </a:r>
-            <a:endParaRPr lang="en-US" sz="1300" dirty="0"/>
+            <a:endParaRPr lang="en-US" sz="1200" dirty="0"/>
           </a:p>
         </p:txBody>
       </p:sp>
@@ -7494,14 +7494,14 @@
               <a:buNone/>
             </a:pPr>
             <a:r>
-              <a:rPr lang="en-US" sz="3000" b="1" dirty="0">
+              <a:rPr lang="en-US" sz="2200" b="1" dirty="0">
                 <a:solidFill>
                   <a:schemeClr val="tx1"/>
                 </a:solidFill>
               </a:rPr>
               <a:t>105</a:t>
             </a:r>
-            <a:endParaRPr lang="en-US" sz="3000" dirty="0"/>
+            <a:endParaRPr lang="en-US" sz="2200" dirty="0"/>
           </a:p>
         </p:txBody>
       </p:sp>
@@ -7513,8 +7513,8 @@
         </p:nvSpPr>
         <p:spPr>
           <a:xfrm>
-            <a:off x="2592781" y="2103120"/>
-            <a:ext cx="1367485" cy="640080"/>
+            <a:off x="2592781" y="2011680"/>
+            <a:ext cx="1367485" cy="685800"/>
           </a:xfrm>
           <a:prstGeom prst="rect">
             <a:avLst/>
@@ -7530,14 +7530,14 @@
               <a:buNone/>
             </a:pPr>
             <a:r>
-              <a:rPr lang="en-US" sz="1300" dirty="0">
+              <a:rPr lang="en-US" sz="1200" dirty="0">
                 <a:solidFill>
                   <a:schemeClr val="tx2"/>
                 </a:solidFill>
               </a:rPr>
               <a:t>features carried over and checked</a:t>
             </a:r>
-            <a:endParaRPr lang="en-US" sz="1300" dirty="0"/>
+            <a:endParaRPr lang="en-US" sz="1200" dirty="0"/>
           </a:p>
         </p:txBody>
       </p:sp>
@@ -7588,14 +7588,14 @@
               <a:buNone/>
             </a:pPr>
             <a:r>
-              <a:rPr lang="en-US" sz="3000" b="1" dirty="0">
+              <a:rPr lang="en-US" sz="2200" b="1" dirty="0">
                 <a:solidFill>
                   <a:schemeClr val="tx1"/>
                 </a:solidFill>
               </a:rPr>
               <a:t>31</a:t>
             </a:r>
-            <a:endParaRPr lang="en-US" sz="3000" dirty="0"/>
+            <a:endParaRPr lang="en-US" sz="2200" dirty="0"/>
           </a:p>
         </p:txBody>
       </p:sp>
@@ -7607,8 +7607,8 @@
         </p:nvSpPr>
         <p:spPr>
           <a:xfrm>
-            <a:off x="4472330" y="2103120"/>
-            <a:ext cx="1367485" cy="640080"/>
+            <a:off x="4472330" y="2011680"/>
+            <a:ext cx="1367485" cy="685800"/>
           </a:xfrm>
           <a:prstGeom prst="rect">
             <a:avLst/>
@@ -7624,14 +7624,14 @@
               <a:buNone/>
             </a:pPr>
             <a:r>
-              <a:rPr lang="en-US" sz="1300" dirty="0">
+              <a:rPr lang="en-US" sz="1200" dirty="0">
                 <a:solidFill>
                   <a:schemeClr val="tx2"/>
                 </a:solidFill>
               </a:rPr>
               <a:t>gaps found by AI review</a:t>
             </a:r>
-            <a:endParaRPr lang="en-US" sz="1300" dirty="0"/>
+            <a:endParaRPr lang="en-US" sz="1200" dirty="0"/>
           </a:p>
         </p:txBody>
       </p:sp>
@@ -7682,14 +7682,14 @@
               <a:buNone/>
             </a:pPr>
             <a:r>
-              <a:rPr lang="en-US" sz="3000" b="1" dirty="0">
-                <a:solidFill>
-                  <a:schemeClr val="accent3"/>
+              <a:rPr lang="en-US" sz="2200" b="1" dirty="0">
+                <a:solidFill>
+                  <a:schemeClr val="tx1"/>
                 </a:solidFill>
               </a:rPr>
               <a:t>7</a:t>
             </a:r>
-            <a:endParaRPr lang="en-US" sz="3000" dirty="0"/>
+            <a:endParaRPr lang="en-US" sz="2200" dirty="0"/>
           </a:p>
         </p:txBody>
       </p:sp>
@@ -7701,8 +7701,8 @@
         </p:nvSpPr>
         <p:spPr>
           <a:xfrm>
-            <a:off x="6351880" y="2103120"/>
-            <a:ext cx="1367485" cy="640080"/>
+            <a:off x="6351880" y="2011680"/>
+            <a:ext cx="1367485" cy="685800"/>
           </a:xfrm>
           <a:prstGeom prst="rect">
             <a:avLst/>
@@ -7718,14 +7718,14 @@
               <a:buNone/>
             </a:pPr>
             <a:r>
-              <a:rPr lang="en-US" sz="1300" dirty="0">
+              <a:rPr lang="en-US" sz="1200" dirty="0">
                 <a:solidFill>
                   <a:schemeClr val="tx2"/>
                 </a:solidFill>
               </a:rPr>
               <a:t>security issues caught in review</a:t>
             </a:r>
-            <a:endParaRPr lang="en-US" sz="1300" dirty="0"/>
+            <a:endParaRPr lang="en-US" sz="1200" dirty="0"/>
           </a:p>
         </p:txBody>
       </p:sp>
@@ -7776,14 +7776,14 @@
               <a:buNone/>
             </a:pPr>
             <a:r>
-              <a:rPr lang="en-US" sz="3000" b="1" dirty="0">
-                <a:solidFill>
-                  <a:schemeClr val="accent3"/>
+              <a:rPr lang="en-US" sz="2200" b="1" dirty="0">
+                <a:solidFill>
+                  <a:schemeClr val="tx1"/>
                 </a:solidFill>
               </a:rPr>
               <a:t>11</a:t>
             </a:r>
-            <a:endParaRPr lang="en-US" sz="3000" dirty="0"/>
+            <a:endParaRPr lang="en-US" sz="2200" dirty="0"/>
           </a:p>
         </p:txBody>
       </p:sp>
@@ -7795,8 +7795,8 @@
         </p:nvSpPr>
         <p:spPr>
           <a:xfrm>
-            <a:off x="8231429" y="2103120"/>
-            <a:ext cx="1367485" cy="640080"/>
+            <a:off x="8231429" y="2011680"/>
+            <a:ext cx="1367485" cy="685800"/>
           </a:xfrm>
           <a:prstGeom prst="rect">
             <a:avLst/>
@@ -7812,14 +7812,14 @@
               <a:buNone/>
             </a:pPr>
             <a:r>
-              <a:rPr lang="en-US" sz="1300" dirty="0">
+              <a:rPr lang="en-US" sz="1200" dirty="0">
                 <a:solidFill>
                   <a:schemeClr val="tx2"/>
                 </a:solidFill>
               </a:rPr>
               <a:t>new features Slate never had</a:t>
             </a:r>
-            <a:endParaRPr lang="en-US" sz="1300" dirty="0"/>
+            <a:endParaRPr lang="en-US" sz="1200" dirty="0"/>
           </a:p>
         </p:txBody>
       </p:sp>
@@ -7870,14 +7870,14 @@
               <a:buNone/>
             </a:pPr>
             <a:r>
-              <a:rPr lang="en-US" sz="3000" b="1" dirty="0">
+              <a:rPr lang="en-US" sz="2200" b="1" dirty="0">
                 <a:solidFill>
                   <a:schemeClr val="tx1"/>
                 </a:solidFill>
               </a:rPr>
               <a:t>0 → 10</a:t>
             </a:r>
-            <a:endParaRPr lang="en-US" sz="3000" dirty="0"/>
+            <a:endParaRPr lang="en-US" sz="2200" dirty="0"/>
           </a:p>
         </p:txBody>
       </p:sp>
@@ -7889,8 +7889,8 @@
         </p:nvSpPr>
         <p:spPr>
           <a:xfrm>
-            <a:off x="10110978" y="2103120"/>
-            <a:ext cx="1367485" cy="640080"/>
+            <a:off x="10110978" y="2011680"/>
+            <a:ext cx="1367485" cy="685800"/>
           </a:xfrm>
           <a:prstGeom prst="rect">
             <a:avLst/>
@@ -7906,14 +7906,14 @@
               <a:buNone/>
             </a:pPr>
             <a:r>
-              <a:rPr lang="en-US" sz="1300" dirty="0">
+              <a:rPr lang="en-US" sz="1200" dirty="0">
                 <a:solidFill>
                   <a:schemeClr val="tx2"/>
                 </a:solidFill>
               </a:rPr>
               <a:t>documents: 8 diagrams, 2 guides</a:t>
             </a:r>
-            <a:endParaRPr lang="en-US" sz="1300" dirty="0"/>
+            <a:endParaRPr lang="en-US" sz="1200" dirty="0"/>
           </a:p>
         </p:txBody>
       </p:sp>
@@ -8221,77 +8221,77 @@
           <a:ln/>
         </p:spPr>
         <p:txBody>
-          <a:bodyPr wrap="square" lIns="0" tIns="0" rIns="0" bIns="0" rtlCol="0" anchor="t"/>
+          <a:bodyPr wrap="square" lIns="0" tIns="0" rIns="0" bIns="0" rtlCol="0" anchor="ctr"/>
           <a:lstStyle/>
           <a:p>
             <a:pPr indent="0" marL="0">
               <a:buNone/>
             </a:pPr>
             <a:r>
-              <a:rPr lang="en-US" sz="4000" b="1" dirty="0">
+              <a:rPr lang="en-US" sz="7200" b="1" dirty="0">
                 <a:solidFill>
                   <a:schemeClr val="bg1"/>
                 </a:solidFill>
               </a:rPr>
-              <a:t>~$80K</a:t>
-            </a:r>
-            <a:endParaRPr lang="en-US" sz="4000" dirty="0"/>
+              <a:t>~76%</a:t>
+            </a:r>
+            <a:endParaRPr lang="en-US" sz="7200" dirty="0"/>
           </a:p>
           <a:p>
             <a:pPr indent="0" marL="0">
               <a:buNone/>
             </a:pPr>
             <a:r>
-              <a:rPr lang="en-US" sz="1400" b="1" dirty="0">
+              <a:rPr lang="en-US" sz="1600" b="1" dirty="0">
                 <a:solidFill>
                   <a:schemeClr val="bg1"/>
                 </a:solidFill>
               </a:rPr>
-              <a:t>saved: about 76% less effort than a manual migration</a:t>
-            </a:r>
-            <a:endParaRPr lang="en-US" sz="4000" dirty="0"/>
+              <a:t>less effort than a manual migration</a:t>
+            </a:r>
+            <a:endParaRPr lang="en-US" sz="7200" dirty="0"/>
           </a:p>
           <a:p>
             <a:pPr indent="0" marL="0">
               <a:buNone/>
             </a:pPr>
             <a:r>
-              <a:rPr lang="en-US" sz="800" dirty="0">
+              <a:rPr lang="en-US" sz="1200" dirty="0">
                 <a:solidFill>
                   <a:srgbClr val="000000"/>
                 </a:solidFill>
               </a:rPr>
               <a:t> </a:t>
             </a:r>
-            <a:endParaRPr lang="en-US" sz="4000" dirty="0"/>
+            <a:endParaRPr lang="en-US" sz="7200" dirty="0"/>
           </a:p>
           <a:p>
             <a:pPr indent="0" marL="0">
               <a:buNone/>
             </a:pPr>
             <a:r>
-              <a:rPr lang="en-US" sz="2800" b="1" dirty="0">
-                <a:solidFill>
-                  <a:schemeClr val="bg1"/>
-                </a:solidFill>
-              </a:rPr>
-              <a:t>~$10K a year</a:t>
-            </a:r>
-            <a:endParaRPr lang="en-US" sz="4000" dirty="0"/>
+              <a:rPr lang="en-US" sz="1300" dirty="0">
+                <a:solidFill>
+                  <a:schemeClr val="accent5"/>
+                </a:solidFill>
+              </a:rPr>
+              <a:t>≈ $80K saved on the build</a:t>
+            </a:r>
+            <a:endParaRPr lang="en-US" sz="7200" dirty="0"/>
           </a:p>
           <a:p>
             <a:pPr indent="0" marL="0">
               <a:buNone/>
             </a:pPr>
             <a:r>
-              <a:rPr lang="en-US" sz="1400" dirty="0">
+              <a:rPr lang="en-US" sz="1300" dirty="0">
                 <a:solidFill>
                   <a:schemeClr val="accent5"/>
                 </a:solidFill>
               </a:rPr>
-              <a:t>less maintenance effort</a:t>
-            </a:r>
-            <a:endParaRPr lang="en-US" sz="4000" dirty="0"/>
+              <a:t>≈ $10K a year less maintenance</a:t>
+            </a:r>
+            <a:endParaRPr lang="en-US" sz="7200" dirty="0"/>
           </a:p>
         </p:txBody>
       </p:sp>

</xml_diff>

<commit_message>
Rewrite v2 jury pitch speaker notes as a one-minute story per slide
Co-Authored-By: Claude Opus 5.5 <noreply@anthropic.com>
Claude-Session: https://claude.ai/code/session_01HdxEbeqqWM97gKbcNqpjAq
</commit_message>
<xml_diff>
--- a/erm-migration/docs/ERM-Migration-Jury-Pitch-v2.pptx
+++ b/erm-migration/docs/ERM-Migration-Jury-Pitch-v2.pptx
@@ -114,29 +114,29 @@
   <p:extLst>
     <p:ext uri="{521415D9-36F7-43E2-AB2F-B90AF26B5E84}">
       <p14:sectionLst xmlns:p14="http://schemas.microsoft.com/office/powerpoint/2010/main">
-        <p14:section name="Answer" id="{0c9102bd-de24-1a40-3cd7-66899d9b8a4d}">
+        <p14:section name="Answer" id="{1462c2d2-a28e-1426-4334-9057c175f087}">
           <p14:sldIdLst>
             <p14:sldId id="256"/>
           </p14:sldIdLst>
         </p14:section>
-        <p14:section name="Situation" id="{575cb915-eda1-78be-e9c9-ed63045de3c0}">
+        <p14:section name="Situation" id="{0bdc2fe9-a12e-e1a5-dd35-4ae85bc175b1}">
           <p14:sldIdLst>
             <p14:sldId id="257"/>
           </p14:sldIdLst>
         </p14:section>
-        <p14:section name="Complication" id="{998a9552-1738-d842-bff5-906e599fcd7b}">
+        <p14:section name="Complication" id="{ee7d66fd-c8d9-e1d4-ffbe-40c3c7797043}">
           <p14:sldIdLst>
             <p14:sldId id="258"/>
           </p14:sldIdLst>
         </p14:section>
-        <p14:section name="Answer and proof" id="{67216c52-7a96-fa12-0a94-9bd6b26eeb0f}">
+        <p14:section name="Answer and proof" id="{c59aff3a-e285-f65e-8047-67920dc97003}">
           <p14:sldIdLst>
             <p14:sldId id="259"/>
             <p14:sldId id="260"/>
             <p14:sldId id="261"/>
           </p14:sldIdLst>
         </p14:section>
-        <p14:section name="Fit and scale" id="{96c0e62f-2d65-037d-ac8b-1eddce0c0a57}">
+        <p14:section name="Fit and scale" id="{712f7c34-fa96-d320-ec5b-87ebdda4b3a9}">
           <p14:sldIdLst>
             <p14:sldId id="262"/>
             <p14:sldId id="263"/>
@@ -1183,7 +1183,10 @@
           <a:p>
             <a:r>
               <a:rPr lang="en-US" dirty="0"/>
-              <a:t>Give the answer first, in one breath: two developers rebuilt ERM, a business-critical Slate application with no documentation, for Airbus DevX with React and OSDK in a single PI, ready for go-live, using an AI-assisted method we designed and that any team can reuse. Then: let me show you why that was hard, what we did differently, and the proof.</a:t>
+              <a:t>In the next few minutes I'd like to tell you how two of us rebuilt a business-critical application in a single PI, and why the way we did it matters for more than this one app.
+The application is ERM, Enterprise Risk Management. If you haven't used it, it's where Airbus risk managers keep track of their risks and opportunities, build dashboards on them and prepare their reviews.
+ERM wasn't ours to begin with. It started as a Business Owned Tool, built in Slate by another team, and it grew fast because people needed it. When it came to us, our job was to standardise it and enhance it, without breaking anything for the people who rely on it every day.
+So let me start with those people.</a:t>
             </a:r>
             <a:endParaRPr lang="en-US" dirty="0"/>
           </a:p>
@@ -1271,7 +1274,11 @@
           <a:p>
             <a:r>
               <a:rPr lang="en-US" dirty="0"/>
-              <a:t>Set the stakes in one view. ERM is where Airbus risk managers manage ARM risks and opportunities: custom dashboards, live editing, trend following, governed quarterly releases and sharing across divisions. 892 people have used it; more than 320 are active in a peak month; more than 1,600 dashboards exist and more than 10 are updated every day. Monthly users have grown steadily since launch, to around 300 in 2026. It is not one team's tool: the largest organisation, siglum B, has around 345 users, then O, P, A, L, S and K and about a dozen smaller ones; by site, Blagnac and Hamburg lead, with users in the UK, Spain, Canada and India. Chart values are read from the usage dashboard, so treat them as approximate. Whatever we did, we could not break it.</a:t>
+              <a:t>Let me explain what ERM actually does. A risk manager opens the dashboard for their area and sees their risks and opportunities on a heat map. They drill into one, update its status, its mitigations and key messages, and then use the one-pager or the report to take it into their review. Every quarter the dashboards are validated and released, so management sees a governed picture, and they can be shared across divisions.
+So it isn't a side tool. Just a few highlights on screen: close to nine hundred people have used it, around three hundred in a busy month, and there are more than sixteen hundred dashboards. It's used right across the company, by many organisations, mostly in France and Germany, but also in the UK, Spain, Canada and India.
+That's why we couldn't afford to break it. And under the surface, it was fragile.
+— — —
+Reference if asked: 892 lifetime unique users; 320+ active in a peak month; 1,600+ dashboards; 10+ updated every day. Largest organisation B (~345), then O, P, A, L, S, K and about a dozen smaller ones. France 314, Germany 205, UK 58, Spain 25, Canada 12, India 7; top sites Blagnac 271 and Hamburg 205. Chart values are read from the usage dashboard, so they are approximate.</a:t>
             </a:r>
             <a:endParaRPr lang="en-US" dirty="0"/>
           </a:p>
@@ -1359,7 +1366,12 @@
           <a:p>
             <a:r>
               <a:rPr lang="en-US" dirty="0"/>
-              <a:t>Here is the complication. In Slate, one simple action triggers a cascade of widgets, events, actions and variables, so any change risks breaking something unrelated, and every tab switch recalculates large variable trees. And nothing was documented: 8 exports, about 25 MB of configuration. Let the animation play: the app breaks into a shell and 7 modules, and 105 features come out of it. Then ask the question on screen: how do two developers move 105 hidden features in one PI without breaking risk reporting?</a:t>
+              <a:t>Let me show you how it was built. The old app is one Slate shell, the board menu, with seven modules running inside it as separate frames: search, heat map, one-pager, waterfall, action tracker, report table and print. The shell alone holds forty-four functions, ninety-six events and fourteen actions, and it pushes data into every module by passing messages between them.
+For users, that showed up as problems. One click sets off a chain of widgets, events and variables, so a small change in one place could break a dashboard somewhere else. And every tab switch recalculated large variable trees, so it felt slow.
+For a migration it was even harder, because nothing was documented. Eight Slate exports, about twenty-five megabytes of configuration, and no list of what the app really did.
+(Let the animation play.) So the real question was the one on screen: how do two developers move a hundred and five hidden features in one PI, without breaking risk reporting?
+— — —
+Reference if asked: behind the shell sit Foundry Functions for versions, sharing and search, 18 Foundry action types for board, risk, key-message and settings writes, and the ERM ontology. Roles were read from a user-profile object and only enforced in the screen.</a:t>
             </a:r>
             <a:endParaRPr lang="en-US" dirty="0"/>
           </a:p>
@@ -1447,7 +1459,11 @@
           <a:p>
             <a:r>
               <a:rPr lang="en-US" dirty="0"/>
-              <a:t>This is the innovation. A usual migration starts with interviews and clicking through screens, reads code in fragments, finds gaps late in testing and documents afterwards, if at all. We flipped it. The AI read all 8 Slate exports and catalogued 105 features. Our script, pack-project.ts, packs the whole React app into one dated file, so the AI sees every component and OSDK call at once. The AI then checked every feature against the code and found 31 gaps; people reviewed, fixed and deployed. The diagrams were produced alongside the work. AI drafts, people verify. If time allows, show the live app here for 60 seconds.</a:t>
+              <a:t>Done the usual way, this is a long project. You interview users and click through every screen just to find out what the app does. Then you read the configuration piece by piece, rebuild it feature by feature, and only discover the gaps in testing, near the end. Documentation comes last, if at all. Our generic estimate for that approach was around seventeen sprints for two people.
+We turned it around. First, the AI read all eight Slate exports and wrote the feature catalogue for us: a hundred and five features. Second, our own script, pack-project.ts, packs the whole React app into one file, so the AI sees every component and every data call at once, not in fragments. Third, it checked every feature against that code and flagged thirty-one gaps before testing even started. And the diagrams were produced along the way, not afterwards.
+One rule throughout: the AI drafts, we verify, fix and decide. So, did it work?
+— — —
+If time allows, show the live app here for about a minute.</a:t>
             </a:r>
             <a:endParaRPr lang="en-US" dirty="0"/>
           </a:p>
@@ -1535,7 +1551,15 @@
           <a:p>
             <a:r>
               <a:rPr lang="en-US" dirty="0"/>
-              <a:t>The proof, hard facts first. One PI. Two developers. All 105 features carried over and checked. The AI review found and prioritised 31 gaps, including 7 security and data-integrity issues, all caught in review; the dashboard sharing-access fix is deployed. We also built 11 features Slate never had: permissions-only edit for locked versions, a web address per tab, a searchable dashboard switcher, a criticality-differs filter, category and impact-category filters, a fourth one-pager layout with custom slots, resizable columns saved per board, report classification and cover toggle, slideshow mode, one-pager selection shortcuts, and showing risks by ID or title. Documentation went from nothing to 10 documents. Building features is now easy: in Slate a feature meant wiring widgets, events and variables across 8 exports with no documentation; in React it is one typed component and one OSDK call, pack-project.ts gives AI the whole app, and 25 MB of Slate configuration became 0.8 MB of typed code. On cost, the headline is 76%: against a generic estimate of about 340 person-days, roughly 17 sprints for two developers, we used 4 sprints, about 76% less effort; at $38.50 per developer hour that is roughly $105,000 against $25,000, around $80,000 saved. Maintenance: with a rule of thumb of 20% of build effort a year, a Slate-equivalent app needs about $21,000 a year; assuming modular, typed, documented code halves that, we save around $10,000 a year. Say clearly these are estimates. Security and data-integrity findings caught in review: stored cross-site scripting from unsanitised rich HTML in 5 places; permission checks that matched e-mails by substring instead of exactly; sharing payload arrays misaligned with the wrong fields; settings JSON overwritten whole from a stale copy; reports printing shared risks the legacy app left out; no 100-risk print cap, a legacy cybersecurity limit; and children edits in the risk drawer silently discarded.</a:t>
+              <a:t>It did. One PI, two developers. All hundred and five features carried over and checked, thirty-one gaps found and fixed, and seven security issues caught in review. On top of that we built eleven features Slate never had, like a searchable dashboard switcher, a slideshow mode and a web address for every tab. And we went from no documentation at all to ten documents.
+But the number I'd like you to remember is this one: about seventy-six percent less effort than doing it by hand. Four sprints instead of roughly seventeen. In money that's around eighty thousand dollars saved, and roughly ten thousand a year less to maintain. These are estimates, and the basis is in the footnote.
+And it keeps paying back. In Slate, a new feature meant wiring widgets across eight exports. Now it's one typed component and one data call.
+Numbers are only half the story, though. Here's what the users say.
+— — —
+Reference if asked.
+The 11 new features: permissions-only edit for locked versions; a web address per tab; a searchable dashboard switcher; a criticality-differs filter; category and impact-category filters; a fourth one-pager layout with custom slots; resizable columns saved per board; report classification and cover toggle; slideshow mode; one-pager selection shortcuts; showing risks by ID or title.
+Cost basis: a generic manual estimate of ~340 person-days (about 17 sprints for two developers) against 4 sprints used; at $38.50 per developer hour, ~$105K against ~$25K. Maintenance: 20% of build effort a year (~$21K), assumed halved by modular, typed, documented code. 25 MB of Slate configuration became 0.8 MB of typed code.
+Security and data-integrity findings caught in review: stored cross-site scripting from unsanitised rich HTML in 5 places; permission checks that matched e-mails by substring instead of exactly; sharing payload arrays misaligned with the wrong fields; settings JSON overwritten whole from a stale copy; reports printing shared risks the legacy app left out; no 100-risk print cap, a legacy cybersecurity limit; children edits in the risk drawer silently discarded. The dashboard sharing-access fix is deployed.</a:t>
             </a:r>
             <a:endParaRPr lang="en-US" dirty="0"/>
           </a:p>
@@ -1623,7 +1647,11 @@
           <a:p>
             <a:r>
               <a:rPr lang="en-US" dirty="0"/>
-              <a:t>Let the business speak. These are testimonials sent by ERM stakeholders in September 2026 about the team and the ERM tool. A member of the ERM centre of competence: teamwork with the business and strong IT skills turned an idea into a user-friendly industrial solution, ERM reports are now generated in a much more automated way, and the user interface and performance have significantly improved. An ERM stakeholder: the ERM dashboard is a tremendous addition to the ERM toolset, and more and more users prepare and run their risk and opportunity reviews with it. A Risk and Opportunity Manager in Hamburg: new features made navigation easier and gave a much clearer view of R&amp;O data, and issues were fixed quickly. Make clear these speak about the team and the tool overall.</a:t>
+              <a:t>I'd rather the business said this than us. These came from ERM stakeholders in September, and they talk about the team and the tool as a whole.
+The ERM Centre of Competence says that regular teamwork with the business, together with strong IT skills, turned an idea into a user-friendly industrial solution, and that the interface and performance have clearly improved.
+Another stakeholder calls it a tremendous addition to the ERM toolset, and says more and more people now prepare and run their risk reviews with it.
+And a Risk and Opportunity Manager in Hamburg says the new features make navigation easier and give a much clearer view of their data, and that whenever something went wrong, it was fixed quickly.
+That's the part we're proudest of, because it was teamwork from start to finish. Which brings me to how this fits where Airbus is heading.</a:t>
             </a:r>
             <a:endParaRPr lang="en-US" dirty="0"/>
           </a:p>
@@ -1711,7 +1739,15 @@
           <a:p>
             <a:r>
               <a:rPr lang="en-US" dirty="0"/>
-              <a:t>This slide shows strategic fit and teamwork; the flow builds one branch at a time. One: Leverage AI to solve business problems. The AI read all 8 Slate exports and the packed React code, recovered 105 features from an undocumented app and found 31 gaps. Two: Deliver on time, on cost, on quality. Two developers delivered it in one PI, about 76% less effort than a generic manual estimate. Three: Ensure our operational performance. ERM is a business system; every one of its 105 features was tracked for parity, and it is rebuilt on standard, maintainable React and OSDK code, ready to replace the legacy Slate configuration. Four: Grow digital acumen and competencies. pack-project.ts and the playbook mean other teams can repeat this, which builds AI-assisted engineering skills across the organisation. Finally the team strip: business users confirmed the feature catalogue, data and security owners kept the restricted-view access model intact, and backend and frontend fixes delivered together. Name the people and teams here.</a:t>
+              <a:t>We didn't do this for its own sake. It lines up with four of our 2026 objectives, and I'll take them one at a time as they appear.
+First, leverage AI to solve business problems: the AI recovered a hundred and five features from an app nobody had documented.
+Second, deliver on time, on cost, on quality: one PI, two developers, about seventy-six percent less effort.
+Third, operational performance: ERM is a business system, so every feature was tracked for parity, and it's now rebuilt on standard, maintainable code, ready to leave Slate.
+Fourth, digital acumen: pack-project.ts and the playbook let other teams do the same, so the skill spreads beyond the two of us.
+And none of it happened alone. Business users confirmed the feature list, data and security owners made sure restricted views stayed restricted, and backend and frontend fixes went out together.
+So the last question is: what happens next?
+— — —
+Name the people and teams on the team strip if you can.</a:t>
             </a:r>
             <a:endParaRPr lang="en-US" dirty="0"/>
           </a:p>
@@ -1799,7 +1835,11 @@
           <a:p>
             <a:r>
               <a:rPr lang="en-US" dirty="0"/>
-              <a:t>Close on scale and make an ask. The method is five steps: pack, extract, compare, fix, document. The pieces are ready to reuse: pack-project.ts, the comparison template and the diagram formats. It fits other Slate apps and any low-code tool with little documentation. Then the ask: endorse the playbook as a DevX pattern. We have already aligned with [Architect] to propose it at the architecture sync, so functions beyond DMS can use it; name the first team outside DMS if you have one. End on the line on screen and invite questions.</a:t>
+              <a:t>What we'd like to leave behind isn't only a new ERM, it's a method. Five steps: pack the code, extract the features, compare, fix, and document. And the pieces are ready today: the packing script, the feature comparison template and the diagram formats.
+It fits any Slate app, and really any low-code tool where the knowledge lives in configuration and nobody wrote it down. There are plenty of those.
+So here's our ask. We'd like you to endorse this playbook as a DevX pattern. We've already aligned with [Architect] to propose it at the architecture sync, so that functions beyond DMS can use it too. (If you have one, name the first team outside DMS.)
+To sum up: a hundred and five features, one PI, two developers, and a method the next team can pick up straight away.
+Thank you. I'm happy to take your questions.</a:t>
             </a:r>
             <a:endParaRPr lang="en-US" dirty="0"/>
           </a:p>

</xml_diff>

<commit_message>
Rewrite v1 speaker notes as a story and drop go-live from v2 closing line
Co-Authored-By: Claude Opus 5.5 <noreply@anthropic.com>
Claude-Session: https://claude.ai/code/session_01HdxEbeqqWM97gKbcNqpjAq
</commit_message>
<xml_diff>
--- a/erm-migration/docs/ERM-Migration-Jury-Pitch-v2.pptx
+++ b/erm-migration/docs/ERM-Migration-Jury-Pitch-v2.pptx
@@ -114,29 +114,29 @@
   <p:extLst>
     <p:ext uri="{521415D9-36F7-43E2-AB2F-B90AF26B5E84}">
       <p14:sectionLst xmlns:p14="http://schemas.microsoft.com/office/powerpoint/2010/main">
-        <p14:section name="Answer" id="{1462c2d2-a28e-1426-4334-9057c175f087}">
+        <p14:section name="Answer" id="{a634cea8-c2d3-b512-4853-dce48fbaab62}">
           <p14:sldIdLst>
             <p14:sldId id="256"/>
           </p14:sldIdLst>
         </p14:section>
-        <p14:section name="Situation" id="{0bdc2fe9-a12e-e1a5-dd35-4ae85bc175b1}">
+        <p14:section name="Situation" id="{15a91126-7555-deb1-cfd5-66d9a81fb395}">
           <p14:sldIdLst>
             <p14:sldId id="257"/>
           </p14:sldIdLst>
         </p14:section>
-        <p14:section name="Complication" id="{ee7d66fd-c8d9-e1d4-ffbe-40c3c7797043}">
+        <p14:section name="Complication" id="{8a29fd7d-4943-cc58-93cf-d9b9748ab51d}">
           <p14:sldIdLst>
             <p14:sldId id="258"/>
           </p14:sldIdLst>
         </p14:section>
-        <p14:section name="Answer and proof" id="{c59aff3a-e285-f65e-8047-67920dc97003}">
+        <p14:section name="Answer and proof" id="{7e87f509-2674-5d75-d8cb-44e9cda4c32d}">
           <p14:sldIdLst>
             <p14:sldId id="259"/>
             <p14:sldId id="260"/>
             <p14:sldId id="261"/>
           </p14:sldIdLst>
         </p14:section>
-        <p14:section name="Fit and scale" id="{712f7c34-fa96-d320-ec5b-87ebdda4b3a9}">
+        <p14:section name="Fit and scale" id="{33907e3b-9d93-9ae1-bfcf-0532d3dbaee1}">
           <p14:sldIdLst>
             <p14:sldId id="262"/>
             <p14:sldId id="263"/>
@@ -13546,7 +13546,7 @@
                   <a:schemeClr val="bg1"/>
                 </a:solidFill>
               </a:rPr>
-              <a:t>105 features, one PI, two developers. Ready for go-live, and for the next app.</a:t>
+              <a:t>105 features, one PI, two developers. Ready to leave Slate, and for the next app.</a:t>
             </a:r>
             <a:endParaRPr lang="en-US" sz="2200" dirty="0"/>
           </a:p>

</xml_diff>

<commit_message>
Decks: speaker notes play the trailer where the live-app demo was
v2 slide 4 and v1 slide 6 end with a handover line and a stage direction to
play the 1:34 trailer (full screen, sound on, sample data, ends on Coming
soon); the next slide's notes pick up from it before the numbers.

Co-Authored-By: Claude Opus 5.5 <noreply@anthropic.com>
Claude-Session: https://claude.ai/code/session_01HdxEbeqqWM97gKbcNqpjAq
</commit_message>
<xml_diff>
--- a/erm-migration/docs/ERM-Migration-Jury-Pitch-v2.pptx
+++ b/erm-migration/docs/ERM-Migration-Jury-Pitch-v2.pptx
@@ -1461,9 +1461,10 @@
               <a:rPr lang="en-US" dirty="0"/>
               <a:t>Done the usual way, this is a long project. You interview users and click through every screen just to find out what the app does. Then you read the configuration piece by piece, rebuild it feature by feature, and only discover the gaps in testing, near the end. Documentation comes last, if at all. Our generic estimate for that approach was around seventeen sprints for two people.
 We turned it around. First, the AI read all eight Slate exports and wrote the feature catalogue for us: a hundred and five features. Second, our own script, pack-project.ts, packs the whole React app into one file, so the AI sees every component and every data call at once, not in fragments. Third, it checked every feature against that code and flagged thirty-one gaps before testing even started. And the diagrams were produced along the way, not afterwards.
-One rule throughout: the AI drafts, we verify, fix and decide. So, did it work?
+One rule throughout: the AI drafts, we verify, fix and decide. So, did it work? Rather than tell you, let me show you.
 — — —
-If time allows, show the live app here for about a minute.</a:t>
+Play the trailer here: 1 min 34 s, full screen, sound on. Let it run without talking over it. It shows sample data only and ends on "Coming soon", which matches where we are: the app isn't live yet.
+Before you start: have the video open and cued (docs/trailer-storyboard/animatic.mp4 for now; swap in the final Blender render when it's ready), or embed it on this slide. Add about 1 min 40 s to your timing.</a:t>
             </a:r>
             <a:endParaRPr lang="en-US" dirty="0"/>
           </a:p>
@@ -1551,7 +1552,7 @@
           <a:p>
             <a:r>
               <a:rPr lang="en-US" dirty="0"/>
-              <a:t>It did. One PI, two developers. All hundred and five features carried over and checked, thirty-one gaps found and fixed, and seven security issues caught in review. On top of that we built eleven features Slate never had, like a searchable dashboard switcher, a slideshow mode and a web address for every tab. And we went from no documentation at all to ten documents.
+              <a:t>That was ERM 2.0: everything people rely on, carried over, every tab rebuilt, and faster. So yes, it did. One PI, two developers. All hundred and five features carried over and checked, thirty-one gaps found and fixed, and seven security issues caught in review. On top of that we built eleven features Slate never had, like a searchable dashboard switcher, a slideshow mode and a web address for every tab. And we went from no documentation at all to ten documents.
 But the number I'd like you to remember is this one: about seventy-six percent less effort than doing it by hand. Four sprints instead of roughly seventeen. In money that's around eighty thousand dollars saved, and roughly ten thousand a year less to maintain. These are estimates, and the basis is in the footnote.
 And it keeps paying back. In Slate, a new feature meant wiring widgets across eight exports. Now it's one typed component and one data call.
 Numbers are only half the story, though. Here's what the users say.

</xml_diff>